<commit_message>
Adicionado todo conteudo de Atividade, atualização do README com as informações da atividade e pequenas correções
</commit_message>
<xml_diff>
--- a/Apresentacao.pptx
+++ b/Apresentacao.pptx
@@ -26,25 +26,31 @@
     <p:sldId id="274" r:id="rId24"/>
     <p:sldId id="275" r:id="rId25"/>
     <p:sldId id="276" r:id="rId26"/>
+    <p:sldId id="277" r:id="rId27"/>
+    <p:sldId id="278" r:id="rId28"/>
+    <p:sldId id="279" r:id="rId29"/>
+    <p:sldId id="280" r:id="rId30"/>
+    <p:sldId id="281" r:id="rId31"/>
+    <p:sldId id="282" r:id="rId32"/>
   </p:sldIdLst>
   <p:sldSz cx="18288000" cy="10287000"/>
   <p:notesSz cx="6858000" cy="9144000"/>
   <p:embeddedFontLst>
     <p:embeddedFont>
       <p:font typeface="Anton" charset="1" panose="00000500000000000000"/>
-      <p:regular r:id="rId27"/>
+      <p:regular r:id="rId33"/>
     </p:embeddedFont>
     <p:embeddedFont>
       <p:font typeface="Montserrat Bold" charset="1" panose="00000800000000000000"/>
-      <p:regular r:id="rId28"/>
+      <p:regular r:id="rId34"/>
     </p:embeddedFont>
     <p:embeddedFont>
       <p:font typeface="Montserrat" charset="1" panose="00000500000000000000"/>
-      <p:regular r:id="rId29"/>
+      <p:regular r:id="rId35"/>
     </p:embeddedFont>
     <p:embeddedFont>
       <p:font typeface="Montserrat Medium" charset="1" panose="00000600000000000000"/>
-      <p:regular r:id="rId30"/>
+      <p:regular r:id="rId36"/>
     </p:embeddedFont>
   </p:embeddedFontLst>
   <p:defaultTextStyle>
@@ -16360,6 +16366,474 @@
 </file>
 
 <file path=ppt/slides/slide21.xml><?xml version="1.0" encoding="utf-8"?>
+<p:sld xmlns:p="http://schemas.openxmlformats.org/presentationml/2006/main" xmlns:a="http://schemas.openxmlformats.org/drawingml/2006/main" xmlns:r="http://schemas.openxmlformats.org/officeDocument/2006/relationships">
+  <p:cSld>
+    <p:bg>
+      <p:bgPr>
+        <a:solidFill>
+          <a:srgbClr val="233D89"/>
+        </a:solidFill>
+      </p:bgPr>
+    </p:bg>
+    <p:spTree>
+      <p:nvGrpSpPr>
+        <p:cNvPr id="1" name=""/>
+        <p:cNvGrpSpPr/>
+        <p:nvPr/>
+      </p:nvGrpSpPr>
+      <p:grpSpPr>
+        <a:xfrm>
+          <a:off x="0" y="0"/>
+          <a:ext cx="0" cy="0"/>
+          <a:chOff x="0" y="0"/>
+          <a:chExt cx="0" cy="0"/>
+        </a:xfrm>
+      </p:grpSpPr>
+      <p:sp>
+        <p:nvSpPr>
+          <p:cNvPr name="Freeform 2" id="2"/>
+          <p:cNvSpPr/>
+          <p:nvPr/>
+        </p:nvSpPr>
+        <p:spPr>
+          <a:xfrm flipH="false" flipV="false" rot="0">
+            <a:off x="1243250" y="302848"/>
+            <a:ext cx="8148397" cy="9287962"/>
+          </a:xfrm>
+          <a:custGeom>
+            <a:avLst/>
+            <a:gdLst/>
+            <a:ahLst/>
+            <a:cxnLst/>
+            <a:rect r="r" b="b" t="t" l="l"/>
+            <a:pathLst>
+              <a:path h="9287962" w="8148397">
+                <a:moveTo>
+                  <a:pt x="0" y="0"/>
+                </a:moveTo>
+                <a:lnTo>
+                  <a:pt x="8148397" y="0"/>
+                </a:lnTo>
+                <a:lnTo>
+                  <a:pt x="8148397" y="9287962"/>
+                </a:lnTo>
+                <a:lnTo>
+                  <a:pt x="0" y="9287962"/>
+                </a:lnTo>
+                <a:lnTo>
+                  <a:pt x="0" y="0"/>
+                </a:lnTo>
+                <a:close/>
+              </a:path>
+            </a:pathLst>
+          </a:custGeom>
+          <a:blipFill>
+            <a:blip r:embed="rId2"/>
+            <a:stretch>
+              <a:fillRect l="0" t="0" r="0" b="0"/>
+            </a:stretch>
+          </a:blipFill>
+        </p:spPr>
+      </p:sp>
+    </p:spTree>
+  </p:cSld>
+  <p:clrMapOvr>
+    <a:masterClrMapping/>
+  </p:clrMapOvr>
+</p:sld>
+</file>
+
+<file path=ppt/slides/slide22.xml><?xml version="1.0" encoding="utf-8"?>
+<p:sld xmlns:p="http://schemas.openxmlformats.org/presentationml/2006/main" xmlns:a="http://schemas.openxmlformats.org/drawingml/2006/main" xmlns:r="http://schemas.openxmlformats.org/officeDocument/2006/relationships">
+  <p:cSld>
+    <p:bg>
+      <p:bgPr>
+        <a:solidFill>
+          <a:srgbClr val="233D89"/>
+        </a:solidFill>
+      </p:bgPr>
+    </p:bg>
+    <p:spTree>
+      <p:nvGrpSpPr>
+        <p:cNvPr id="1" name=""/>
+        <p:cNvGrpSpPr/>
+        <p:nvPr/>
+      </p:nvGrpSpPr>
+      <p:grpSpPr>
+        <a:xfrm>
+          <a:off x="0" y="0"/>
+          <a:ext cx="0" cy="0"/>
+          <a:chOff x="0" y="0"/>
+          <a:chExt cx="0" cy="0"/>
+        </a:xfrm>
+      </p:grpSpPr>
+      <p:sp>
+        <p:nvSpPr>
+          <p:cNvPr name="Freeform 2" id="2"/>
+          <p:cNvSpPr/>
+          <p:nvPr/>
+        </p:nvSpPr>
+        <p:spPr>
+          <a:xfrm flipH="false" flipV="false" rot="0">
+            <a:off x="1450288" y="461402"/>
+            <a:ext cx="9485850" cy="9017664"/>
+          </a:xfrm>
+          <a:custGeom>
+            <a:avLst/>
+            <a:gdLst/>
+            <a:ahLst/>
+            <a:cxnLst/>
+            <a:rect r="r" b="b" t="t" l="l"/>
+            <a:pathLst>
+              <a:path h="9017664" w="9485850">
+                <a:moveTo>
+                  <a:pt x="0" y="0"/>
+                </a:moveTo>
+                <a:lnTo>
+                  <a:pt x="9485850" y="0"/>
+                </a:lnTo>
+                <a:lnTo>
+                  <a:pt x="9485850" y="9017664"/>
+                </a:lnTo>
+                <a:lnTo>
+                  <a:pt x="0" y="9017664"/>
+                </a:lnTo>
+                <a:lnTo>
+                  <a:pt x="0" y="0"/>
+                </a:lnTo>
+                <a:close/>
+              </a:path>
+            </a:pathLst>
+          </a:custGeom>
+          <a:blipFill>
+            <a:blip r:embed="rId2"/>
+            <a:stretch>
+              <a:fillRect l="0" t="0" r="0" b="0"/>
+            </a:stretch>
+          </a:blipFill>
+        </p:spPr>
+      </p:sp>
+    </p:spTree>
+  </p:cSld>
+  <p:clrMapOvr>
+    <a:masterClrMapping/>
+  </p:clrMapOvr>
+</p:sld>
+</file>
+
+<file path=ppt/slides/slide23.xml><?xml version="1.0" encoding="utf-8"?>
+<p:sld xmlns:p="http://schemas.openxmlformats.org/presentationml/2006/main" xmlns:a="http://schemas.openxmlformats.org/drawingml/2006/main" xmlns:r="http://schemas.openxmlformats.org/officeDocument/2006/relationships">
+  <p:cSld>
+    <p:bg>
+      <p:bgPr>
+        <a:solidFill>
+          <a:srgbClr val="283D87"/>
+        </a:solidFill>
+      </p:bgPr>
+    </p:bg>
+    <p:spTree>
+      <p:nvGrpSpPr>
+        <p:cNvPr id="1" name=""/>
+        <p:cNvGrpSpPr/>
+        <p:nvPr/>
+      </p:nvGrpSpPr>
+      <p:grpSpPr>
+        <a:xfrm>
+          <a:off x="0" y="0"/>
+          <a:ext cx="0" cy="0"/>
+          <a:chOff x="0" y="0"/>
+          <a:chExt cx="0" cy="0"/>
+        </a:xfrm>
+      </p:grpSpPr>
+      <p:sp>
+        <p:nvSpPr>
+          <p:cNvPr name="Freeform 2" id="2"/>
+          <p:cNvSpPr/>
+          <p:nvPr/>
+        </p:nvSpPr>
+        <p:spPr>
+          <a:xfrm flipH="false" flipV="false" rot="0">
+            <a:off x="150912" y="2890385"/>
+            <a:ext cx="17986175" cy="4202955"/>
+          </a:xfrm>
+          <a:custGeom>
+            <a:avLst/>
+            <a:gdLst/>
+            <a:ahLst/>
+            <a:cxnLst/>
+            <a:rect r="r" b="b" t="t" l="l"/>
+            <a:pathLst>
+              <a:path h="4202955" w="17986175">
+                <a:moveTo>
+                  <a:pt x="0" y="0"/>
+                </a:moveTo>
+                <a:lnTo>
+                  <a:pt x="17986176" y="0"/>
+                </a:lnTo>
+                <a:lnTo>
+                  <a:pt x="17986176" y="4202956"/>
+                </a:lnTo>
+                <a:lnTo>
+                  <a:pt x="0" y="4202956"/>
+                </a:lnTo>
+                <a:lnTo>
+                  <a:pt x="0" y="0"/>
+                </a:lnTo>
+                <a:close/>
+              </a:path>
+            </a:pathLst>
+          </a:custGeom>
+          <a:blipFill>
+            <a:blip r:embed="rId2"/>
+            <a:stretch>
+              <a:fillRect l="0" t="0" r="0" b="0"/>
+            </a:stretch>
+          </a:blipFill>
+        </p:spPr>
+      </p:sp>
+    </p:spTree>
+  </p:cSld>
+  <p:clrMapOvr>
+    <a:masterClrMapping/>
+  </p:clrMapOvr>
+</p:sld>
+</file>
+
+<file path=ppt/slides/slide24.xml><?xml version="1.0" encoding="utf-8"?>
+<p:sld xmlns:p="http://schemas.openxmlformats.org/presentationml/2006/main" xmlns:a="http://schemas.openxmlformats.org/drawingml/2006/main" xmlns:r="http://schemas.openxmlformats.org/officeDocument/2006/relationships">
+  <p:cSld>
+    <p:bg>
+      <p:bgPr>
+        <a:solidFill>
+          <a:srgbClr val="283D87"/>
+        </a:solidFill>
+      </p:bgPr>
+    </p:bg>
+    <p:spTree>
+      <p:nvGrpSpPr>
+        <p:cNvPr id="1" name=""/>
+        <p:cNvGrpSpPr/>
+        <p:nvPr/>
+      </p:nvGrpSpPr>
+      <p:grpSpPr>
+        <a:xfrm>
+          <a:off x="0" y="0"/>
+          <a:ext cx="0" cy="0"/>
+          <a:chOff x="0" y="0"/>
+          <a:chExt cx="0" cy="0"/>
+        </a:xfrm>
+      </p:grpSpPr>
+      <p:sp>
+        <p:nvSpPr>
+          <p:cNvPr name="Freeform 2" id="2"/>
+          <p:cNvSpPr/>
+          <p:nvPr/>
+        </p:nvSpPr>
+        <p:spPr>
+          <a:xfrm flipH="false" flipV="false" rot="0">
+            <a:off x="241034" y="1970578"/>
+            <a:ext cx="17805932" cy="4874374"/>
+          </a:xfrm>
+          <a:custGeom>
+            <a:avLst/>
+            <a:gdLst/>
+            <a:ahLst/>
+            <a:cxnLst/>
+            <a:rect r="r" b="b" t="t" l="l"/>
+            <a:pathLst>
+              <a:path h="4874374" w="17805932">
+                <a:moveTo>
+                  <a:pt x="0" y="0"/>
+                </a:moveTo>
+                <a:lnTo>
+                  <a:pt x="17805932" y="0"/>
+                </a:lnTo>
+                <a:lnTo>
+                  <a:pt x="17805932" y="4874374"/>
+                </a:lnTo>
+                <a:lnTo>
+                  <a:pt x="0" y="4874374"/>
+                </a:lnTo>
+                <a:lnTo>
+                  <a:pt x="0" y="0"/>
+                </a:lnTo>
+                <a:close/>
+              </a:path>
+            </a:pathLst>
+          </a:custGeom>
+          <a:blipFill>
+            <a:blip r:embed="rId2"/>
+            <a:stretch>
+              <a:fillRect l="0" t="0" r="0" b="0"/>
+            </a:stretch>
+          </a:blipFill>
+        </p:spPr>
+      </p:sp>
+    </p:spTree>
+  </p:cSld>
+  <p:clrMapOvr>
+    <a:masterClrMapping/>
+  </p:clrMapOvr>
+</p:sld>
+</file>
+
+<file path=ppt/slides/slide25.xml><?xml version="1.0" encoding="utf-8"?>
+<p:sld xmlns:p="http://schemas.openxmlformats.org/presentationml/2006/main" xmlns:a="http://schemas.openxmlformats.org/drawingml/2006/main" xmlns:r="http://schemas.openxmlformats.org/officeDocument/2006/relationships">
+  <p:cSld>
+    <p:bg>
+      <p:bgPr>
+        <a:solidFill>
+          <a:srgbClr val="233D89"/>
+        </a:solidFill>
+      </p:bgPr>
+    </p:bg>
+    <p:spTree>
+      <p:nvGrpSpPr>
+        <p:cNvPr id="1" name=""/>
+        <p:cNvGrpSpPr/>
+        <p:nvPr/>
+      </p:nvGrpSpPr>
+      <p:grpSpPr>
+        <a:xfrm>
+          <a:off x="0" y="0"/>
+          <a:ext cx="0" cy="0"/>
+          <a:chOff x="0" y="0"/>
+          <a:chExt cx="0" cy="0"/>
+        </a:xfrm>
+      </p:grpSpPr>
+      <p:sp>
+        <p:nvSpPr>
+          <p:cNvPr name="Freeform 2" id="2"/>
+          <p:cNvSpPr/>
+          <p:nvPr/>
+        </p:nvSpPr>
+        <p:spPr>
+          <a:xfrm flipH="false" flipV="false" rot="0">
+            <a:off x="4528962" y="624966"/>
+            <a:ext cx="9832027" cy="9382626"/>
+          </a:xfrm>
+          <a:custGeom>
+            <a:avLst/>
+            <a:gdLst/>
+            <a:ahLst/>
+            <a:cxnLst/>
+            <a:rect r="r" b="b" t="t" l="l"/>
+            <a:pathLst>
+              <a:path h="9382626" w="9832027">
+                <a:moveTo>
+                  <a:pt x="0" y="0"/>
+                </a:moveTo>
+                <a:lnTo>
+                  <a:pt x="9832028" y="0"/>
+                </a:lnTo>
+                <a:lnTo>
+                  <a:pt x="9832028" y="9382626"/>
+                </a:lnTo>
+                <a:lnTo>
+                  <a:pt x="0" y="9382626"/>
+                </a:lnTo>
+                <a:lnTo>
+                  <a:pt x="0" y="0"/>
+                </a:lnTo>
+                <a:close/>
+              </a:path>
+            </a:pathLst>
+          </a:custGeom>
+          <a:blipFill>
+            <a:blip r:embed="rId2"/>
+            <a:stretch>
+              <a:fillRect l="0" t="0" r="0" b="0"/>
+            </a:stretch>
+          </a:blipFill>
+        </p:spPr>
+      </p:sp>
+    </p:spTree>
+  </p:cSld>
+  <p:clrMapOvr>
+    <a:masterClrMapping/>
+  </p:clrMapOvr>
+</p:sld>
+</file>
+
+<file path=ppt/slides/slide26.xml><?xml version="1.0" encoding="utf-8"?>
+<p:sld xmlns:p="http://schemas.openxmlformats.org/presentationml/2006/main" xmlns:a="http://schemas.openxmlformats.org/drawingml/2006/main" xmlns:r="http://schemas.openxmlformats.org/officeDocument/2006/relationships">
+  <p:cSld>
+    <p:bg>
+      <p:bgPr>
+        <a:solidFill>
+          <a:srgbClr val="233D89"/>
+        </a:solidFill>
+      </p:bgPr>
+    </p:bg>
+    <p:spTree>
+      <p:nvGrpSpPr>
+        <p:cNvPr id="1" name=""/>
+        <p:cNvGrpSpPr/>
+        <p:nvPr/>
+      </p:nvGrpSpPr>
+      <p:grpSpPr>
+        <a:xfrm>
+          <a:off x="0" y="0"/>
+          <a:ext cx="0" cy="0"/>
+          <a:chOff x="0" y="0"/>
+          <a:chExt cx="0" cy="0"/>
+        </a:xfrm>
+      </p:grpSpPr>
+      <p:sp>
+        <p:nvSpPr>
+          <p:cNvPr name="Freeform 2" id="2"/>
+          <p:cNvSpPr/>
+          <p:nvPr/>
+        </p:nvSpPr>
+        <p:spPr>
+          <a:xfrm flipH="false" flipV="false" rot="0">
+            <a:off x="4644143" y="509748"/>
+            <a:ext cx="9623518" cy="9267504"/>
+          </a:xfrm>
+          <a:custGeom>
+            <a:avLst/>
+            <a:gdLst/>
+            <a:ahLst/>
+            <a:cxnLst/>
+            <a:rect r="r" b="b" t="t" l="l"/>
+            <a:pathLst>
+              <a:path h="9267504" w="9623518">
+                <a:moveTo>
+                  <a:pt x="0" y="0"/>
+                </a:moveTo>
+                <a:lnTo>
+                  <a:pt x="9623518" y="0"/>
+                </a:lnTo>
+                <a:lnTo>
+                  <a:pt x="9623518" y="9267504"/>
+                </a:lnTo>
+                <a:lnTo>
+                  <a:pt x="0" y="9267504"/>
+                </a:lnTo>
+                <a:lnTo>
+                  <a:pt x="0" y="0"/>
+                </a:lnTo>
+                <a:close/>
+              </a:path>
+            </a:pathLst>
+          </a:custGeom>
+          <a:blipFill>
+            <a:blip r:embed="rId2"/>
+            <a:stretch>
+              <a:fillRect l="0" t="0" r="0" b="0"/>
+            </a:stretch>
+          </a:blipFill>
+        </p:spPr>
+      </p:sp>
+    </p:spTree>
+  </p:cSld>
+  <p:clrMapOvr>
+    <a:masterClrMapping/>
+  </p:clrMapOvr>
+</p:sld>
+</file>
+
+<file path=ppt/slides/slide27.xml><?xml version="1.0" encoding="utf-8"?>
 <p:sld xmlns:p="http://schemas.openxmlformats.org/presentationml/2006/main" xmlns:a="http://schemas.openxmlformats.org/drawingml/2006/main">
   <p:cSld>
     <p:bg>

</xml_diff>

<commit_message>
Adição da lista de palavras da atividade
</commit_message>
<xml_diff>
--- a/Apresentacao.pptx
+++ b/Apresentacao.pptx
@@ -30,25 +30,39 @@
     <p:sldId id="278" r:id="rId28"/>
     <p:sldId id="279" r:id="rId29"/>
     <p:sldId id="280" r:id="rId30"/>
+    <p:sldId id="281" r:id="rId31"/>
+    <p:sldId id="282" r:id="rId32"/>
+    <p:sldId id="283" r:id="rId33"/>
+    <p:sldId id="284" r:id="rId34"/>
+    <p:sldId id="285" r:id="rId35"/>
+    <p:sldId id="286" r:id="rId36"/>
+    <p:sldId id="287" r:id="rId37"/>
+    <p:sldId id="288" r:id="rId38"/>
+    <p:sldId id="289" r:id="rId39"/>
+    <p:sldId id="290" r:id="rId40"/>
+    <p:sldId id="291" r:id="rId41"/>
+    <p:sldId id="292" r:id="rId42"/>
+    <p:sldId id="293" r:id="rId43"/>
+    <p:sldId id="294" r:id="rId44"/>
   </p:sldIdLst>
   <p:sldSz cx="18288000" cy="10287000"/>
   <p:notesSz cx="6858000" cy="9144000"/>
   <p:embeddedFontLst>
     <p:embeddedFont>
       <p:font typeface="Anton" charset="1" panose="00000500000000000000"/>
-      <p:regular r:id="rId31"/>
+      <p:regular r:id="rId45"/>
     </p:embeddedFont>
     <p:embeddedFont>
       <p:font typeface="Montserrat Bold" charset="1" panose="00000800000000000000"/>
-      <p:regular r:id="rId32"/>
+      <p:regular r:id="rId46"/>
     </p:embeddedFont>
     <p:embeddedFont>
       <p:font typeface="Montserrat" charset="1" panose="00000500000000000000"/>
-      <p:regular r:id="rId33"/>
+      <p:regular r:id="rId47"/>
     </p:embeddedFont>
     <p:embeddedFont>
       <p:font typeface="Montserrat Medium" charset="1" panose="00000600000000000000"/>
-      <p:regular r:id="rId34"/>
+      <p:regular r:id="rId48"/>
     </p:embeddedFont>
   </p:embeddedFontLst>
   <p:defaultTextStyle>
@@ -13698,8 +13712,8 @@
         </p:nvSpPr>
         <p:spPr>
           <a:xfrm flipH="false" flipV="false" rot="0">
-            <a:off x="1243250" y="302848"/>
-            <a:ext cx="8148397" cy="9287962"/>
+            <a:off x="266228" y="2227353"/>
+            <a:ext cx="17755545" cy="5149108"/>
           </a:xfrm>
           <a:custGeom>
             <a:avLst/>
@@ -13708,18 +13722,18 @@
             <a:cxnLst/>
             <a:rect r="r" b="b" t="t" l="l"/>
             <a:pathLst>
-              <a:path h="9287962" w="8148397">
+              <a:path h="5149108" w="17755545">
                 <a:moveTo>
                   <a:pt x="0" y="0"/>
                 </a:moveTo>
                 <a:lnTo>
-                  <a:pt x="8148397" y="0"/>
+                  <a:pt x="17755544" y="0"/>
                 </a:lnTo>
                 <a:lnTo>
-                  <a:pt x="8148397" y="9287962"/>
+                  <a:pt x="17755544" y="5149108"/>
                 </a:lnTo>
                 <a:lnTo>
-                  <a:pt x="0" y="9287962"/>
+                  <a:pt x="0" y="5149108"/>
                 </a:lnTo>
                 <a:lnTo>
                   <a:pt x="0" y="0"/>
@@ -13736,6 +13750,236 @@
           </a:blipFill>
         </p:spPr>
       </p:sp>
+      <p:grpSp>
+        <p:nvGrpSpPr>
+          <p:cNvPr name="Group 3" id="3"/>
+          <p:cNvGrpSpPr/>
+          <p:nvPr/>
+        </p:nvGrpSpPr>
+        <p:grpSpPr>
+          <a:xfrm rot="0">
+            <a:off x="621952" y="3823778"/>
+            <a:ext cx="16960349" cy="3086100"/>
+            <a:chOff x="0" y="0"/>
+            <a:chExt cx="4466923" cy="812800"/>
+          </a:xfrm>
+        </p:grpSpPr>
+        <p:sp>
+          <p:nvSpPr>
+            <p:cNvPr name="Freeform 4" id="4"/>
+            <p:cNvSpPr/>
+            <p:nvPr/>
+          </p:nvSpPr>
+          <p:spPr>
+            <a:xfrm flipH="false" flipV="false" rot="0">
+              <a:off x="0" y="0"/>
+              <a:ext cx="4466923" cy="812800"/>
+            </a:xfrm>
+            <a:custGeom>
+              <a:avLst/>
+              <a:gdLst/>
+              <a:ahLst/>
+              <a:cxnLst/>
+              <a:rect r="r" b="b" t="t" l="l"/>
+              <a:pathLst>
+                <a:path h="812800" w="4466923">
+                  <a:moveTo>
+                    <a:pt x="7760" y="0"/>
+                  </a:moveTo>
+                  <a:lnTo>
+                    <a:pt x="4459163" y="0"/>
+                  </a:lnTo>
+                  <a:cubicBezTo>
+                    <a:pt x="4461221" y="0"/>
+                    <a:pt x="4463195" y="818"/>
+                    <a:pt x="4464650" y="2273"/>
+                  </a:cubicBezTo>
+                  <a:cubicBezTo>
+                    <a:pt x="4466106" y="3728"/>
+                    <a:pt x="4466923" y="5702"/>
+                    <a:pt x="4466923" y="7760"/>
+                  </a:cubicBezTo>
+                  <a:lnTo>
+                    <a:pt x="4466923" y="805040"/>
+                  </a:lnTo>
+                  <a:cubicBezTo>
+                    <a:pt x="4466923" y="807098"/>
+                    <a:pt x="4466106" y="809072"/>
+                    <a:pt x="4464650" y="810527"/>
+                  </a:cubicBezTo>
+                  <a:cubicBezTo>
+                    <a:pt x="4463195" y="811982"/>
+                    <a:pt x="4461221" y="812800"/>
+                    <a:pt x="4459163" y="812800"/>
+                  </a:cubicBezTo>
+                  <a:lnTo>
+                    <a:pt x="7760" y="812800"/>
+                  </a:lnTo>
+                  <a:cubicBezTo>
+                    <a:pt x="5702" y="812800"/>
+                    <a:pt x="3728" y="811982"/>
+                    <a:pt x="2273" y="810527"/>
+                  </a:cubicBezTo>
+                  <a:cubicBezTo>
+                    <a:pt x="818" y="809072"/>
+                    <a:pt x="0" y="807098"/>
+                    <a:pt x="0" y="805040"/>
+                  </a:cubicBezTo>
+                  <a:lnTo>
+                    <a:pt x="0" y="7760"/>
+                  </a:lnTo>
+                  <a:cubicBezTo>
+                    <a:pt x="0" y="5702"/>
+                    <a:pt x="818" y="3728"/>
+                    <a:pt x="2273" y="2273"/>
+                  </a:cubicBezTo>
+                  <a:cubicBezTo>
+                    <a:pt x="3728" y="818"/>
+                    <a:pt x="5702" y="0"/>
+                    <a:pt x="7760" y="0"/>
+                  </a:cubicBezTo>
+                  <a:close/>
+                </a:path>
+              </a:pathLst>
+            </a:custGeom>
+            <a:solidFill>
+              <a:srgbClr val="233D89"/>
+            </a:solidFill>
+          </p:spPr>
+        </p:sp>
+        <p:sp>
+          <p:nvSpPr>
+            <p:cNvPr name="TextBox 5" id="5"/>
+            <p:cNvSpPr txBox="true"/>
+            <p:nvPr/>
+          </p:nvSpPr>
+          <p:spPr>
+            <a:xfrm>
+              <a:off x="0" y="-38100"/>
+              <a:ext cx="4466923" cy="850900"/>
+            </a:xfrm>
+            <a:prstGeom prst="rect">
+              <a:avLst/>
+            </a:prstGeom>
+          </p:spPr>
+          <p:txBody>
+            <a:bodyPr anchor="ctr" rtlCol="false" tIns="50800" lIns="50800" bIns="50800" rIns="50800"/>
+            <a:lstStyle/>
+            <a:p>
+              <a:pPr algn="ctr">
+                <a:lnSpc>
+                  <a:spcPts val="3449"/>
+                </a:lnSpc>
+              </a:pPr>
+            </a:p>
+          </p:txBody>
+        </p:sp>
+      </p:grpSp>
+      <p:grpSp>
+        <p:nvGrpSpPr>
+          <p:cNvPr name="Group 6" id="6"/>
+          <p:cNvGrpSpPr/>
+          <p:nvPr/>
+        </p:nvGrpSpPr>
+        <p:grpSpPr>
+          <a:xfrm rot="0">
+            <a:off x="7027534" y="2929328"/>
+            <a:ext cx="10776956" cy="3086100"/>
+            <a:chOff x="0" y="0"/>
+            <a:chExt cx="2838375" cy="812800"/>
+          </a:xfrm>
+        </p:grpSpPr>
+        <p:sp>
+          <p:nvSpPr>
+            <p:cNvPr name="Freeform 7" id="7"/>
+            <p:cNvSpPr/>
+            <p:nvPr/>
+          </p:nvSpPr>
+          <p:spPr>
+            <a:xfrm flipH="false" flipV="false" rot="0">
+              <a:off x="0" y="0"/>
+              <a:ext cx="2838375" cy="812800"/>
+            </a:xfrm>
+            <a:custGeom>
+              <a:avLst/>
+              <a:gdLst/>
+              <a:ahLst/>
+              <a:cxnLst/>
+              <a:rect r="r" b="b" t="t" l="l"/>
+              <a:pathLst>
+                <a:path h="812800" w="2838375">
+                  <a:moveTo>
+                    <a:pt x="12212" y="0"/>
+                  </a:moveTo>
+                  <a:lnTo>
+                    <a:pt x="2826163" y="0"/>
+                  </a:lnTo>
+                  <a:cubicBezTo>
+                    <a:pt x="2832908" y="0"/>
+                    <a:pt x="2838375" y="5468"/>
+                    <a:pt x="2838375" y="12212"/>
+                  </a:cubicBezTo>
+                  <a:lnTo>
+                    <a:pt x="2838375" y="800588"/>
+                  </a:lnTo>
+                  <a:cubicBezTo>
+                    <a:pt x="2838375" y="807332"/>
+                    <a:pt x="2832908" y="812800"/>
+                    <a:pt x="2826163" y="812800"/>
+                  </a:cubicBezTo>
+                  <a:lnTo>
+                    <a:pt x="12212" y="812800"/>
+                  </a:lnTo>
+                  <a:cubicBezTo>
+                    <a:pt x="5468" y="812800"/>
+                    <a:pt x="0" y="807332"/>
+                    <a:pt x="0" y="800588"/>
+                  </a:cubicBezTo>
+                  <a:lnTo>
+                    <a:pt x="0" y="12212"/>
+                  </a:lnTo>
+                  <a:cubicBezTo>
+                    <a:pt x="0" y="5468"/>
+                    <a:pt x="5468" y="0"/>
+                    <a:pt x="12212" y="0"/>
+                  </a:cubicBezTo>
+                  <a:close/>
+                </a:path>
+              </a:pathLst>
+            </a:custGeom>
+            <a:solidFill>
+              <a:srgbClr val="233D89"/>
+            </a:solidFill>
+          </p:spPr>
+        </p:sp>
+        <p:sp>
+          <p:nvSpPr>
+            <p:cNvPr name="TextBox 8" id="8"/>
+            <p:cNvSpPr txBox="true"/>
+            <p:nvPr/>
+          </p:nvSpPr>
+          <p:spPr>
+            <a:xfrm>
+              <a:off x="0" y="-38100"/>
+              <a:ext cx="2838375" cy="850900"/>
+            </a:xfrm>
+            <a:prstGeom prst="rect">
+              <a:avLst/>
+            </a:prstGeom>
+          </p:spPr>
+          <p:txBody>
+            <a:bodyPr anchor="ctr" rtlCol="false" tIns="50800" lIns="50800" bIns="50800" rIns="50800"/>
+            <a:lstStyle/>
+            <a:p>
+              <a:pPr algn="ctr">
+                <a:lnSpc>
+                  <a:spcPts val="3449"/>
+                </a:lnSpc>
+              </a:pPr>
+            </a:p>
+          </p:txBody>
+        </p:sp>
+      </p:grpSp>
     </p:spTree>
   </p:cSld>
   <p:clrMapOvr>
@@ -14330,8 +14574,8 @@
         </p:nvSpPr>
         <p:spPr>
           <a:xfrm flipH="false" flipV="false" rot="0">
-            <a:off x="1450288" y="461402"/>
-            <a:ext cx="9485850" cy="9017664"/>
+            <a:off x="266228" y="2227353"/>
+            <a:ext cx="17755545" cy="5149108"/>
           </a:xfrm>
           <a:custGeom>
             <a:avLst/>
@@ -14340,18 +14584,18 @@
             <a:cxnLst/>
             <a:rect r="r" b="b" t="t" l="l"/>
             <a:pathLst>
-              <a:path h="9017664" w="9485850">
+              <a:path h="5149108" w="17755545">
                 <a:moveTo>
                   <a:pt x="0" y="0"/>
                 </a:moveTo>
                 <a:lnTo>
-                  <a:pt x="9485850" y="0"/>
+                  <a:pt x="17755544" y="0"/>
                 </a:lnTo>
                 <a:lnTo>
-                  <a:pt x="9485850" y="9017664"/>
+                  <a:pt x="17755544" y="5149108"/>
                 </a:lnTo>
                 <a:lnTo>
-                  <a:pt x="0" y="9017664"/>
+                  <a:pt x="0" y="5149108"/>
                 </a:lnTo>
                 <a:lnTo>
                   <a:pt x="0" y="0"/>
@@ -14368,6 +14612,256 @@
           </a:blipFill>
         </p:spPr>
       </p:sp>
+      <p:grpSp>
+        <p:nvGrpSpPr>
+          <p:cNvPr name="Group 3" id="3"/>
+          <p:cNvGrpSpPr/>
+          <p:nvPr/>
+        </p:nvGrpSpPr>
+        <p:grpSpPr>
+          <a:xfrm rot="0">
+            <a:off x="621952" y="3823778"/>
+            <a:ext cx="16960349" cy="3086100"/>
+            <a:chOff x="0" y="0"/>
+            <a:chExt cx="4466923" cy="812800"/>
+          </a:xfrm>
+        </p:grpSpPr>
+        <p:sp>
+          <p:nvSpPr>
+            <p:cNvPr name="Freeform 4" id="4"/>
+            <p:cNvSpPr/>
+            <p:nvPr/>
+          </p:nvSpPr>
+          <p:spPr>
+            <a:xfrm flipH="false" flipV="false" rot="0">
+              <a:off x="0" y="0"/>
+              <a:ext cx="4466923" cy="812800"/>
+            </a:xfrm>
+            <a:custGeom>
+              <a:avLst/>
+              <a:gdLst/>
+              <a:ahLst/>
+              <a:cxnLst/>
+              <a:rect r="r" b="b" t="t" l="l"/>
+              <a:pathLst>
+                <a:path h="812800" w="4466923">
+                  <a:moveTo>
+                    <a:pt x="7760" y="0"/>
+                  </a:moveTo>
+                  <a:lnTo>
+                    <a:pt x="4459163" y="0"/>
+                  </a:lnTo>
+                  <a:cubicBezTo>
+                    <a:pt x="4461221" y="0"/>
+                    <a:pt x="4463195" y="818"/>
+                    <a:pt x="4464650" y="2273"/>
+                  </a:cubicBezTo>
+                  <a:cubicBezTo>
+                    <a:pt x="4466106" y="3728"/>
+                    <a:pt x="4466923" y="5702"/>
+                    <a:pt x="4466923" y="7760"/>
+                  </a:cubicBezTo>
+                  <a:lnTo>
+                    <a:pt x="4466923" y="805040"/>
+                  </a:lnTo>
+                  <a:cubicBezTo>
+                    <a:pt x="4466923" y="807098"/>
+                    <a:pt x="4466106" y="809072"/>
+                    <a:pt x="4464650" y="810527"/>
+                  </a:cubicBezTo>
+                  <a:cubicBezTo>
+                    <a:pt x="4463195" y="811982"/>
+                    <a:pt x="4461221" y="812800"/>
+                    <a:pt x="4459163" y="812800"/>
+                  </a:cubicBezTo>
+                  <a:lnTo>
+                    <a:pt x="7760" y="812800"/>
+                  </a:lnTo>
+                  <a:cubicBezTo>
+                    <a:pt x="5702" y="812800"/>
+                    <a:pt x="3728" y="811982"/>
+                    <a:pt x="2273" y="810527"/>
+                  </a:cubicBezTo>
+                  <a:cubicBezTo>
+                    <a:pt x="818" y="809072"/>
+                    <a:pt x="0" y="807098"/>
+                    <a:pt x="0" y="805040"/>
+                  </a:cubicBezTo>
+                  <a:lnTo>
+                    <a:pt x="0" y="7760"/>
+                  </a:lnTo>
+                  <a:cubicBezTo>
+                    <a:pt x="0" y="5702"/>
+                    <a:pt x="818" y="3728"/>
+                    <a:pt x="2273" y="2273"/>
+                  </a:cubicBezTo>
+                  <a:cubicBezTo>
+                    <a:pt x="3728" y="818"/>
+                    <a:pt x="5702" y="0"/>
+                    <a:pt x="7760" y="0"/>
+                  </a:cubicBezTo>
+                  <a:close/>
+                </a:path>
+              </a:pathLst>
+            </a:custGeom>
+            <a:solidFill>
+              <a:srgbClr val="233D89"/>
+            </a:solidFill>
+          </p:spPr>
+        </p:sp>
+        <p:sp>
+          <p:nvSpPr>
+            <p:cNvPr name="TextBox 5" id="5"/>
+            <p:cNvSpPr txBox="true"/>
+            <p:nvPr/>
+          </p:nvSpPr>
+          <p:spPr>
+            <a:xfrm>
+              <a:off x="0" y="-38100"/>
+              <a:ext cx="4466923" cy="850900"/>
+            </a:xfrm>
+            <a:prstGeom prst="rect">
+              <a:avLst/>
+            </a:prstGeom>
+          </p:spPr>
+          <p:txBody>
+            <a:bodyPr anchor="ctr" rtlCol="false" tIns="50800" lIns="50800" bIns="50800" rIns="50800"/>
+            <a:lstStyle/>
+            <a:p>
+              <a:pPr algn="ctr">
+                <a:lnSpc>
+                  <a:spcPts val="3449"/>
+                </a:lnSpc>
+              </a:pPr>
+            </a:p>
+          </p:txBody>
+        </p:sp>
+      </p:grpSp>
+      <p:grpSp>
+        <p:nvGrpSpPr>
+          <p:cNvPr name="Group 6" id="6"/>
+          <p:cNvGrpSpPr/>
+          <p:nvPr/>
+        </p:nvGrpSpPr>
+        <p:grpSpPr>
+          <a:xfrm rot="0">
+            <a:off x="11563883" y="2957244"/>
+            <a:ext cx="6324355" cy="3086100"/>
+            <a:chOff x="0" y="0"/>
+            <a:chExt cx="1665674" cy="812800"/>
+          </a:xfrm>
+        </p:grpSpPr>
+        <p:sp>
+          <p:nvSpPr>
+            <p:cNvPr name="Freeform 7" id="7"/>
+            <p:cNvSpPr/>
+            <p:nvPr/>
+          </p:nvSpPr>
+          <p:spPr>
+            <a:xfrm flipH="false" flipV="false" rot="0">
+              <a:off x="0" y="0"/>
+              <a:ext cx="1665674" cy="812800"/>
+            </a:xfrm>
+            <a:custGeom>
+              <a:avLst/>
+              <a:gdLst/>
+              <a:ahLst/>
+              <a:cxnLst/>
+              <a:rect r="r" b="b" t="t" l="l"/>
+              <a:pathLst>
+                <a:path h="812800" w="1665674">
+                  <a:moveTo>
+                    <a:pt x="20810" y="0"/>
+                  </a:moveTo>
+                  <a:lnTo>
+                    <a:pt x="1644863" y="0"/>
+                  </a:lnTo>
+                  <a:cubicBezTo>
+                    <a:pt x="1650383" y="0"/>
+                    <a:pt x="1655676" y="2193"/>
+                    <a:pt x="1659579" y="6095"/>
+                  </a:cubicBezTo>
+                  <a:cubicBezTo>
+                    <a:pt x="1663481" y="9998"/>
+                    <a:pt x="1665674" y="15291"/>
+                    <a:pt x="1665674" y="20810"/>
+                  </a:cubicBezTo>
+                  <a:lnTo>
+                    <a:pt x="1665674" y="791990"/>
+                  </a:lnTo>
+                  <a:cubicBezTo>
+                    <a:pt x="1665674" y="797509"/>
+                    <a:pt x="1663481" y="802802"/>
+                    <a:pt x="1659579" y="806705"/>
+                  </a:cubicBezTo>
+                  <a:cubicBezTo>
+                    <a:pt x="1655676" y="810607"/>
+                    <a:pt x="1650383" y="812800"/>
+                    <a:pt x="1644863" y="812800"/>
+                  </a:cubicBezTo>
+                  <a:lnTo>
+                    <a:pt x="20810" y="812800"/>
+                  </a:lnTo>
+                  <a:cubicBezTo>
+                    <a:pt x="15291" y="812800"/>
+                    <a:pt x="9998" y="810607"/>
+                    <a:pt x="6095" y="806705"/>
+                  </a:cubicBezTo>
+                  <a:cubicBezTo>
+                    <a:pt x="2193" y="802802"/>
+                    <a:pt x="0" y="797509"/>
+                    <a:pt x="0" y="791990"/>
+                  </a:cubicBezTo>
+                  <a:lnTo>
+                    <a:pt x="0" y="20810"/>
+                  </a:lnTo>
+                  <a:cubicBezTo>
+                    <a:pt x="0" y="15291"/>
+                    <a:pt x="2193" y="9998"/>
+                    <a:pt x="6095" y="6095"/>
+                  </a:cubicBezTo>
+                  <a:cubicBezTo>
+                    <a:pt x="9998" y="2193"/>
+                    <a:pt x="15291" y="0"/>
+                    <a:pt x="20810" y="0"/>
+                  </a:cubicBezTo>
+                  <a:close/>
+                </a:path>
+              </a:pathLst>
+            </a:custGeom>
+            <a:solidFill>
+              <a:srgbClr val="233D89"/>
+            </a:solidFill>
+          </p:spPr>
+        </p:sp>
+        <p:sp>
+          <p:nvSpPr>
+            <p:cNvPr name="TextBox 8" id="8"/>
+            <p:cNvSpPr txBox="true"/>
+            <p:nvPr/>
+          </p:nvSpPr>
+          <p:spPr>
+            <a:xfrm>
+              <a:off x="0" y="-38100"/>
+              <a:ext cx="1665674" cy="850900"/>
+            </a:xfrm>
+            <a:prstGeom prst="rect">
+              <a:avLst/>
+            </a:prstGeom>
+          </p:spPr>
+          <p:txBody>
+            <a:bodyPr anchor="ctr" rtlCol="false" tIns="50800" lIns="50800" bIns="50800" rIns="50800"/>
+            <a:lstStyle/>
+            <a:p>
+              <a:pPr algn="ctr">
+                <a:lnSpc>
+                  <a:spcPts val="3449"/>
+                </a:lnSpc>
+              </a:pPr>
+            </a:p>
+          </p:txBody>
+        </p:sp>
+      </p:grpSp>
     </p:spTree>
   </p:cSld>
   <p:clrMapOvr>
@@ -14382,7 +14876,7 @@
     <p:bg>
       <p:bgPr>
         <a:solidFill>
-          <a:srgbClr val="283D87"/>
+          <a:srgbClr val="233D89"/>
         </a:solidFill>
       </p:bgPr>
     </p:bg>
@@ -14408,8 +14902,8 @@
         </p:nvSpPr>
         <p:spPr>
           <a:xfrm flipH="false" flipV="false" rot="0">
-            <a:off x="150912" y="2890385"/>
-            <a:ext cx="17986175" cy="4202955"/>
+            <a:off x="266228" y="2227353"/>
+            <a:ext cx="17755545" cy="5149108"/>
           </a:xfrm>
           <a:custGeom>
             <a:avLst/>
@@ -14418,18 +14912,18 @@
             <a:cxnLst/>
             <a:rect r="r" b="b" t="t" l="l"/>
             <a:pathLst>
-              <a:path h="4202955" w="17986175">
+              <a:path h="5149108" w="17755545">
                 <a:moveTo>
                   <a:pt x="0" y="0"/>
                 </a:moveTo>
                 <a:lnTo>
-                  <a:pt x="17986176" y="0"/>
+                  <a:pt x="17755544" y="0"/>
                 </a:lnTo>
                 <a:lnTo>
-                  <a:pt x="17986176" y="4202956"/>
+                  <a:pt x="17755544" y="5149108"/>
                 </a:lnTo>
                 <a:lnTo>
-                  <a:pt x="0" y="4202956"/>
+                  <a:pt x="0" y="5149108"/>
                 </a:lnTo>
                 <a:lnTo>
                   <a:pt x="0" y="0"/>
@@ -14446,6 +14940,256 @@
           </a:blipFill>
         </p:spPr>
       </p:sp>
+      <p:grpSp>
+        <p:nvGrpSpPr>
+          <p:cNvPr name="Group 3" id="3"/>
+          <p:cNvGrpSpPr/>
+          <p:nvPr/>
+        </p:nvGrpSpPr>
+        <p:grpSpPr>
+          <a:xfrm rot="0">
+            <a:off x="663826" y="4577510"/>
+            <a:ext cx="16960349" cy="3086100"/>
+            <a:chOff x="0" y="0"/>
+            <a:chExt cx="4466923" cy="812800"/>
+          </a:xfrm>
+        </p:grpSpPr>
+        <p:sp>
+          <p:nvSpPr>
+            <p:cNvPr name="Freeform 4" id="4"/>
+            <p:cNvSpPr/>
+            <p:nvPr/>
+          </p:nvSpPr>
+          <p:spPr>
+            <a:xfrm flipH="false" flipV="false" rot="0">
+              <a:off x="0" y="0"/>
+              <a:ext cx="4466923" cy="812800"/>
+            </a:xfrm>
+            <a:custGeom>
+              <a:avLst/>
+              <a:gdLst/>
+              <a:ahLst/>
+              <a:cxnLst/>
+              <a:rect r="r" b="b" t="t" l="l"/>
+              <a:pathLst>
+                <a:path h="812800" w="4466923">
+                  <a:moveTo>
+                    <a:pt x="7760" y="0"/>
+                  </a:moveTo>
+                  <a:lnTo>
+                    <a:pt x="4459163" y="0"/>
+                  </a:lnTo>
+                  <a:cubicBezTo>
+                    <a:pt x="4461221" y="0"/>
+                    <a:pt x="4463195" y="818"/>
+                    <a:pt x="4464650" y="2273"/>
+                  </a:cubicBezTo>
+                  <a:cubicBezTo>
+                    <a:pt x="4466106" y="3728"/>
+                    <a:pt x="4466923" y="5702"/>
+                    <a:pt x="4466923" y="7760"/>
+                  </a:cubicBezTo>
+                  <a:lnTo>
+                    <a:pt x="4466923" y="805040"/>
+                  </a:lnTo>
+                  <a:cubicBezTo>
+                    <a:pt x="4466923" y="807098"/>
+                    <a:pt x="4466106" y="809072"/>
+                    <a:pt x="4464650" y="810527"/>
+                  </a:cubicBezTo>
+                  <a:cubicBezTo>
+                    <a:pt x="4463195" y="811982"/>
+                    <a:pt x="4461221" y="812800"/>
+                    <a:pt x="4459163" y="812800"/>
+                  </a:cubicBezTo>
+                  <a:lnTo>
+                    <a:pt x="7760" y="812800"/>
+                  </a:lnTo>
+                  <a:cubicBezTo>
+                    <a:pt x="5702" y="812800"/>
+                    <a:pt x="3728" y="811982"/>
+                    <a:pt x="2273" y="810527"/>
+                  </a:cubicBezTo>
+                  <a:cubicBezTo>
+                    <a:pt x="818" y="809072"/>
+                    <a:pt x="0" y="807098"/>
+                    <a:pt x="0" y="805040"/>
+                  </a:cubicBezTo>
+                  <a:lnTo>
+                    <a:pt x="0" y="7760"/>
+                  </a:lnTo>
+                  <a:cubicBezTo>
+                    <a:pt x="0" y="5702"/>
+                    <a:pt x="818" y="3728"/>
+                    <a:pt x="2273" y="2273"/>
+                  </a:cubicBezTo>
+                  <a:cubicBezTo>
+                    <a:pt x="3728" y="818"/>
+                    <a:pt x="5702" y="0"/>
+                    <a:pt x="7760" y="0"/>
+                  </a:cubicBezTo>
+                  <a:close/>
+                </a:path>
+              </a:pathLst>
+            </a:custGeom>
+            <a:solidFill>
+              <a:srgbClr val="233D89"/>
+            </a:solidFill>
+          </p:spPr>
+        </p:sp>
+        <p:sp>
+          <p:nvSpPr>
+            <p:cNvPr name="TextBox 5" id="5"/>
+            <p:cNvSpPr txBox="true"/>
+            <p:nvPr/>
+          </p:nvSpPr>
+          <p:spPr>
+            <a:xfrm>
+              <a:off x="0" y="-38100"/>
+              <a:ext cx="4466923" cy="850900"/>
+            </a:xfrm>
+            <a:prstGeom prst="rect">
+              <a:avLst/>
+            </a:prstGeom>
+          </p:spPr>
+          <p:txBody>
+            <a:bodyPr anchor="ctr" rtlCol="false" tIns="50800" lIns="50800" bIns="50800" rIns="50800"/>
+            <a:lstStyle/>
+            <a:p>
+              <a:pPr algn="ctr">
+                <a:lnSpc>
+                  <a:spcPts val="3449"/>
+                </a:lnSpc>
+              </a:pPr>
+            </a:p>
+          </p:txBody>
+        </p:sp>
+      </p:grpSp>
+      <p:grpSp>
+        <p:nvGrpSpPr>
+          <p:cNvPr name="Group 6" id="6"/>
+          <p:cNvGrpSpPr/>
+          <p:nvPr/>
+        </p:nvGrpSpPr>
+        <p:grpSpPr>
+          <a:xfrm rot="0">
+            <a:off x="1327651" y="3921484"/>
+            <a:ext cx="16960349" cy="3086100"/>
+            <a:chOff x="0" y="0"/>
+            <a:chExt cx="4466923" cy="812800"/>
+          </a:xfrm>
+        </p:grpSpPr>
+        <p:sp>
+          <p:nvSpPr>
+            <p:cNvPr name="Freeform 7" id="7"/>
+            <p:cNvSpPr/>
+            <p:nvPr/>
+          </p:nvSpPr>
+          <p:spPr>
+            <a:xfrm flipH="false" flipV="false" rot="0">
+              <a:off x="0" y="0"/>
+              <a:ext cx="4466923" cy="812800"/>
+            </a:xfrm>
+            <a:custGeom>
+              <a:avLst/>
+              <a:gdLst/>
+              <a:ahLst/>
+              <a:cxnLst/>
+              <a:rect r="r" b="b" t="t" l="l"/>
+              <a:pathLst>
+                <a:path h="812800" w="4466923">
+                  <a:moveTo>
+                    <a:pt x="7760" y="0"/>
+                  </a:moveTo>
+                  <a:lnTo>
+                    <a:pt x="4459163" y="0"/>
+                  </a:lnTo>
+                  <a:cubicBezTo>
+                    <a:pt x="4461221" y="0"/>
+                    <a:pt x="4463195" y="818"/>
+                    <a:pt x="4464650" y="2273"/>
+                  </a:cubicBezTo>
+                  <a:cubicBezTo>
+                    <a:pt x="4466106" y="3728"/>
+                    <a:pt x="4466923" y="5702"/>
+                    <a:pt x="4466923" y="7760"/>
+                  </a:cubicBezTo>
+                  <a:lnTo>
+                    <a:pt x="4466923" y="805040"/>
+                  </a:lnTo>
+                  <a:cubicBezTo>
+                    <a:pt x="4466923" y="807098"/>
+                    <a:pt x="4466106" y="809072"/>
+                    <a:pt x="4464650" y="810527"/>
+                  </a:cubicBezTo>
+                  <a:cubicBezTo>
+                    <a:pt x="4463195" y="811982"/>
+                    <a:pt x="4461221" y="812800"/>
+                    <a:pt x="4459163" y="812800"/>
+                  </a:cubicBezTo>
+                  <a:lnTo>
+                    <a:pt x="7760" y="812800"/>
+                  </a:lnTo>
+                  <a:cubicBezTo>
+                    <a:pt x="5702" y="812800"/>
+                    <a:pt x="3728" y="811982"/>
+                    <a:pt x="2273" y="810527"/>
+                  </a:cubicBezTo>
+                  <a:cubicBezTo>
+                    <a:pt x="818" y="809072"/>
+                    <a:pt x="0" y="807098"/>
+                    <a:pt x="0" y="805040"/>
+                  </a:cubicBezTo>
+                  <a:lnTo>
+                    <a:pt x="0" y="7760"/>
+                  </a:lnTo>
+                  <a:cubicBezTo>
+                    <a:pt x="0" y="5702"/>
+                    <a:pt x="818" y="3728"/>
+                    <a:pt x="2273" y="2273"/>
+                  </a:cubicBezTo>
+                  <a:cubicBezTo>
+                    <a:pt x="3728" y="818"/>
+                    <a:pt x="5702" y="0"/>
+                    <a:pt x="7760" y="0"/>
+                  </a:cubicBezTo>
+                  <a:close/>
+                </a:path>
+              </a:pathLst>
+            </a:custGeom>
+            <a:solidFill>
+              <a:srgbClr val="233D89"/>
+            </a:solidFill>
+          </p:spPr>
+        </p:sp>
+        <p:sp>
+          <p:nvSpPr>
+            <p:cNvPr name="TextBox 8" id="8"/>
+            <p:cNvSpPr txBox="true"/>
+            <p:nvPr/>
+          </p:nvSpPr>
+          <p:spPr>
+            <a:xfrm>
+              <a:off x="0" y="-38100"/>
+              <a:ext cx="4466923" cy="850900"/>
+            </a:xfrm>
+            <a:prstGeom prst="rect">
+              <a:avLst/>
+            </a:prstGeom>
+          </p:spPr>
+          <p:txBody>
+            <a:bodyPr anchor="ctr" rtlCol="false" tIns="50800" lIns="50800" bIns="50800" rIns="50800"/>
+            <a:lstStyle/>
+            <a:p>
+              <a:pPr algn="ctr">
+                <a:lnSpc>
+                  <a:spcPts val="3449"/>
+                </a:lnSpc>
+              </a:pPr>
+            </a:p>
+          </p:txBody>
+        </p:sp>
+      </p:grpSp>
     </p:spTree>
   </p:cSld>
   <p:clrMapOvr>
@@ -14460,7 +15204,7 @@
     <p:bg>
       <p:bgPr>
         <a:solidFill>
-          <a:srgbClr val="283D87"/>
+          <a:srgbClr val="233D89"/>
         </a:solidFill>
       </p:bgPr>
     </p:bg>
@@ -14486,8 +15230,8 @@
         </p:nvSpPr>
         <p:spPr>
           <a:xfrm flipH="false" flipV="false" rot="0">
-            <a:off x="241034" y="1970578"/>
-            <a:ext cx="17805932" cy="4874374"/>
+            <a:off x="266228" y="2227353"/>
+            <a:ext cx="17755545" cy="5149108"/>
           </a:xfrm>
           <a:custGeom>
             <a:avLst/>
@@ -14496,18 +15240,18 @@
             <a:cxnLst/>
             <a:rect r="r" b="b" t="t" l="l"/>
             <a:pathLst>
-              <a:path h="4874374" w="17805932">
+              <a:path h="5149108" w="17755545">
                 <a:moveTo>
                   <a:pt x="0" y="0"/>
                 </a:moveTo>
                 <a:lnTo>
-                  <a:pt x="17805932" y="0"/>
+                  <a:pt x="17755544" y="0"/>
                 </a:lnTo>
                 <a:lnTo>
-                  <a:pt x="17805932" y="4874374"/>
+                  <a:pt x="17755544" y="5149108"/>
                 </a:lnTo>
                 <a:lnTo>
-                  <a:pt x="0" y="4874374"/>
+                  <a:pt x="0" y="5149108"/>
                 </a:lnTo>
                 <a:lnTo>
                   <a:pt x="0" y="0"/>
@@ -14524,6 +15268,256 @@
           </a:blipFill>
         </p:spPr>
       </p:sp>
+      <p:grpSp>
+        <p:nvGrpSpPr>
+          <p:cNvPr name="Group 3" id="3"/>
+          <p:cNvGrpSpPr/>
+          <p:nvPr/>
+        </p:nvGrpSpPr>
+        <p:grpSpPr>
+          <a:xfrm rot="0">
+            <a:off x="663826" y="4577510"/>
+            <a:ext cx="16960349" cy="3086100"/>
+            <a:chOff x="0" y="0"/>
+            <a:chExt cx="4466923" cy="812800"/>
+          </a:xfrm>
+        </p:grpSpPr>
+        <p:sp>
+          <p:nvSpPr>
+            <p:cNvPr name="Freeform 4" id="4"/>
+            <p:cNvSpPr/>
+            <p:nvPr/>
+          </p:nvSpPr>
+          <p:spPr>
+            <a:xfrm flipH="false" flipV="false" rot="0">
+              <a:off x="0" y="0"/>
+              <a:ext cx="4466923" cy="812800"/>
+            </a:xfrm>
+            <a:custGeom>
+              <a:avLst/>
+              <a:gdLst/>
+              <a:ahLst/>
+              <a:cxnLst/>
+              <a:rect r="r" b="b" t="t" l="l"/>
+              <a:pathLst>
+                <a:path h="812800" w="4466923">
+                  <a:moveTo>
+                    <a:pt x="7760" y="0"/>
+                  </a:moveTo>
+                  <a:lnTo>
+                    <a:pt x="4459163" y="0"/>
+                  </a:lnTo>
+                  <a:cubicBezTo>
+                    <a:pt x="4461221" y="0"/>
+                    <a:pt x="4463195" y="818"/>
+                    <a:pt x="4464650" y="2273"/>
+                  </a:cubicBezTo>
+                  <a:cubicBezTo>
+                    <a:pt x="4466106" y="3728"/>
+                    <a:pt x="4466923" y="5702"/>
+                    <a:pt x="4466923" y="7760"/>
+                  </a:cubicBezTo>
+                  <a:lnTo>
+                    <a:pt x="4466923" y="805040"/>
+                  </a:lnTo>
+                  <a:cubicBezTo>
+                    <a:pt x="4466923" y="807098"/>
+                    <a:pt x="4466106" y="809072"/>
+                    <a:pt x="4464650" y="810527"/>
+                  </a:cubicBezTo>
+                  <a:cubicBezTo>
+                    <a:pt x="4463195" y="811982"/>
+                    <a:pt x="4461221" y="812800"/>
+                    <a:pt x="4459163" y="812800"/>
+                  </a:cubicBezTo>
+                  <a:lnTo>
+                    <a:pt x="7760" y="812800"/>
+                  </a:lnTo>
+                  <a:cubicBezTo>
+                    <a:pt x="5702" y="812800"/>
+                    <a:pt x="3728" y="811982"/>
+                    <a:pt x="2273" y="810527"/>
+                  </a:cubicBezTo>
+                  <a:cubicBezTo>
+                    <a:pt x="818" y="809072"/>
+                    <a:pt x="0" y="807098"/>
+                    <a:pt x="0" y="805040"/>
+                  </a:cubicBezTo>
+                  <a:lnTo>
+                    <a:pt x="0" y="7760"/>
+                  </a:lnTo>
+                  <a:cubicBezTo>
+                    <a:pt x="0" y="5702"/>
+                    <a:pt x="818" y="3728"/>
+                    <a:pt x="2273" y="2273"/>
+                  </a:cubicBezTo>
+                  <a:cubicBezTo>
+                    <a:pt x="3728" y="818"/>
+                    <a:pt x="5702" y="0"/>
+                    <a:pt x="7760" y="0"/>
+                  </a:cubicBezTo>
+                  <a:close/>
+                </a:path>
+              </a:pathLst>
+            </a:custGeom>
+            <a:solidFill>
+              <a:srgbClr val="233D89"/>
+            </a:solidFill>
+          </p:spPr>
+        </p:sp>
+        <p:sp>
+          <p:nvSpPr>
+            <p:cNvPr name="TextBox 5" id="5"/>
+            <p:cNvSpPr txBox="true"/>
+            <p:nvPr/>
+          </p:nvSpPr>
+          <p:spPr>
+            <a:xfrm>
+              <a:off x="0" y="-38100"/>
+              <a:ext cx="4466923" cy="850900"/>
+            </a:xfrm>
+            <a:prstGeom prst="rect">
+              <a:avLst/>
+            </a:prstGeom>
+          </p:spPr>
+          <p:txBody>
+            <a:bodyPr anchor="ctr" rtlCol="false" tIns="50800" lIns="50800" bIns="50800" rIns="50800"/>
+            <a:lstStyle/>
+            <a:p>
+              <a:pPr algn="ctr">
+                <a:lnSpc>
+                  <a:spcPts val="3449"/>
+                </a:lnSpc>
+              </a:pPr>
+            </a:p>
+          </p:txBody>
+        </p:sp>
+      </p:grpSp>
+      <p:grpSp>
+        <p:nvGrpSpPr>
+          <p:cNvPr name="Group 6" id="6"/>
+          <p:cNvGrpSpPr/>
+          <p:nvPr/>
+        </p:nvGrpSpPr>
+        <p:grpSpPr>
+          <a:xfrm rot="0">
+            <a:off x="5646830" y="3865652"/>
+            <a:ext cx="16960349" cy="3086100"/>
+            <a:chOff x="0" y="0"/>
+            <a:chExt cx="4466923" cy="812800"/>
+          </a:xfrm>
+        </p:grpSpPr>
+        <p:sp>
+          <p:nvSpPr>
+            <p:cNvPr name="Freeform 7" id="7"/>
+            <p:cNvSpPr/>
+            <p:nvPr/>
+          </p:nvSpPr>
+          <p:spPr>
+            <a:xfrm flipH="false" flipV="false" rot="0">
+              <a:off x="0" y="0"/>
+              <a:ext cx="4466923" cy="812800"/>
+            </a:xfrm>
+            <a:custGeom>
+              <a:avLst/>
+              <a:gdLst/>
+              <a:ahLst/>
+              <a:cxnLst/>
+              <a:rect r="r" b="b" t="t" l="l"/>
+              <a:pathLst>
+                <a:path h="812800" w="4466923">
+                  <a:moveTo>
+                    <a:pt x="7760" y="0"/>
+                  </a:moveTo>
+                  <a:lnTo>
+                    <a:pt x="4459163" y="0"/>
+                  </a:lnTo>
+                  <a:cubicBezTo>
+                    <a:pt x="4461221" y="0"/>
+                    <a:pt x="4463195" y="818"/>
+                    <a:pt x="4464650" y="2273"/>
+                  </a:cubicBezTo>
+                  <a:cubicBezTo>
+                    <a:pt x="4466106" y="3728"/>
+                    <a:pt x="4466923" y="5702"/>
+                    <a:pt x="4466923" y="7760"/>
+                  </a:cubicBezTo>
+                  <a:lnTo>
+                    <a:pt x="4466923" y="805040"/>
+                  </a:lnTo>
+                  <a:cubicBezTo>
+                    <a:pt x="4466923" y="807098"/>
+                    <a:pt x="4466106" y="809072"/>
+                    <a:pt x="4464650" y="810527"/>
+                  </a:cubicBezTo>
+                  <a:cubicBezTo>
+                    <a:pt x="4463195" y="811982"/>
+                    <a:pt x="4461221" y="812800"/>
+                    <a:pt x="4459163" y="812800"/>
+                  </a:cubicBezTo>
+                  <a:lnTo>
+                    <a:pt x="7760" y="812800"/>
+                  </a:lnTo>
+                  <a:cubicBezTo>
+                    <a:pt x="5702" y="812800"/>
+                    <a:pt x="3728" y="811982"/>
+                    <a:pt x="2273" y="810527"/>
+                  </a:cubicBezTo>
+                  <a:cubicBezTo>
+                    <a:pt x="818" y="809072"/>
+                    <a:pt x="0" y="807098"/>
+                    <a:pt x="0" y="805040"/>
+                  </a:cubicBezTo>
+                  <a:lnTo>
+                    <a:pt x="0" y="7760"/>
+                  </a:lnTo>
+                  <a:cubicBezTo>
+                    <a:pt x="0" y="5702"/>
+                    <a:pt x="818" y="3728"/>
+                    <a:pt x="2273" y="2273"/>
+                  </a:cubicBezTo>
+                  <a:cubicBezTo>
+                    <a:pt x="3728" y="818"/>
+                    <a:pt x="5702" y="0"/>
+                    <a:pt x="7760" y="0"/>
+                  </a:cubicBezTo>
+                  <a:close/>
+                </a:path>
+              </a:pathLst>
+            </a:custGeom>
+            <a:solidFill>
+              <a:srgbClr val="233D89"/>
+            </a:solidFill>
+          </p:spPr>
+        </p:sp>
+        <p:sp>
+          <p:nvSpPr>
+            <p:cNvPr name="TextBox 8" id="8"/>
+            <p:cNvSpPr txBox="true"/>
+            <p:nvPr/>
+          </p:nvSpPr>
+          <p:spPr>
+            <a:xfrm>
+              <a:off x="0" y="-38100"/>
+              <a:ext cx="4466923" cy="850900"/>
+            </a:xfrm>
+            <a:prstGeom prst="rect">
+              <a:avLst/>
+            </a:prstGeom>
+          </p:spPr>
+          <p:txBody>
+            <a:bodyPr anchor="ctr" rtlCol="false" tIns="50800" lIns="50800" bIns="50800" rIns="50800"/>
+            <a:lstStyle/>
+            <a:p>
+              <a:pPr algn="ctr">
+                <a:lnSpc>
+                  <a:spcPts val="3449"/>
+                </a:lnSpc>
+              </a:pPr>
+            </a:p>
+          </p:txBody>
+        </p:sp>
+      </p:grpSp>
     </p:spTree>
   </p:cSld>
   <p:clrMapOvr>
@@ -14564,8 +15558,8 @@
         </p:nvSpPr>
         <p:spPr>
           <a:xfrm flipH="false" flipV="false" rot="0">
-            <a:off x="4528962" y="624966"/>
-            <a:ext cx="9832027" cy="9382626"/>
+            <a:off x="266228" y="2227353"/>
+            <a:ext cx="17755545" cy="5149108"/>
           </a:xfrm>
           <a:custGeom>
             <a:avLst/>
@@ -14574,18 +15568,18 @@
             <a:cxnLst/>
             <a:rect r="r" b="b" t="t" l="l"/>
             <a:pathLst>
-              <a:path h="9382626" w="9832027">
+              <a:path h="5149108" w="17755545">
                 <a:moveTo>
                   <a:pt x="0" y="0"/>
                 </a:moveTo>
                 <a:lnTo>
-                  <a:pt x="9832028" y="0"/>
+                  <a:pt x="17755544" y="0"/>
                 </a:lnTo>
                 <a:lnTo>
-                  <a:pt x="9832028" y="9382626"/>
+                  <a:pt x="17755544" y="5149108"/>
                 </a:lnTo>
                 <a:lnTo>
-                  <a:pt x="0" y="9382626"/>
+                  <a:pt x="0" y="5149108"/>
                 </a:lnTo>
                 <a:lnTo>
                   <a:pt x="0" y="0"/>
@@ -14602,6 +15596,236 @@
           </a:blipFill>
         </p:spPr>
       </p:sp>
+      <p:grpSp>
+        <p:nvGrpSpPr>
+          <p:cNvPr name="Group 3" id="3"/>
+          <p:cNvGrpSpPr/>
+          <p:nvPr/>
+        </p:nvGrpSpPr>
+        <p:grpSpPr>
+          <a:xfrm rot="0">
+            <a:off x="761532" y="4717090"/>
+            <a:ext cx="16960349" cy="3086100"/>
+            <a:chOff x="0" y="0"/>
+            <a:chExt cx="4466923" cy="812800"/>
+          </a:xfrm>
+        </p:grpSpPr>
+        <p:sp>
+          <p:nvSpPr>
+            <p:cNvPr name="Freeform 4" id="4"/>
+            <p:cNvSpPr/>
+            <p:nvPr/>
+          </p:nvSpPr>
+          <p:spPr>
+            <a:xfrm flipH="false" flipV="false" rot="0">
+              <a:off x="0" y="0"/>
+              <a:ext cx="4466923" cy="812800"/>
+            </a:xfrm>
+            <a:custGeom>
+              <a:avLst/>
+              <a:gdLst/>
+              <a:ahLst/>
+              <a:cxnLst/>
+              <a:rect r="r" b="b" t="t" l="l"/>
+              <a:pathLst>
+                <a:path h="812800" w="4466923">
+                  <a:moveTo>
+                    <a:pt x="7760" y="0"/>
+                  </a:moveTo>
+                  <a:lnTo>
+                    <a:pt x="4459163" y="0"/>
+                  </a:lnTo>
+                  <a:cubicBezTo>
+                    <a:pt x="4461221" y="0"/>
+                    <a:pt x="4463195" y="818"/>
+                    <a:pt x="4464650" y="2273"/>
+                  </a:cubicBezTo>
+                  <a:cubicBezTo>
+                    <a:pt x="4466106" y="3728"/>
+                    <a:pt x="4466923" y="5702"/>
+                    <a:pt x="4466923" y="7760"/>
+                  </a:cubicBezTo>
+                  <a:lnTo>
+                    <a:pt x="4466923" y="805040"/>
+                  </a:lnTo>
+                  <a:cubicBezTo>
+                    <a:pt x="4466923" y="807098"/>
+                    <a:pt x="4466106" y="809072"/>
+                    <a:pt x="4464650" y="810527"/>
+                  </a:cubicBezTo>
+                  <a:cubicBezTo>
+                    <a:pt x="4463195" y="811982"/>
+                    <a:pt x="4461221" y="812800"/>
+                    <a:pt x="4459163" y="812800"/>
+                  </a:cubicBezTo>
+                  <a:lnTo>
+                    <a:pt x="7760" y="812800"/>
+                  </a:lnTo>
+                  <a:cubicBezTo>
+                    <a:pt x="5702" y="812800"/>
+                    <a:pt x="3728" y="811982"/>
+                    <a:pt x="2273" y="810527"/>
+                  </a:cubicBezTo>
+                  <a:cubicBezTo>
+                    <a:pt x="818" y="809072"/>
+                    <a:pt x="0" y="807098"/>
+                    <a:pt x="0" y="805040"/>
+                  </a:cubicBezTo>
+                  <a:lnTo>
+                    <a:pt x="0" y="7760"/>
+                  </a:lnTo>
+                  <a:cubicBezTo>
+                    <a:pt x="0" y="5702"/>
+                    <a:pt x="818" y="3728"/>
+                    <a:pt x="2273" y="2273"/>
+                  </a:cubicBezTo>
+                  <a:cubicBezTo>
+                    <a:pt x="3728" y="818"/>
+                    <a:pt x="5702" y="0"/>
+                    <a:pt x="7760" y="0"/>
+                  </a:cubicBezTo>
+                  <a:close/>
+                </a:path>
+              </a:pathLst>
+            </a:custGeom>
+            <a:solidFill>
+              <a:srgbClr val="233D89"/>
+            </a:solidFill>
+          </p:spPr>
+        </p:sp>
+        <p:sp>
+          <p:nvSpPr>
+            <p:cNvPr name="TextBox 5" id="5"/>
+            <p:cNvSpPr txBox="true"/>
+            <p:nvPr/>
+          </p:nvSpPr>
+          <p:spPr>
+            <a:xfrm>
+              <a:off x="0" y="-38100"/>
+              <a:ext cx="4466923" cy="850900"/>
+            </a:xfrm>
+            <a:prstGeom prst="rect">
+              <a:avLst/>
+            </a:prstGeom>
+          </p:spPr>
+          <p:txBody>
+            <a:bodyPr anchor="ctr" rtlCol="false" tIns="50800" lIns="50800" bIns="50800" rIns="50800"/>
+            <a:lstStyle/>
+            <a:p>
+              <a:pPr algn="ctr">
+                <a:lnSpc>
+                  <a:spcPts val="3449"/>
+                </a:lnSpc>
+              </a:pPr>
+            </a:p>
+          </p:txBody>
+        </p:sp>
+      </p:grpSp>
+      <p:grpSp>
+        <p:nvGrpSpPr>
+          <p:cNvPr name="Group 6" id="6"/>
+          <p:cNvGrpSpPr/>
+          <p:nvPr/>
+        </p:nvGrpSpPr>
+        <p:grpSpPr>
+          <a:xfrm rot="0">
+            <a:off x="11662727" y="3823778"/>
+            <a:ext cx="5919573" cy="3086100"/>
+            <a:chOff x="0" y="0"/>
+            <a:chExt cx="1559065" cy="812800"/>
+          </a:xfrm>
+        </p:grpSpPr>
+        <p:sp>
+          <p:nvSpPr>
+            <p:cNvPr name="Freeform 7" id="7"/>
+            <p:cNvSpPr/>
+            <p:nvPr/>
+          </p:nvSpPr>
+          <p:spPr>
+            <a:xfrm flipH="false" flipV="false" rot="0">
+              <a:off x="0" y="0"/>
+              <a:ext cx="1559065" cy="812800"/>
+            </a:xfrm>
+            <a:custGeom>
+              <a:avLst/>
+              <a:gdLst/>
+              <a:ahLst/>
+              <a:cxnLst/>
+              <a:rect r="r" b="b" t="t" l="l"/>
+              <a:pathLst>
+                <a:path h="812800" w="1559065">
+                  <a:moveTo>
+                    <a:pt x="22233" y="0"/>
+                  </a:moveTo>
+                  <a:lnTo>
+                    <a:pt x="1536831" y="0"/>
+                  </a:lnTo>
+                  <a:cubicBezTo>
+                    <a:pt x="1549110" y="0"/>
+                    <a:pt x="1559065" y="9954"/>
+                    <a:pt x="1559065" y="22233"/>
+                  </a:cubicBezTo>
+                  <a:lnTo>
+                    <a:pt x="1559065" y="790567"/>
+                  </a:lnTo>
+                  <a:cubicBezTo>
+                    <a:pt x="1559065" y="802846"/>
+                    <a:pt x="1549110" y="812800"/>
+                    <a:pt x="1536831" y="812800"/>
+                  </a:cubicBezTo>
+                  <a:lnTo>
+                    <a:pt x="22233" y="812800"/>
+                  </a:lnTo>
+                  <a:cubicBezTo>
+                    <a:pt x="9954" y="812800"/>
+                    <a:pt x="0" y="802846"/>
+                    <a:pt x="0" y="790567"/>
+                  </a:cubicBezTo>
+                  <a:lnTo>
+                    <a:pt x="0" y="22233"/>
+                  </a:lnTo>
+                  <a:cubicBezTo>
+                    <a:pt x="0" y="9954"/>
+                    <a:pt x="9954" y="0"/>
+                    <a:pt x="22233" y="0"/>
+                  </a:cubicBezTo>
+                  <a:close/>
+                </a:path>
+              </a:pathLst>
+            </a:custGeom>
+            <a:solidFill>
+              <a:srgbClr val="233D89"/>
+            </a:solidFill>
+          </p:spPr>
+        </p:sp>
+        <p:sp>
+          <p:nvSpPr>
+            <p:cNvPr name="TextBox 8" id="8"/>
+            <p:cNvSpPr txBox="true"/>
+            <p:nvPr/>
+          </p:nvSpPr>
+          <p:spPr>
+            <a:xfrm>
+              <a:off x="0" y="-38100"/>
+              <a:ext cx="1559065" cy="850900"/>
+            </a:xfrm>
+            <a:prstGeom prst="rect">
+              <a:avLst/>
+            </a:prstGeom>
+          </p:spPr>
+          <p:txBody>
+            <a:bodyPr anchor="ctr" rtlCol="false" tIns="50800" lIns="50800" bIns="50800" rIns="50800"/>
+            <a:lstStyle/>
+            <a:p>
+              <a:pPr algn="ctr">
+                <a:lnSpc>
+                  <a:spcPts val="3449"/>
+                </a:lnSpc>
+              </a:pPr>
+            </a:p>
+          </p:txBody>
+        </p:sp>
+      </p:grpSp>
     </p:spTree>
   </p:cSld>
   <p:clrMapOvr>
@@ -14642,8 +15866,8 @@
         </p:nvSpPr>
         <p:spPr>
           <a:xfrm flipH="false" flipV="false" rot="0">
-            <a:off x="4644143" y="509748"/>
-            <a:ext cx="9623518" cy="9267504"/>
+            <a:off x="266228" y="2227353"/>
+            <a:ext cx="17755545" cy="5149108"/>
           </a:xfrm>
           <a:custGeom>
             <a:avLst/>
@@ -14652,18 +15876,18 @@
             <a:cxnLst/>
             <a:rect r="r" b="b" t="t" l="l"/>
             <a:pathLst>
-              <a:path h="9267504" w="9623518">
+              <a:path h="5149108" w="17755545">
                 <a:moveTo>
                   <a:pt x="0" y="0"/>
                 </a:moveTo>
                 <a:lnTo>
-                  <a:pt x="9623518" y="0"/>
+                  <a:pt x="17755544" y="0"/>
                 </a:lnTo>
                 <a:lnTo>
-                  <a:pt x="9623518" y="9267504"/>
+                  <a:pt x="17755544" y="5149108"/>
                 </a:lnTo>
                 <a:lnTo>
-                  <a:pt x="0" y="9267504"/>
+                  <a:pt x="0" y="5149108"/>
                 </a:lnTo>
                 <a:lnTo>
                   <a:pt x="0" y="0"/>
@@ -14680,6 +15904,131 @@
           </a:blipFill>
         </p:spPr>
       </p:sp>
+      <p:grpSp>
+        <p:nvGrpSpPr>
+          <p:cNvPr name="Group 3" id="3"/>
+          <p:cNvGrpSpPr/>
+          <p:nvPr/>
+        </p:nvGrpSpPr>
+        <p:grpSpPr>
+          <a:xfrm rot="0">
+            <a:off x="859238" y="4661258"/>
+            <a:ext cx="16960349" cy="3086100"/>
+            <a:chOff x="0" y="0"/>
+            <a:chExt cx="4466923" cy="812800"/>
+          </a:xfrm>
+        </p:grpSpPr>
+        <p:sp>
+          <p:nvSpPr>
+            <p:cNvPr name="Freeform 4" id="4"/>
+            <p:cNvSpPr/>
+            <p:nvPr/>
+          </p:nvSpPr>
+          <p:spPr>
+            <a:xfrm flipH="false" flipV="false" rot="0">
+              <a:off x="0" y="0"/>
+              <a:ext cx="4466923" cy="812800"/>
+            </a:xfrm>
+            <a:custGeom>
+              <a:avLst/>
+              <a:gdLst/>
+              <a:ahLst/>
+              <a:cxnLst/>
+              <a:rect r="r" b="b" t="t" l="l"/>
+              <a:pathLst>
+                <a:path h="812800" w="4466923">
+                  <a:moveTo>
+                    <a:pt x="7760" y="0"/>
+                  </a:moveTo>
+                  <a:lnTo>
+                    <a:pt x="4459163" y="0"/>
+                  </a:lnTo>
+                  <a:cubicBezTo>
+                    <a:pt x="4461221" y="0"/>
+                    <a:pt x="4463195" y="818"/>
+                    <a:pt x="4464650" y="2273"/>
+                  </a:cubicBezTo>
+                  <a:cubicBezTo>
+                    <a:pt x="4466106" y="3728"/>
+                    <a:pt x="4466923" y="5702"/>
+                    <a:pt x="4466923" y="7760"/>
+                  </a:cubicBezTo>
+                  <a:lnTo>
+                    <a:pt x="4466923" y="805040"/>
+                  </a:lnTo>
+                  <a:cubicBezTo>
+                    <a:pt x="4466923" y="807098"/>
+                    <a:pt x="4466106" y="809072"/>
+                    <a:pt x="4464650" y="810527"/>
+                  </a:cubicBezTo>
+                  <a:cubicBezTo>
+                    <a:pt x="4463195" y="811982"/>
+                    <a:pt x="4461221" y="812800"/>
+                    <a:pt x="4459163" y="812800"/>
+                  </a:cubicBezTo>
+                  <a:lnTo>
+                    <a:pt x="7760" y="812800"/>
+                  </a:lnTo>
+                  <a:cubicBezTo>
+                    <a:pt x="5702" y="812800"/>
+                    <a:pt x="3728" y="811982"/>
+                    <a:pt x="2273" y="810527"/>
+                  </a:cubicBezTo>
+                  <a:cubicBezTo>
+                    <a:pt x="818" y="809072"/>
+                    <a:pt x="0" y="807098"/>
+                    <a:pt x="0" y="805040"/>
+                  </a:cubicBezTo>
+                  <a:lnTo>
+                    <a:pt x="0" y="7760"/>
+                  </a:lnTo>
+                  <a:cubicBezTo>
+                    <a:pt x="0" y="5702"/>
+                    <a:pt x="818" y="3728"/>
+                    <a:pt x="2273" y="2273"/>
+                  </a:cubicBezTo>
+                  <a:cubicBezTo>
+                    <a:pt x="3728" y="818"/>
+                    <a:pt x="5702" y="0"/>
+                    <a:pt x="7760" y="0"/>
+                  </a:cubicBezTo>
+                  <a:close/>
+                </a:path>
+              </a:pathLst>
+            </a:custGeom>
+            <a:solidFill>
+              <a:srgbClr val="233D89"/>
+            </a:solidFill>
+          </p:spPr>
+        </p:sp>
+        <p:sp>
+          <p:nvSpPr>
+            <p:cNvPr name="TextBox 5" id="5"/>
+            <p:cNvSpPr txBox="true"/>
+            <p:nvPr/>
+          </p:nvSpPr>
+          <p:spPr>
+            <a:xfrm>
+              <a:off x="0" y="-38100"/>
+              <a:ext cx="4466923" cy="850900"/>
+            </a:xfrm>
+            <a:prstGeom prst="rect">
+              <a:avLst/>
+            </a:prstGeom>
+          </p:spPr>
+          <p:txBody>
+            <a:bodyPr anchor="ctr" rtlCol="false" tIns="50800" lIns="50800" bIns="50800" rIns="50800"/>
+            <a:lstStyle/>
+            <a:p>
+              <a:pPr algn="ctr">
+                <a:lnSpc>
+                  <a:spcPts val="3449"/>
+                </a:lnSpc>
+              </a:pPr>
+            </a:p>
+          </p:txBody>
+        </p:sp>
+      </p:grpSp>
     </p:spTree>
   </p:cSld>
   <p:clrMapOvr>
@@ -14689,12 +16038,12 @@
 </file>
 
 <file path=ppt/slides/slide25.xml><?xml version="1.0" encoding="utf-8"?>
-<p:sld xmlns:p="http://schemas.openxmlformats.org/presentationml/2006/main" xmlns:a="http://schemas.openxmlformats.org/drawingml/2006/main">
+<p:sld xmlns:p="http://schemas.openxmlformats.org/presentationml/2006/main" xmlns:a="http://schemas.openxmlformats.org/drawingml/2006/main" xmlns:r="http://schemas.openxmlformats.org/officeDocument/2006/relationships">
   <p:cSld>
     <p:bg>
       <p:bgPr>
         <a:solidFill>
-          <a:srgbClr val="1E3A8A"/>
+          <a:srgbClr val="233D89"/>
         </a:solidFill>
       </p:bgPr>
     </p:bg>
@@ -14714,45 +16063,1432 @@
       </p:grpSpPr>
       <p:sp>
         <p:nvSpPr>
-          <p:cNvPr name="TextBox 2" id="2"/>
-          <p:cNvSpPr txBox="true"/>
+          <p:cNvPr name="Freeform 2" id="2"/>
+          <p:cNvSpPr/>
           <p:nvPr/>
         </p:nvSpPr>
         <p:spPr>
+          <a:xfrm flipH="false" flipV="false" rot="0">
+            <a:off x="266228" y="2227353"/>
+            <a:ext cx="17755545" cy="5149108"/>
+          </a:xfrm>
+          <a:custGeom>
+            <a:avLst/>
+            <a:gdLst/>
+            <a:ahLst/>
+            <a:cxnLst/>
+            <a:rect r="r" b="b" t="t" l="l"/>
+            <a:pathLst>
+              <a:path h="5149108" w="17755545">
+                <a:moveTo>
+                  <a:pt x="0" y="0"/>
+                </a:moveTo>
+                <a:lnTo>
+                  <a:pt x="17755544" y="0"/>
+                </a:lnTo>
+                <a:lnTo>
+                  <a:pt x="17755544" y="5149108"/>
+                </a:lnTo>
+                <a:lnTo>
+                  <a:pt x="0" y="5149108"/>
+                </a:lnTo>
+                <a:lnTo>
+                  <a:pt x="0" y="0"/>
+                </a:lnTo>
+                <a:close/>
+              </a:path>
+            </a:pathLst>
+          </a:custGeom>
+          <a:blipFill>
+            <a:blip r:embed="rId2"/>
+            <a:stretch>
+              <a:fillRect l="0" t="0" r="0" b="0"/>
+            </a:stretch>
+          </a:blipFill>
+        </p:spPr>
+      </p:sp>
+      <p:grpSp>
+        <p:nvGrpSpPr>
+          <p:cNvPr name="Group 3" id="3"/>
+          <p:cNvGrpSpPr/>
+          <p:nvPr/>
+        </p:nvGrpSpPr>
+        <p:grpSpPr>
           <a:xfrm rot="0">
-            <a:off x="2335702" y="3082273"/>
-            <a:ext cx="13616597" cy="3145790"/>
+            <a:off x="775490" y="5442906"/>
+            <a:ext cx="16960349" cy="3086100"/>
+            <a:chOff x="0" y="0"/>
+            <a:chExt cx="4466923" cy="812800"/>
           </a:xfrm>
-          <a:prstGeom prst="rect">
+        </p:grpSpPr>
+        <p:sp>
+          <p:nvSpPr>
+            <p:cNvPr name="Freeform 4" id="4"/>
+            <p:cNvSpPr/>
+            <p:nvPr/>
+          </p:nvSpPr>
+          <p:spPr>
+            <a:xfrm flipH="false" flipV="false" rot="0">
+              <a:off x="0" y="0"/>
+              <a:ext cx="4466923" cy="812800"/>
+            </a:xfrm>
+            <a:custGeom>
+              <a:avLst/>
+              <a:gdLst/>
+              <a:ahLst/>
+              <a:cxnLst/>
+              <a:rect r="r" b="b" t="t" l="l"/>
+              <a:pathLst>
+                <a:path h="812800" w="4466923">
+                  <a:moveTo>
+                    <a:pt x="7760" y="0"/>
+                  </a:moveTo>
+                  <a:lnTo>
+                    <a:pt x="4459163" y="0"/>
+                  </a:lnTo>
+                  <a:cubicBezTo>
+                    <a:pt x="4461221" y="0"/>
+                    <a:pt x="4463195" y="818"/>
+                    <a:pt x="4464650" y="2273"/>
+                  </a:cubicBezTo>
+                  <a:cubicBezTo>
+                    <a:pt x="4466106" y="3728"/>
+                    <a:pt x="4466923" y="5702"/>
+                    <a:pt x="4466923" y="7760"/>
+                  </a:cubicBezTo>
+                  <a:lnTo>
+                    <a:pt x="4466923" y="805040"/>
+                  </a:lnTo>
+                  <a:cubicBezTo>
+                    <a:pt x="4466923" y="807098"/>
+                    <a:pt x="4466106" y="809072"/>
+                    <a:pt x="4464650" y="810527"/>
+                  </a:cubicBezTo>
+                  <a:cubicBezTo>
+                    <a:pt x="4463195" y="811982"/>
+                    <a:pt x="4461221" y="812800"/>
+                    <a:pt x="4459163" y="812800"/>
+                  </a:cubicBezTo>
+                  <a:lnTo>
+                    <a:pt x="7760" y="812800"/>
+                  </a:lnTo>
+                  <a:cubicBezTo>
+                    <a:pt x="5702" y="812800"/>
+                    <a:pt x="3728" y="811982"/>
+                    <a:pt x="2273" y="810527"/>
+                  </a:cubicBezTo>
+                  <a:cubicBezTo>
+                    <a:pt x="818" y="809072"/>
+                    <a:pt x="0" y="807098"/>
+                    <a:pt x="0" y="805040"/>
+                  </a:cubicBezTo>
+                  <a:lnTo>
+                    <a:pt x="0" y="7760"/>
+                  </a:lnTo>
+                  <a:cubicBezTo>
+                    <a:pt x="0" y="5702"/>
+                    <a:pt x="818" y="3728"/>
+                    <a:pt x="2273" y="2273"/>
+                  </a:cubicBezTo>
+                  <a:cubicBezTo>
+                    <a:pt x="3728" y="818"/>
+                    <a:pt x="5702" y="0"/>
+                    <a:pt x="7760" y="0"/>
+                  </a:cubicBezTo>
+                  <a:close/>
+                </a:path>
+              </a:pathLst>
+            </a:custGeom>
+            <a:solidFill>
+              <a:srgbClr val="233D89"/>
+            </a:solidFill>
+          </p:spPr>
+        </p:sp>
+        <p:sp>
+          <p:nvSpPr>
+            <p:cNvPr name="TextBox 5" id="5"/>
+            <p:cNvSpPr txBox="true"/>
+            <p:nvPr/>
+          </p:nvSpPr>
+          <p:spPr>
+            <a:xfrm>
+              <a:off x="0" y="-38100"/>
+              <a:ext cx="4466923" cy="850900"/>
+            </a:xfrm>
+            <a:prstGeom prst="rect">
+              <a:avLst/>
+            </a:prstGeom>
+          </p:spPr>
+          <p:txBody>
+            <a:bodyPr anchor="ctr" rtlCol="false" tIns="50800" lIns="50800" bIns="50800" rIns="50800"/>
+            <a:lstStyle/>
+            <a:p>
+              <a:pPr algn="ctr">
+                <a:lnSpc>
+                  <a:spcPts val="3449"/>
+                </a:lnSpc>
+              </a:pPr>
+            </a:p>
+          </p:txBody>
+        </p:sp>
+      </p:grpSp>
+      <p:grpSp>
+        <p:nvGrpSpPr>
+          <p:cNvPr name="Group 6" id="6"/>
+          <p:cNvGrpSpPr/>
+          <p:nvPr/>
+        </p:nvGrpSpPr>
+        <p:grpSpPr>
+          <a:xfrm rot="0">
+            <a:off x="6692542" y="4606495"/>
+            <a:ext cx="10330300" cy="3086100"/>
+            <a:chOff x="0" y="0"/>
+            <a:chExt cx="2720738" cy="812800"/>
+          </a:xfrm>
+        </p:grpSpPr>
+        <p:sp>
+          <p:nvSpPr>
+            <p:cNvPr name="Freeform 7" id="7"/>
+            <p:cNvSpPr/>
+            <p:nvPr/>
+          </p:nvSpPr>
+          <p:spPr>
+            <a:xfrm flipH="false" flipV="false" rot="0">
+              <a:off x="0" y="0"/>
+              <a:ext cx="2720738" cy="812800"/>
+            </a:xfrm>
+            <a:custGeom>
+              <a:avLst/>
+              <a:gdLst/>
+              <a:ahLst/>
+              <a:cxnLst/>
+              <a:rect r="r" b="b" t="t" l="l"/>
+              <a:pathLst>
+                <a:path h="812800" w="2720738">
+                  <a:moveTo>
+                    <a:pt x="12740" y="0"/>
+                  </a:moveTo>
+                  <a:lnTo>
+                    <a:pt x="2707997" y="0"/>
+                  </a:lnTo>
+                  <a:cubicBezTo>
+                    <a:pt x="2715034" y="0"/>
+                    <a:pt x="2720738" y="5704"/>
+                    <a:pt x="2720738" y="12740"/>
+                  </a:cubicBezTo>
+                  <a:lnTo>
+                    <a:pt x="2720738" y="800060"/>
+                  </a:lnTo>
+                  <a:cubicBezTo>
+                    <a:pt x="2720738" y="803439"/>
+                    <a:pt x="2719395" y="806679"/>
+                    <a:pt x="2717006" y="809068"/>
+                  </a:cubicBezTo>
+                  <a:cubicBezTo>
+                    <a:pt x="2714617" y="811458"/>
+                    <a:pt x="2711376" y="812800"/>
+                    <a:pt x="2707997" y="812800"/>
+                  </a:cubicBezTo>
+                  <a:lnTo>
+                    <a:pt x="12740" y="812800"/>
+                  </a:lnTo>
+                  <a:cubicBezTo>
+                    <a:pt x="5704" y="812800"/>
+                    <a:pt x="0" y="807096"/>
+                    <a:pt x="0" y="800060"/>
+                  </a:cubicBezTo>
+                  <a:lnTo>
+                    <a:pt x="0" y="12740"/>
+                  </a:lnTo>
+                  <a:cubicBezTo>
+                    <a:pt x="0" y="5704"/>
+                    <a:pt x="5704" y="0"/>
+                    <a:pt x="12740" y="0"/>
+                  </a:cubicBezTo>
+                  <a:close/>
+                </a:path>
+              </a:pathLst>
+            </a:custGeom>
+            <a:solidFill>
+              <a:srgbClr val="233D89"/>
+            </a:solidFill>
+          </p:spPr>
+        </p:sp>
+        <p:sp>
+          <p:nvSpPr>
+            <p:cNvPr name="TextBox 8" id="8"/>
+            <p:cNvSpPr txBox="true"/>
+            <p:nvPr/>
+          </p:nvSpPr>
+          <p:spPr>
+            <a:xfrm>
+              <a:off x="0" y="-38100"/>
+              <a:ext cx="2720738" cy="850900"/>
+            </a:xfrm>
+            <a:prstGeom prst="rect">
+              <a:avLst/>
+            </a:prstGeom>
+          </p:spPr>
+          <p:txBody>
+            <a:bodyPr anchor="ctr" rtlCol="false" tIns="50800" lIns="50800" bIns="50800" rIns="50800"/>
+            <a:lstStyle/>
+            <a:p>
+              <a:pPr algn="ctr">
+                <a:lnSpc>
+                  <a:spcPts val="3449"/>
+                </a:lnSpc>
+              </a:pPr>
+            </a:p>
+          </p:txBody>
+        </p:sp>
+      </p:grpSp>
+    </p:spTree>
+  </p:cSld>
+  <p:clrMapOvr>
+    <a:masterClrMapping/>
+  </p:clrMapOvr>
+</p:sld>
+</file>
+
+<file path=ppt/slides/slide26.xml><?xml version="1.0" encoding="utf-8"?>
+<p:sld xmlns:p="http://schemas.openxmlformats.org/presentationml/2006/main" xmlns:a="http://schemas.openxmlformats.org/drawingml/2006/main" xmlns:r="http://schemas.openxmlformats.org/officeDocument/2006/relationships">
+  <p:cSld>
+    <p:bg>
+      <p:bgPr>
+        <a:solidFill>
+          <a:srgbClr val="233D89"/>
+        </a:solidFill>
+      </p:bgPr>
+    </p:bg>
+    <p:spTree>
+      <p:nvGrpSpPr>
+        <p:cNvPr id="1" name=""/>
+        <p:cNvGrpSpPr/>
+        <p:nvPr/>
+      </p:nvGrpSpPr>
+      <p:grpSpPr>
+        <a:xfrm>
+          <a:off x="0" y="0"/>
+          <a:ext cx="0" cy="0"/>
+          <a:chOff x="0" y="0"/>
+          <a:chExt cx="0" cy="0"/>
+        </a:xfrm>
+      </p:grpSpPr>
+      <p:sp>
+        <p:nvSpPr>
+          <p:cNvPr name="Freeform 2" id="2"/>
+          <p:cNvSpPr/>
+          <p:nvPr/>
+        </p:nvSpPr>
+        <p:spPr>
+          <a:xfrm flipH="false" flipV="false" rot="0">
+            <a:off x="266228" y="2227353"/>
+            <a:ext cx="17755545" cy="5149108"/>
+          </a:xfrm>
+          <a:custGeom>
             <a:avLst/>
-          </a:prstGeom>
+            <a:gdLst/>
+            <a:ahLst/>
+            <a:cxnLst/>
+            <a:rect r="r" b="b" t="t" l="l"/>
+            <a:pathLst>
+              <a:path h="5149108" w="17755545">
+                <a:moveTo>
+                  <a:pt x="0" y="0"/>
+                </a:moveTo>
+                <a:lnTo>
+                  <a:pt x="17755544" y="0"/>
+                </a:lnTo>
+                <a:lnTo>
+                  <a:pt x="17755544" y="5149108"/>
+                </a:lnTo>
+                <a:lnTo>
+                  <a:pt x="0" y="5149108"/>
+                </a:lnTo>
+                <a:lnTo>
+                  <a:pt x="0" y="0"/>
+                </a:lnTo>
+                <a:close/>
+              </a:path>
+            </a:pathLst>
+          </a:custGeom>
+          <a:blipFill>
+            <a:blip r:embed="rId2"/>
+            <a:stretch>
+              <a:fillRect l="0" t="0" r="0" b="0"/>
+            </a:stretch>
+          </a:blipFill>
         </p:spPr>
-        <p:txBody>
-          <a:bodyPr anchor="t" rtlCol="false" tIns="0" lIns="0" bIns="0" rIns="0">
-            <a:spAutoFit/>
-          </a:bodyPr>
-          <a:lstStyle/>
-          <a:p>
-            <a:pPr algn="l">
-              <a:lnSpc>
-                <a:spcPts val="25180"/>
-              </a:lnSpc>
-            </a:pPr>
-            <a:r>
-              <a:rPr lang="en-US" b="true" sz="20000">
-                <a:solidFill>
-                  <a:srgbClr val="FFFFFF"/>
-                </a:solidFill>
-                <a:latin typeface="Montserrat Bold"/>
-                <a:ea typeface="Montserrat Bold"/>
-                <a:cs typeface="Montserrat Bold"/>
-                <a:sym typeface="Montserrat Bold"/>
-              </a:rPr>
-              <a:t>Obrigado!</a:t>
-            </a:r>
-          </a:p>
-        </p:txBody>
       </p:sp>
+      <p:grpSp>
+        <p:nvGrpSpPr>
+          <p:cNvPr name="Group 3" id="3"/>
+          <p:cNvGrpSpPr/>
+          <p:nvPr/>
+        </p:nvGrpSpPr>
+        <p:grpSpPr>
+          <a:xfrm rot="0">
+            <a:off x="775490" y="5442906"/>
+            <a:ext cx="16960349" cy="3086100"/>
+            <a:chOff x="0" y="0"/>
+            <a:chExt cx="4466923" cy="812800"/>
+          </a:xfrm>
+        </p:grpSpPr>
+        <p:sp>
+          <p:nvSpPr>
+            <p:cNvPr name="Freeform 4" id="4"/>
+            <p:cNvSpPr/>
+            <p:nvPr/>
+          </p:nvSpPr>
+          <p:spPr>
+            <a:xfrm flipH="false" flipV="false" rot="0">
+              <a:off x="0" y="0"/>
+              <a:ext cx="4466923" cy="812800"/>
+            </a:xfrm>
+            <a:custGeom>
+              <a:avLst/>
+              <a:gdLst/>
+              <a:ahLst/>
+              <a:cxnLst/>
+              <a:rect r="r" b="b" t="t" l="l"/>
+              <a:pathLst>
+                <a:path h="812800" w="4466923">
+                  <a:moveTo>
+                    <a:pt x="7760" y="0"/>
+                  </a:moveTo>
+                  <a:lnTo>
+                    <a:pt x="4459163" y="0"/>
+                  </a:lnTo>
+                  <a:cubicBezTo>
+                    <a:pt x="4461221" y="0"/>
+                    <a:pt x="4463195" y="818"/>
+                    <a:pt x="4464650" y="2273"/>
+                  </a:cubicBezTo>
+                  <a:cubicBezTo>
+                    <a:pt x="4466106" y="3728"/>
+                    <a:pt x="4466923" y="5702"/>
+                    <a:pt x="4466923" y="7760"/>
+                  </a:cubicBezTo>
+                  <a:lnTo>
+                    <a:pt x="4466923" y="805040"/>
+                  </a:lnTo>
+                  <a:cubicBezTo>
+                    <a:pt x="4466923" y="807098"/>
+                    <a:pt x="4466106" y="809072"/>
+                    <a:pt x="4464650" y="810527"/>
+                  </a:cubicBezTo>
+                  <a:cubicBezTo>
+                    <a:pt x="4463195" y="811982"/>
+                    <a:pt x="4461221" y="812800"/>
+                    <a:pt x="4459163" y="812800"/>
+                  </a:cubicBezTo>
+                  <a:lnTo>
+                    <a:pt x="7760" y="812800"/>
+                  </a:lnTo>
+                  <a:cubicBezTo>
+                    <a:pt x="5702" y="812800"/>
+                    <a:pt x="3728" y="811982"/>
+                    <a:pt x="2273" y="810527"/>
+                  </a:cubicBezTo>
+                  <a:cubicBezTo>
+                    <a:pt x="818" y="809072"/>
+                    <a:pt x="0" y="807098"/>
+                    <a:pt x="0" y="805040"/>
+                  </a:cubicBezTo>
+                  <a:lnTo>
+                    <a:pt x="0" y="7760"/>
+                  </a:lnTo>
+                  <a:cubicBezTo>
+                    <a:pt x="0" y="5702"/>
+                    <a:pt x="818" y="3728"/>
+                    <a:pt x="2273" y="2273"/>
+                  </a:cubicBezTo>
+                  <a:cubicBezTo>
+                    <a:pt x="3728" y="818"/>
+                    <a:pt x="5702" y="0"/>
+                    <a:pt x="7760" y="0"/>
+                  </a:cubicBezTo>
+                  <a:close/>
+                </a:path>
+              </a:pathLst>
+            </a:custGeom>
+            <a:solidFill>
+              <a:srgbClr val="233D89"/>
+            </a:solidFill>
+          </p:spPr>
+        </p:sp>
+        <p:sp>
+          <p:nvSpPr>
+            <p:cNvPr name="TextBox 5" id="5"/>
+            <p:cNvSpPr txBox="true"/>
+            <p:nvPr/>
+          </p:nvSpPr>
+          <p:spPr>
+            <a:xfrm>
+              <a:off x="0" y="-38100"/>
+              <a:ext cx="4466923" cy="850900"/>
+            </a:xfrm>
+            <a:prstGeom prst="rect">
+              <a:avLst/>
+            </a:prstGeom>
+          </p:spPr>
+          <p:txBody>
+            <a:bodyPr anchor="ctr" rtlCol="false" tIns="50800" lIns="50800" bIns="50800" rIns="50800"/>
+            <a:lstStyle/>
+            <a:p>
+              <a:pPr algn="ctr">
+                <a:lnSpc>
+                  <a:spcPts val="3449"/>
+                </a:lnSpc>
+              </a:pPr>
+            </a:p>
+          </p:txBody>
+        </p:sp>
+      </p:grpSp>
+      <p:grpSp>
+        <p:nvGrpSpPr>
+          <p:cNvPr name="Group 6" id="6"/>
+          <p:cNvGrpSpPr/>
+          <p:nvPr/>
+        </p:nvGrpSpPr>
+        <p:grpSpPr>
+          <a:xfrm rot="0">
+            <a:off x="11410345" y="4606495"/>
+            <a:ext cx="5612497" cy="3086100"/>
+            <a:chOff x="0" y="0"/>
+            <a:chExt cx="1478189" cy="812800"/>
+          </a:xfrm>
+        </p:grpSpPr>
+        <p:sp>
+          <p:nvSpPr>
+            <p:cNvPr name="Freeform 7" id="7"/>
+            <p:cNvSpPr/>
+            <p:nvPr/>
+          </p:nvSpPr>
+          <p:spPr>
+            <a:xfrm flipH="false" flipV="false" rot="0">
+              <a:off x="0" y="0"/>
+              <a:ext cx="1478189" cy="812800"/>
+            </a:xfrm>
+            <a:custGeom>
+              <a:avLst/>
+              <a:gdLst/>
+              <a:ahLst/>
+              <a:cxnLst/>
+              <a:rect r="r" b="b" t="t" l="l"/>
+              <a:pathLst>
+                <a:path h="812800" w="1478189">
+                  <a:moveTo>
+                    <a:pt x="23450" y="0"/>
+                  </a:moveTo>
+                  <a:lnTo>
+                    <a:pt x="1454739" y="0"/>
+                  </a:lnTo>
+                  <a:cubicBezTo>
+                    <a:pt x="1460958" y="0"/>
+                    <a:pt x="1466923" y="2471"/>
+                    <a:pt x="1471320" y="6868"/>
+                  </a:cubicBezTo>
+                  <a:cubicBezTo>
+                    <a:pt x="1475718" y="11266"/>
+                    <a:pt x="1478189" y="17231"/>
+                    <a:pt x="1478189" y="23450"/>
+                  </a:cubicBezTo>
+                  <a:lnTo>
+                    <a:pt x="1478189" y="789350"/>
+                  </a:lnTo>
+                  <a:cubicBezTo>
+                    <a:pt x="1478189" y="795569"/>
+                    <a:pt x="1475718" y="801534"/>
+                    <a:pt x="1471320" y="805932"/>
+                  </a:cubicBezTo>
+                  <a:cubicBezTo>
+                    <a:pt x="1466923" y="810329"/>
+                    <a:pt x="1460958" y="812800"/>
+                    <a:pt x="1454739" y="812800"/>
+                  </a:cubicBezTo>
+                  <a:lnTo>
+                    <a:pt x="23450" y="812800"/>
+                  </a:lnTo>
+                  <a:cubicBezTo>
+                    <a:pt x="17231" y="812800"/>
+                    <a:pt x="11266" y="810329"/>
+                    <a:pt x="6868" y="805932"/>
+                  </a:cubicBezTo>
+                  <a:cubicBezTo>
+                    <a:pt x="2471" y="801534"/>
+                    <a:pt x="0" y="795569"/>
+                    <a:pt x="0" y="789350"/>
+                  </a:cubicBezTo>
+                  <a:lnTo>
+                    <a:pt x="0" y="23450"/>
+                  </a:lnTo>
+                  <a:cubicBezTo>
+                    <a:pt x="0" y="17231"/>
+                    <a:pt x="2471" y="11266"/>
+                    <a:pt x="6868" y="6868"/>
+                  </a:cubicBezTo>
+                  <a:cubicBezTo>
+                    <a:pt x="11266" y="2471"/>
+                    <a:pt x="17231" y="0"/>
+                    <a:pt x="23450" y="0"/>
+                  </a:cubicBezTo>
+                  <a:close/>
+                </a:path>
+              </a:pathLst>
+            </a:custGeom>
+            <a:solidFill>
+              <a:srgbClr val="233D89"/>
+            </a:solidFill>
+          </p:spPr>
+        </p:sp>
+        <p:sp>
+          <p:nvSpPr>
+            <p:cNvPr name="TextBox 8" id="8"/>
+            <p:cNvSpPr txBox="true"/>
+            <p:nvPr/>
+          </p:nvSpPr>
+          <p:spPr>
+            <a:xfrm>
+              <a:off x="0" y="-38100"/>
+              <a:ext cx="1478189" cy="850900"/>
+            </a:xfrm>
+            <a:prstGeom prst="rect">
+              <a:avLst/>
+            </a:prstGeom>
+          </p:spPr>
+          <p:txBody>
+            <a:bodyPr anchor="ctr" rtlCol="false" tIns="50800" lIns="50800" bIns="50800" rIns="50800"/>
+            <a:lstStyle/>
+            <a:p>
+              <a:pPr algn="ctr">
+                <a:lnSpc>
+                  <a:spcPts val="3449"/>
+                </a:lnSpc>
+              </a:pPr>
+            </a:p>
+          </p:txBody>
+        </p:sp>
+      </p:grpSp>
+    </p:spTree>
+  </p:cSld>
+  <p:clrMapOvr>
+    <a:masterClrMapping/>
+  </p:clrMapOvr>
+</p:sld>
+</file>
+
+<file path=ppt/slides/slide27.xml><?xml version="1.0" encoding="utf-8"?>
+<p:sld xmlns:p="http://schemas.openxmlformats.org/presentationml/2006/main" xmlns:a="http://schemas.openxmlformats.org/drawingml/2006/main" xmlns:r="http://schemas.openxmlformats.org/officeDocument/2006/relationships">
+  <p:cSld>
+    <p:bg>
+      <p:bgPr>
+        <a:solidFill>
+          <a:srgbClr val="233D89"/>
+        </a:solidFill>
+      </p:bgPr>
+    </p:bg>
+    <p:spTree>
+      <p:nvGrpSpPr>
+        <p:cNvPr id="1" name=""/>
+        <p:cNvGrpSpPr/>
+        <p:nvPr/>
+      </p:nvGrpSpPr>
+      <p:grpSpPr>
+        <a:xfrm>
+          <a:off x="0" y="0"/>
+          <a:ext cx="0" cy="0"/>
+          <a:chOff x="0" y="0"/>
+          <a:chExt cx="0" cy="0"/>
+        </a:xfrm>
+      </p:grpSpPr>
+      <p:sp>
+        <p:nvSpPr>
+          <p:cNvPr name="Freeform 2" id="2"/>
+          <p:cNvSpPr/>
+          <p:nvPr/>
+        </p:nvSpPr>
+        <p:spPr>
+          <a:xfrm flipH="false" flipV="false" rot="0">
+            <a:off x="266228" y="2227353"/>
+            <a:ext cx="17755545" cy="5149108"/>
+          </a:xfrm>
+          <a:custGeom>
+            <a:avLst/>
+            <a:gdLst/>
+            <a:ahLst/>
+            <a:cxnLst/>
+            <a:rect r="r" b="b" t="t" l="l"/>
+            <a:pathLst>
+              <a:path h="5149108" w="17755545">
+                <a:moveTo>
+                  <a:pt x="0" y="0"/>
+                </a:moveTo>
+                <a:lnTo>
+                  <a:pt x="17755544" y="0"/>
+                </a:lnTo>
+                <a:lnTo>
+                  <a:pt x="17755544" y="5149108"/>
+                </a:lnTo>
+                <a:lnTo>
+                  <a:pt x="0" y="5149108"/>
+                </a:lnTo>
+                <a:lnTo>
+                  <a:pt x="0" y="0"/>
+                </a:lnTo>
+                <a:close/>
+              </a:path>
+            </a:pathLst>
+          </a:custGeom>
+          <a:blipFill>
+            <a:blip r:embed="rId2"/>
+            <a:stretch>
+              <a:fillRect l="0" t="0" r="0" b="0"/>
+            </a:stretch>
+          </a:blipFill>
+        </p:spPr>
+      </p:sp>
+      <p:grpSp>
+        <p:nvGrpSpPr>
+          <p:cNvPr name="Group 3" id="3"/>
+          <p:cNvGrpSpPr/>
+          <p:nvPr/>
+        </p:nvGrpSpPr>
+        <p:grpSpPr>
+          <a:xfrm rot="0">
+            <a:off x="775490" y="5442906"/>
+            <a:ext cx="16960349" cy="3086100"/>
+            <a:chOff x="0" y="0"/>
+            <a:chExt cx="4466923" cy="812800"/>
+          </a:xfrm>
+        </p:grpSpPr>
+        <p:sp>
+          <p:nvSpPr>
+            <p:cNvPr name="Freeform 4" id="4"/>
+            <p:cNvSpPr/>
+            <p:nvPr/>
+          </p:nvSpPr>
+          <p:spPr>
+            <a:xfrm flipH="false" flipV="false" rot="0">
+              <a:off x="0" y="0"/>
+              <a:ext cx="4466923" cy="812800"/>
+            </a:xfrm>
+            <a:custGeom>
+              <a:avLst/>
+              <a:gdLst/>
+              <a:ahLst/>
+              <a:cxnLst/>
+              <a:rect r="r" b="b" t="t" l="l"/>
+              <a:pathLst>
+                <a:path h="812800" w="4466923">
+                  <a:moveTo>
+                    <a:pt x="7760" y="0"/>
+                  </a:moveTo>
+                  <a:lnTo>
+                    <a:pt x="4459163" y="0"/>
+                  </a:lnTo>
+                  <a:cubicBezTo>
+                    <a:pt x="4461221" y="0"/>
+                    <a:pt x="4463195" y="818"/>
+                    <a:pt x="4464650" y="2273"/>
+                  </a:cubicBezTo>
+                  <a:cubicBezTo>
+                    <a:pt x="4466106" y="3728"/>
+                    <a:pt x="4466923" y="5702"/>
+                    <a:pt x="4466923" y="7760"/>
+                  </a:cubicBezTo>
+                  <a:lnTo>
+                    <a:pt x="4466923" y="805040"/>
+                  </a:lnTo>
+                  <a:cubicBezTo>
+                    <a:pt x="4466923" y="807098"/>
+                    <a:pt x="4466106" y="809072"/>
+                    <a:pt x="4464650" y="810527"/>
+                  </a:cubicBezTo>
+                  <a:cubicBezTo>
+                    <a:pt x="4463195" y="811982"/>
+                    <a:pt x="4461221" y="812800"/>
+                    <a:pt x="4459163" y="812800"/>
+                  </a:cubicBezTo>
+                  <a:lnTo>
+                    <a:pt x="7760" y="812800"/>
+                  </a:lnTo>
+                  <a:cubicBezTo>
+                    <a:pt x="5702" y="812800"/>
+                    <a:pt x="3728" y="811982"/>
+                    <a:pt x="2273" y="810527"/>
+                  </a:cubicBezTo>
+                  <a:cubicBezTo>
+                    <a:pt x="818" y="809072"/>
+                    <a:pt x="0" y="807098"/>
+                    <a:pt x="0" y="805040"/>
+                  </a:cubicBezTo>
+                  <a:lnTo>
+                    <a:pt x="0" y="7760"/>
+                  </a:lnTo>
+                  <a:cubicBezTo>
+                    <a:pt x="0" y="5702"/>
+                    <a:pt x="818" y="3728"/>
+                    <a:pt x="2273" y="2273"/>
+                  </a:cubicBezTo>
+                  <a:cubicBezTo>
+                    <a:pt x="3728" y="818"/>
+                    <a:pt x="5702" y="0"/>
+                    <a:pt x="7760" y="0"/>
+                  </a:cubicBezTo>
+                  <a:close/>
+                </a:path>
+              </a:pathLst>
+            </a:custGeom>
+            <a:solidFill>
+              <a:srgbClr val="233D89"/>
+            </a:solidFill>
+          </p:spPr>
+        </p:sp>
+        <p:sp>
+          <p:nvSpPr>
+            <p:cNvPr name="TextBox 5" id="5"/>
+            <p:cNvSpPr txBox="true"/>
+            <p:nvPr/>
+          </p:nvSpPr>
+          <p:spPr>
+            <a:xfrm>
+              <a:off x="0" y="-38100"/>
+              <a:ext cx="4466923" cy="850900"/>
+            </a:xfrm>
+            <a:prstGeom prst="rect">
+              <a:avLst/>
+            </a:prstGeom>
+          </p:spPr>
+          <p:txBody>
+            <a:bodyPr anchor="ctr" rtlCol="false" tIns="50800" lIns="50800" bIns="50800" rIns="50800"/>
+            <a:lstStyle/>
+            <a:p>
+              <a:pPr algn="ctr">
+                <a:lnSpc>
+                  <a:spcPts val="3449"/>
+                </a:lnSpc>
+              </a:pPr>
+            </a:p>
+          </p:txBody>
+        </p:sp>
+      </p:grpSp>
+    </p:spTree>
+  </p:cSld>
+  <p:clrMapOvr>
+    <a:masterClrMapping/>
+  </p:clrMapOvr>
+</p:sld>
+</file>
+
+<file path=ppt/slides/slide28.xml><?xml version="1.0" encoding="utf-8"?>
+<p:sld xmlns:p="http://schemas.openxmlformats.org/presentationml/2006/main" xmlns:a="http://schemas.openxmlformats.org/drawingml/2006/main" xmlns:r="http://schemas.openxmlformats.org/officeDocument/2006/relationships">
+  <p:cSld>
+    <p:bg>
+      <p:bgPr>
+        <a:solidFill>
+          <a:srgbClr val="233D89"/>
+        </a:solidFill>
+      </p:bgPr>
+    </p:bg>
+    <p:spTree>
+      <p:nvGrpSpPr>
+        <p:cNvPr id="1" name=""/>
+        <p:cNvGrpSpPr/>
+        <p:nvPr/>
+      </p:nvGrpSpPr>
+      <p:grpSpPr>
+        <a:xfrm>
+          <a:off x="0" y="0"/>
+          <a:ext cx="0" cy="0"/>
+          <a:chOff x="0" y="0"/>
+          <a:chExt cx="0" cy="0"/>
+        </a:xfrm>
+      </p:grpSpPr>
+      <p:sp>
+        <p:nvSpPr>
+          <p:cNvPr name="Freeform 2" id="2"/>
+          <p:cNvSpPr/>
+          <p:nvPr/>
+        </p:nvSpPr>
+        <p:spPr>
+          <a:xfrm flipH="false" flipV="false" rot="0">
+            <a:off x="266228" y="2227353"/>
+            <a:ext cx="17755545" cy="5149108"/>
+          </a:xfrm>
+          <a:custGeom>
+            <a:avLst/>
+            <a:gdLst/>
+            <a:ahLst/>
+            <a:cxnLst/>
+            <a:rect r="r" b="b" t="t" l="l"/>
+            <a:pathLst>
+              <a:path h="5149108" w="17755545">
+                <a:moveTo>
+                  <a:pt x="0" y="0"/>
+                </a:moveTo>
+                <a:lnTo>
+                  <a:pt x="17755544" y="0"/>
+                </a:lnTo>
+                <a:lnTo>
+                  <a:pt x="17755544" y="5149108"/>
+                </a:lnTo>
+                <a:lnTo>
+                  <a:pt x="0" y="5149108"/>
+                </a:lnTo>
+                <a:lnTo>
+                  <a:pt x="0" y="0"/>
+                </a:lnTo>
+                <a:close/>
+              </a:path>
+            </a:pathLst>
+          </a:custGeom>
+          <a:blipFill>
+            <a:blip r:embed="rId2"/>
+            <a:stretch>
+              <a:fillRect l="0" t="0" r="0" b="0"/>
+            </a:stretch>
+          </a:blipFill>
+        </p:spPr>
+      </p:sp>
+      <p:grpSp>
+        <p:nvGrpSpPr>
+          <p:cNvPr name="Group 3" id="3"/>
+          <p:cNvGrpSpPr/>
+          <p:nvPr/>
+        </p:nvGrpSpPr>
+        <p:grpSpPr>
+          <a:xfrm rot="0">
+            <a:off x="621952" y="6126847"/>
+            <a:ext cx="5905615" cy="1425098"/>
+            <a:chOff x="0" y="0"/>
+            <a:chExt cx="1555388" cy="375335"/>
+          </a:xfrm>
+        </p:grpSpPr>
+        <p:sp>
+          <p:nvSpPr>
+            <p:cNvPr name="Freeform 4" id="4"/>
+            <p:cNvSpPr/>
+            <p:nvPr/>
+          </p:nvSpPr>
+          <p:spPr>
+            <a:xfrm flipH="false" flipV="false" rot="0">
+              <a:off x="0" y="0"/>
+              <a:ext cx="1555388" cy="375335"/>
+            </a:xfrm>
+            <a:custGeom>
+              <a:avLst/>
+              <a:gdLst/>
+              <a:ahLst/>
+              <a:cxnLst/>
+              <a:rect r="r" b="b" t="t" l="l"/>
+              <a:pathLst>
+                <a:path h="375335" w="1555388">
+                  <a:moveTo>
+                    <a:pt x="22286" y="0"/>
+                  </a:moveTo>
+                  <a:lnTo>
+                    <a:pt x="1533102" y="0"/>
+                  </a:lnTo>
+                  <a:cubicBezTo>
+                    <a:pt x="1539013" y="0"/>
+                    <a:pt x="1544682" y="2348"/>
+                    <a:pt x="1548861" y="6527"/>
+                  </a:cubicBezTo>
+                  <a:cubicBezTo>
+                    <a:pt x="1553040" y="10707"/>
+                    <a:pt x="1555388" y="16375"/>
+                    <a:pt x="1555388" y="22286"/>
+                  </a:cubicBezTo>
+                  <a:lnTo>
+                    <a:pt x="1555388" y="353049"/>
+                  </a:lnTo>
+                  <a:cubicBezTo>
+                    <a:pt x="1555388" y="365357"/>
+                    <a:pt x="1545411" y="375335"/>
+                    <a:pt x="1533102" y="375335"/>
+                  </a:cubicBezTo>
+                  <a:lnTo>
+                    <a:pt x="22286" y="375335"/>
+                  </a:lnTo>
+                  <a:cubicBezTo>
+                    <a:pt x="16375" y="375335"/>
+                    <a:pt x="10707" y="372987"/>
+                    <a:pt x="6527" y="368807"/>
+                  </a:cubicBezTo>
+                  <a:cubicBezTo>
+                    <a:pt x="2348" y="364628"/>
+                    <a:pt x="0" y="358959"/>
+                    <a:pt x="0" y="353049"/>
+                  </a:cubicBezTo>
+                  <a:lnTo>
+                    <a:pt x="0" y="22286"/>
+                  </a:lnTo>
+                  <a:cubicBezTo>
+                    <a:pt x="0" y="9978"/>
+                    <a:pt x="9978" y="0"/>
+                    <a:pt x="22286" y="0"/>
+                  </a:cubicBezTo>
+                  <a:close/>
+                </a:path>
+              </a:pathLst>
+            </a:custGeom>
+            <a:solidFill>
+              <a:srgbClr val="233D89"/>
+            </a:solidFill>
+          </p:spPr>
+        </p:sp>
+        <p:sp>
+          <p:nvSpPr>
+            <p:cNvPr name="TextBox 5" id="5"/>
+            <p:cNvSpPr txBox="true"/>
+            <p:nvPr/>
+          </p:nvSpPr>
+          <p:spPr>
+            <a:xfrm>
+              <a:off x="0" y="-38100"/>
+              <a:ext cx="1555388" cy="413435"/>
+            </a:xfrm>
+            <a:prstGeom prst="rect">
+              <a:avLst/>
+            </a:prstGeom>
+          </p:spPr>
+          <p:txBody>
+            <a:bodyPr anchor="ctr" rtlCol="false" tIns="50800" lIns="50800" bIns="50800" rIns="50800"/>
+            <a:lstStyle/>
+            <a:p>
+              <a:pPr algn="ctr">
+                <a:lnSpc>
+                  <a:spcPts val="3449"/>
+                </a:lnSpc>
+              </a:pPr>
+            </a:p>
+          </p:txBody>
+        </p:sp>
+      </p:grpSp>
+      <p:grpSp>
+        <p:nvGrpSpPr>
+          <p:cNvPr name="Group 6" id="6"/>
+          <p:cNvGrpSpPr/>
+          <p:nvPr/>
+        </p:nvGrpSpPr>
+        <p:grpSpPr>
+          <a:xfrm rot="0">
+            <a:off x="6441298" y="5246356"/>
+            <a:ext cx="10400090" cy="1425098"/>
+            <a:chOff x="0" y="0"/>
+            <a:chExt cx="2739118" cy="375335"/>
+          </a:xfrm>
+        </p:grpSpPr>
+        <p:sp>
+          <p:nvSpPr>
+            <p:cNvPr name="Freeform 7" id="7"/>
+            <p:cNvSpPr/>
+            <p:nvPr/>
+          </p:nvSpPr>
+          <p:spPr>
+            <a:xfrm flipH="false" flipV="false" rot="0">
+              <a:off x="0" y="0"/>
+              <a:ext cx="2739118" cy="375335"/>
+            </a:xfrm>
+            <a:custGeom>
+              <a:avLst/>
+              <a:gdLst/>
+              <a:ahLst/>
+              <a:cxnLst/>
+              <a:rect r="r" b="b" t="t" l="l"/>
+              <a:pathLst>
+                <a:path h="375335" w="2739118">
+                  <a:moveTo>
+                    <a:pt x="12655" y="0"/>
+                  </a:moveTo>
+                  <a:lnTo>
+                    <a:pt x="2726463" y="0"/>
+                  </a:lnTo>
+                  <a:cubicBezTo>
+                    <a:pt x="2733453" y="0"/>
+                    <a:pt x="2739118" y="5666"/>
+                    <a:pt x="2739118" y="12655"/>
+                  </a:cubicBezTo>
+                  <a:lnTo>
+                    <a:pt x="2739118" y="362680"/>
+                  </a:lnTo>
+                  <a:cubicBezTo>
+                    <a:pt x="2739118" y="366036"/>
+                    <a:pt x="2737785" y="369255"/>
+                    <a:pt x="2735412" y="371628"/>
+                  </a:cubicBezTo>
+                  <a:cubicBezTo>
+                    <a:pt x="2733039" y="374001"/>
+                    <a:pt x="2729820" y="375335"/>
+                    <a:pt x="2726463" y="375335"/>
+                  </a:cubicBezTo>
+                  <a:lnTo>
+                    <a:pt x="12655" y="375335"/>
+                  </a:lnTo>
+                  <a:cubicBezTo>
+                    <a:pt x="9299" y="375335"/>
+                    <a:pt x="6080" y="374001"/>
+                    <a:pt x="3707" y="371628"/>
+                  </a:cubicBezTo>
+                  <a:cubicBezTo>
+                    <a:pt x="1333" y="369255"/>
+                    <a:pt x="0" y="366036"/>
+                    <a:pt x="0" y="362680"/>
+                  </a:cubicBezTo>
+                  <a:lnTo>
+                    <a:pt x="0" y="12655"/>
+                  </a:lnTo>
+                  <a:cubicBezTo>
+                    <a:pt x="0" y="9299"/>
+                    <a:pt x="1333" y="6080"/>
+                    <a:pt x="3707" y="3707"/>
+                  </a:cubicBezTo>
+                  <a:cubicBezTo>
+                    <a:pt x="6080" y="1333"/>
+                    <a:pt x="9299" y="0"/>
+                    <a:pt x="12655" y="0"/>
+                  </a:cubicBezTo>
+                  <a:close/>
+                </a:path>
+              </a:pathLst>
+            </a:custGeom>
+            <a:solidFill>
+              <a:srgbClr val="233D89"/>
+            </a:solidFill>
+          </p:spPr>
+        </p:sp>
+        <p:sp>
+          <p:nvSpPr>
+            <p:cNvPr name="TextBox 8" id="8"/>
+            <p:cNvSpPr txBox="true"/>
+            <p:nvPr/>
+          </p:nvSpPr>
+          <p:spPr>
+            <a:xfrm>
+              <a:off x="0" y="-38100"/>
+              <a:ext cx="2739118" cy="413435"/>
+            </a:xfrm>
+            <a:prstGeom prst="rect">
+              <a:avLst/>
+            </a:prstGeom>
+          </p:spPr>
+          <p:txBody>
+            <a:bodyPr anchor="ctr" rtlCol="false" tIns="50800" lIns="50800" bIns="50800" rIns="50800"/>
+            <a:lstStyle/>
+            <a:p>
+              <a:pPr algn="ctr">
+                <a:lnSpc>
+                  <a:spcPts val="3449"/>
+                </a:lnSpc>
+              </a:pPr>
+            </a:p>
+          </p:txBody>
+        </p:sp>
+      </p:grpSp>
+    </p:spTree>
+  </p:cSld>
+  <p:clrMapOvr>
+    <a:masterClrMapping/>
+  </p:clrMapOvr>
+</p:sld>
+</file>
+
+<file path=ppt/slides/slide29.xml><?xml version="1.0" encoding="utf-8"?>
+<p:sld xmlns:p="http://schemas.openxmlformats.org/presentationml/2006/main" xmlns:a="http://schemas.openxmlformats.org/drawingml/2006/main" xmlns:r="http://schemas.openxmlformats.org/officeDocument/2006/relationships">
+  <p:cSld>
+    <p:bg>
+      <p:bgPr>
+        <a:solidFill>
+          <a:srgbClr val="233D89"/>
+        </a:solidFill>
+      </p:bgPr>
+    </p:bg>
+    <p:spTree>
+      <p:nvGrpSpPr>
+        <p:cNvPr id="1" name=""/>
+        <p:cNvGrpSpPr/>
+        <p:nvPr/>
+      </p:nvGrpSpPr>
+      <p:grpSpPr>
+        <a:xfrm>
+          <a:off x="0" y="0"/>
+          <a:ext cx="0" cy="0"/>
+          <a:chOff x="0" y="0"/>
+          <a:chExt cx="0" cy="0"/>
+        </a:xfrm>
+      </p:grpSpPr>
+      <p:sp>
+        <p:nvSpPr>
+          <p:cNvPr name="Freeform 2" id="2"/>
+          <p:cNvSpPr/>
+          <p:nvPr/>
+        </p:nvSpPr>
+        <p:spPr>
+          <a:xfrm flipH="false" flipV="false" rot="0">
+            <a:off x="266228" y="2227353"/>
+            <a:ext cx="17755545" cy="5149108"/>
+          </a:xfrm>
+          <a:custGeom>
+            <a:avLst/>
+            <a:gdLst/>
+            <a:ahLst/>
+            <a:cxnLst/>
+            <a:rect r="r" b="b" t="t" l="l"/>
+            <a:pathLst>
+              <a:path h="5149108" w="17755545">
+                <a:moveTo>
+                  <a:pt x="0" y="0"/>
+                </a:moveTo>
+                <a:lnTo>
+                  <a:pt x="17755544" y="0"/>
+                </a:lnTo>
+                <a:lnTo>
+                  <a:pt x="17755544" y="5149108"/>
+                </a:lnTo>
+                <a:lnTo>
+                  <a:pt x="0" y="5149108"/>
+                </a:lnTo>
+                <a:lnTo>
+                  <a:pt x="0" y="0"/>
+                </a:lnTo>
+                <a:close/>
+              </a:path>
+            </a:pathLst>
+          </a:custGeom>
+          <a:blipFill>
+            <a:blip r:embed="rId2"/>
+            <a:stretch>
+              <a:fillRect l="0" t="0" r="0" b="0"/>
+            </a:stretch>
+          </a:blipFill>
+        </p:spPr>
+      </p:sp>
+      <p:grpSp>
+        <p:nvGrpSpPr>
+          <p:cNvPr name="Group 3" id="3"/>
+          <p:cNvGrpSpPr/>
+          <p:nvPr/>
+        </p:nvGrpSpPr>
+        <p:grpSpPr>
+          <a:xfrm rot="0">
+            <a:off x="621952" y="6126847"/>
+            <a:ext cx="5905615" cy="1425098"/>
+            <a:chOff x="0" y="0"/>
+            <a:chExt cx="1555388" cy="375335"/>
+          </a:xfrm>
+        </p:grpSpPr>
+        <p:sp>
+          <p:nvSpPr>
+            <p:cNvPr name="Freeform 4" id="4"/>
+            <p:cNvSpPr/>
+            <p:nvPr/>
+          </p:nvSpPr>
+          <p:spPr>
+            <a:xfrm flipH="false" flipV="false" rot="0">
+              <a:off x="0" y="0"/>
+              <a:ext cx="1555388" cy="375335"/>
+            </a:xfrm>
+            <a:custGeom>
+              <a:avLst/>
+              <a:gdLst/>
+              <a:ahLst/>
+              <a:cxnLst/>
+              <a:rect r="r" b="b" t="t" l="l"/>
+              <a:pathLst>
+                <a:path h="375335" w="1555388">
+                  <a:moveTo>
+                    <a:pt x="22286" y="0"/>
+                  </a:moveTo>
+                  <a:lnTo>
+                    <a:pt x="1533102" y="0"/>
+                  </a:lnTo>
+                  <a:cubicBezTo>
+                    <a:pt x="1539013" y="0"/>
+                    <a:pt x="1544682" y="2348"/>
+                    <a:pt x="1548861" y="6527"/>
+                  </a:cubicBezTo>
+                  <a:cubicBezTo>
+                    <a:pt x="1553040" y="10707"/>
+                    <a:pt x="1555388" y="16375"/>
+                    <a:pt x="1555388" y="22286"/>
+                  </a:cubicBezTo>
+                  <a:lnTo>
+                    <a:pt x="1555388" y="353049"/>
+                  </a:lnTo>
+                  <a:cubicBezTo>
+                    <a:pt x="1555388" y="365357"/>
+                    <a:pt x="1545411" y="375335"/>
+                    <a:pt x="1533102" y="375335"/>
+                  </a:cubicBezTo>
+                  <a:lnTo>
+                    <a:pt x="22286" y="375335"/>
+                  </a:lnTo>
+                  <a:cubicBezTo>
+                    <a:pt x="16375" y="375335"/>
+                    <a:pt x="10707" y="372987"/>
+                    <a:pt x="6527" y="368807"/>
+                  </a:cubicBezTo>
+                  <a:cubicBezTo>
+                    <a:pt x="2348" y="364628"/>
+                    <a:pt x="0" y="358959"/>
+                    <a:pt x="0" y="353049"/>
+                  </a:cubicBezTo>
+                  <a:lnTo>
+                    <a:pt x="0" y="22286"/>
+                  </a:lnTo>
+                  <a:cubicBezTo>
+                    <a:pt x="0" y="9978"/>
+                    <a:pt x="9978" y="0"/>
+                    <a:pt x="22286" y="0"/>
+                  </a:cubicBezTo>
+                  <a:close/>
+                </a:path>
+              </a:pathLst>
+            </a:custGeom>
+            <a:solidFill>
+              <a:srgbClr val="233D89"/>
+            </a:solidFill>
+          </p:spPr>
+        </p:sp>
+        <p:sp>
+          <p:nvSpPr>
+            <p:cNvPr name="TextBox 5" id="5"/>
+            <p:cNvSpPr txBox="true"/>
+            <p:nvPr/>
+          </p:nvSpPr>
+          <p:spPr>
+            <a:xfrm>
+              <a:off x="0" y="-38100"/>
+              <a:ext cx="1555388" cy="413435"/>
+            </a:xfrm>
+            <a:prstGeom prst="rect">
+              <a:avLst/>
+            </a:prstGeom>
+          </p:spPr>
+          <p:txBody>
+            <a:bodyPr anchor="ctr" rtlCol="false" tIns="50800" lIns="50800" bIns="50800" rIns="50800"/>
+            <a:lstStyle/>
+            <a:p>
+              <a:pPr algn="ctr">
+                <a:lnSpc>
+                  <a:spcPts val="3449"/>
+                </a:lnSpc>
+              </a:pPr>
+            </a:p>
+          </p:txBody>
+        </p:sp>
+      </p:grpSp>
+      <p:grpSp>
+        <p:nvGrpSpPr>
+          <p:cNvPr name="Group 6" id="6"/>
+          <p:cNvGrpSpPr/>
+          <p:nvPr/>
+        </p:nvGrpSpPr>
+        <p:grpSpPr>
+          <a:xfrm rot="0">
+            <a:off x="12261783" y="5246356"/>
+            <a:ext cx="4579606" cy="1425098"/>
+            <a:chOff x="0" y="0"/>
+            <a:chExt cx="1206151" cy="375335"/>
+          </a:xfrm>
+        </p:grpSpPr>
+        <p:sp>
+          <p:nvSpPr>
+            <p:cNvPr name="Freeform 7" id="7"/>
+            <p:cNvSpPr/>
+            <p:nvPr/>
+          </p:nvSpPr>
+          <p:spPr>
+            <a:xfrm flipH="false" flipV="false" rot="0">
+              <a:off x="0" y="0"/>
+              <a:ext cx="1206151" cy="375335"/>
+            </a:xfrm>
+            <a:custGeom>
+              <a:avLst/>
+              <a:gdLst/>
+              <a:ahLst/>
+              <a:cxnLst/>
+              <a:rect r="r" b="b" t="t" l="l"/>
+              <a:pathLst>
+                <a:path h="375335" w="1206151">
+                  <a:moveTo>
+                    <a:pt x="28739" y="0"/>
+                  </a:moveTo>
+                  <a:lnTo>
+                    <a:pt x="1177412" y="0"/>
+                  </a:lnTo>
+                  <a:cubicBezTo>
+                    <a:pt x="1193284" y="0"/>
+                    <a:pt x="1206151" y="12867"/>
+                    <a:pt x="1206151" y="28739"/>
+                  </a:cubicBezTo>
+                  <a:lnTo>
+                    <a:pt x="1206151" y="346596"/>
+                  </a:lnTo>
+                  <a:cubicBezTo>
+                    <a:pt x="1206151" y="362468"/>
+                    <a:pt x="1193284" y="375335"/>
+                    <a:pt x="1177412" y="375335"/>
+                  </a:cubicBezTo>
+                  <a:lnTo>
+                    <a:pt x="28739" y="375335"/>
+                  </a:lnTo>
+                  <a:cubicBezTo>
+                    <a:pt x="21117" y="375335"/>
+                    <a:pt x="13807" y="372307"/>
+                    <a:pt x="8417" y="366917"/>
+                  </a:cubicBezTo>
+                  <a:cubicBezTo>
+                    <a:pt x="3028" y="361528"/>
+                    <a:pt x="0" y="354218"/>
+                    <a:pt x="0" y="346596"/>
+                  </a:cubicBezTo>
+                  <a:lnTo>
+                    <a:pt x="0" y="28739"/>
+                  </a:lnTo>
+                  <a:cubicBezTo>
+                    <a:pt x="0" y="12867"/>
+                    <a:pt x="12867" y="0"/>
+                    <a:pt x="28739" y="0"/>
+                  </a:cubicBezTo>
+                  <a:close/>
+                </a:path>
+              </a:pathLst>
+            </a:custGeom>
+            <a:solidFill>
+              <a:srgbClr val="233D89"/>
+            </a:solidFill>
+          </p:spPr>
+        </p:sp>
+        <p:sp>
+          <p:nvSpPr>
+            <p:cNvPr name="TextBox 8" id="8"/>
+            <p:cNvSpPr txBox="true"/>
+            <p:nvPr/>
+          </p:nvSpPr>
+          <p:spPr>
+            <a:xfrm>
+              <a:off x="0" y="-38100"/>
+              <a:ext cx="1206151" cy="413435"/>
+            </a:xfrm>
+            <a:prstGeom prst="rect">
+              <a:avLst/>
+            </a:prstGeom>
+          </p:spPr>
+          <p:txBody>
+            <a:bodyPr anchor="ctr" rtlCol="false" tIns="50800" lIns="50800" bIns="50800" rIns="50800"/>
+            <a:lstStyle/>
+            <a:p>
+              <a:pPr algn="ctr">
+                <a:lnSpc>
+                  <a:spcPts val="3449"/>
+                </a:lnSpc>
+              </a:pPr>
+            </a:p>
+          </p:txBody>
+        </p:sp>
+      </p:grpSp>
     </p:spTree>
   </p:cSld>
   <p:clrMapOvr>
@@ -15066,6 +17802,891 @@
                 <a:sym typeface="Montserrat Bold"/>
               </a:rPr>
               <a:t>Desempenho; Segurança; Escalabilidade.</a:t>
+            </a:r>
+          </a:p>
+        </p:txBody>
+      </p:sp>
+    </p:spTree>
+  </p:cSld>
+  <p:clrMapOvr>
+    <a:masterClrMapping/>
+  </p:clrMapOvr>
+</p:sld>
+</file>
+
+<file path=ppt/slides/slide30.xml><?xml version="1.0" encoding="utf-8"?>
+<p:sld xmlns:p="http://schemas.openxmlformats.org/presentationml/2006/main" xmlns:a="http://schemas.openxmlformats.org/drawingml/2006/main" xmlns:r="http://schemas.openxmlformats.org/officeDocument/2006/relationships">
+  <p:cSld>
+    <p:bg>
+      <p:bgPr>
+        <a:solidFill>
+          <a:srgbClr val="233D89"/>
+        </a:solidFill>
+      </p:bgPr>
+    </p:bg>
+    <p:spTree>
+      <p:nvGrpSpPr>
+        <p:cNvPr id="1" name=""/>
+        <p:cNvGrpSpPr/>
+        <p:nvPr/>
+      </p:nvGrpSpPr>
+      <p:grpSpPr>
+        <a:xfrm>
+          <a:off x="0" y="0"/>
+          <a:ext cx="0" cy="0"/>
+          <a:chOff x="0" y="0"/>
+          <a:chExt cx="0" cy="0"/>
+        </a:xfrm>
+      </p:grpSpPr>
+      <p:sp>
+        <p:nvSpPr>
+          <p:cNvPr name="Freeform 2" id="2"/>
+          <p:cNvSpPr/>
+          <p:nvPr/>
+        </p:nvSpPr>
+        <p:spPr>
+          <a:xfrm flipH="false" flipV="false" rot="0">
+            <a:off x="266228" y="2227353"/>
+            <a:ext cx="17755545" cy="5149108"/>
+          </a:xfrm>
+          <a:custGeom>
+            <a:avLst/>
+            <a:gdLst/>
+            <a:ahLst/>
+            <a:cxnLst/>
+            <a:rect r="r" b="b" t="t" l="l"/>
+            <a:pathLst>
+              <a:path h="5149108" w="17755545">
+                <a:moveTo>
+                  <a:pt x="0" y="0"/>
+                </a:moveTo>
+                <a:lnTo>
+                  <a:pt x="17755544" y="0"/>
+                </a:lnTo>
+                <a:lnTo>
+                  <a:pt x="17755544" y="5149108"/>
+                </a:lnTo>
+                <a:lnTo>
+                  <a:pt x="0" y="5149108"/>
+                </a:lnTo>
+                <a:lnTo>
+                  <a:pt x="0" y="0"/>
+                </a:lnTo>
+                <a:close/>
+              </a:path>
+            </a:pathLst>
+          </a:custGeom>
+          <a:blipFill>
+            <a:blip r:embed="rId2"/>
+            <a:stretch>
+              <a:fillRect l="0" t="0" r="0" b="0"/>
+            </a:stretch>
+          </a:blipFill>
+        </p:spPr>
+      </p:sp>
+      <p:grpSp>
+        <p:nvGrpSpPr>
+          <p:cNvPr name="Group 3" id="3"/>
+          <p:cNvGrpSpPr/>
+          <p:nvPr/>
+        </p:nvGrpSpPr>
+        <p:grpSpPr>
+          <a:xfrm rot="0">
+            <a:off x="621952" y="6126847"/>
+            <a:ext cx="5905615" cy="1425098"/>
+            <a:chOff x="0" y="0"/>
+            <a:chExt cx="1555388" cy="375335"/>
+          </a:xfrm>
+        </p:grpSpPr>
+        <p:sp>
+          <p:nvSpPr>
+            <p:cNvPr name="Freeform 4" id="4"/>
+            <p:cNvSpPr/>
+            <p:nvPr/>
+          </p:nvSpPr>
+          <p:spPr>
+            <a:xfrm flipH="false" flipV="false" rot="0">
+              <a:off x="0" y="0"/>
+              <a:ext cx="1555388" cy="375335"/>
+            </a:xfrm>
+            <a:custGeom>
+              <a:avLst/>
+              <a:gdLst/>
+              <a:ahLst/>
+              <a:cxnLst/>
+              <a:rect r="r" b="b" t="t" l="l"/>
+              <a:pathLst>
+                <a:path h="375335" w="1555388">
+                  <a:moveTo>
+                    <a:pt x="22286" y="0"/>
+                  </a:moveTo>
+                  <a:lnTo>
+                    <a:pt x="1533102" y="0"/>
+                  </a:lnTo>
+                  <a:cubicBezTo>
+                    <a:pt x="1539013" y="0"/>
+                    <a:pt x="1544682" y="2348"/>
+                    <a:pt x="1548861" y="6527"/>
+                  </a:cubicBezTo>
+                  <a:cubicBezTo>
+                    <a:pt x="1553040" y="10707"/>
+                    <a:pt x="1555388" y="16375"/>
+                    <a:pt x="1555388" y="22286"/>
+                  </a:cubicBezTo>
+                  <a:lnTo>
+                    <a:pt x="1555388" y="353049"/>
+                  </a:lnTo>
+                  <a:cubicBezTo>
+                    <a:pt x="1555388" y="365357"/>
+                    <a:pt x="1545411" y="375335"/>
+                    <a:pt x="1533102" y="375335"/>
+                  </a:cubicBezTo>
+                  <a:lnTo>
+                    <a:pt x="22286" y="375335"/>
+                  </a:lnTo>
+                  <a:cubicBezTo>
+                    <a:pt x="16375" y="375335"/>
+                    <a:pt x="10707" y="372987"/>
+                    <a:pt x="6527" y="368807"/>
+                  </a:cubicBezTo>
+                  <a:cubicBezTo>
+                    <a:pt x="2348" y="364628"/>
+                    <a:pt x="0" y="358959"/>
+                    <a:pt x="0" y="353049"/>
+                  </a:cubicBezTo>
+                  <a:lnTo>
+                    <a:pt x="0" y="22286"/>
+                  </a:lnTo>
+                  <a:cubicBezTo>
+                    <a:pt x="0" y="9978"/>
+                    <a:pt x="9978" y="0"/>
+                    <a:pt x="22286" y="0"/>
+                  </a:cubicBezTo>
+                  <a:close/>
+                </a:path>
+              </a:pathLst>
+            </a:custGeom>
+            <a:solidFill>
+              <a:srgbClr val="233D89"/>
+            </a:solidFill>
+          </p:spPr>
+        </p:sp>
+        <p:sp>
+          <p:nvSpPr>
+            <p:cNvPr name="TextBox 5" id="5"/>
+            <p:cNvSpPr txBox="true"/>
+            <p:nvPr/>
+          </p:nvSpPr>
+          <p:spPr>
+            <a:xfrm>
+              <a:off x="0" y="-38100"/>
+              <a:ext cx="1555388" cy="413435"/>
+            </a:xfrm>
+            <a:prstGeom prst="rect">
+              <a:avLst/>
+            </a:prstGeom>
+          </p:spPr>
+          <p:txBody>
+            <a:bodyPr anchor="ctr" rtlCol="false" tIns="50800" lIns="50800" bIns="50800" rIns="50800"/>
+            <a:lstStyle/>
+            <a:p>
+              <a:pPr algn="ctr">
+                <a:lnSpc>
+                  <a:spcPts val="3449"/>
+                </a:lnSpc>
+              </a:pPr>
+            </a:p>
+          </p:txBody>
+        </p:sp>
+      </p:grpSp>
+    </p:spTree>
+  </p:cSld>
+  <p:clrMapOvr>
+    <a:masterClrMapping/>
+  </p:clrMapOvr>
+</p:sld>
+</file>
+
+<file path=ppt/slides/slide31.xml><?xml version="1.0" encoding="utf-8"?>
+<p:sld xmlns:p="http://schemas.openxmlformats.org/presentationml/2006/main" xmlns:a="http://schemas.openxmlformats.org/drawingml/2006/main" xmlns:r="http://schemas.openxmlformats.org/officeDocument/2006/relationships">
+  <p:cSld>
+    <p:bg>
+      <p:bgPr>
+        <a:solidFill>
+          <a:srgbClr val="233D89"/>
+        </a:solidFill>
+      </p:bgPr>
+    </p:bg>
+    <p:spTree>
+      <p:nvGrpSpPr>
+        <p:cNvPr id="1" name=""/>
+        <p:cNvGrpSpPr/>
+        <p:nvPr/>
+      </p:nvGrpSpPr>
+      <p:grpSpPr>
+        <a:xfrm>
+          <a:off x="0" y="0"/>
+          <a:ext cx="0" cy="0"/>
+          <a:chOff x="0" y="0"/>
+          <a:chExt cx="0" cy="0"/>
+        </a:xfrm>
+      </p:grpSpPr>
+      <p:sp>
+        <p:nvSpPr>
+          <p:cNvPr name="Freeform 2" id="2"/>
+          <p:cNvSpPr/>
+          <p:nvPr/>
+        </p:nvSpPr>
+        <p:spPr>
+          <a:xfrm flipH="false" flipV="false" rot="0">
+            <a:off x="266228" y="2227353"/>
+            <a:ext cx="17755545" cy="5149108"/>
+          </a:xfrm>
+          <a:custGeom>
+            <a:avLst/>
+            <a:gdLst/>
+            <a:ahLst/>
+            <a:cxnLst/>
+            <a:rect r="r" b="b" t="t" l="l"/>
+            <a:pathLst>
+              <a:path h="5149108" w="17755545">
+                <a:moveTo>
+                  <a:pt x="0" y="0"/>
+                </a:moveTo>
+                <a:lnTo>
+                  <a:pt x="17755544" y="0"/>
+                </a:lnTo>
+                <a:lnTo>
+                  <a:pt x="17755544" y="5149108"/>
+                </a:lnTo>
+                <a:lnTo>
+                  <a:pt x="0" y="5149108"/>
+                </a:lnTo>
+                <a:lnTo>
+                  <a:pt x="0" y="0"/>
+                </a:lnTo>
+                <a:close/>
+              </a:path>
+            </a:pathLst>
+          </a:custGeom>
+          <a:blipFill>
+            <a:blip r:embed="rId2"/>
+            <a:stretch>
+              <a:fillRect l="0" t="0" r="0" b="0"/>
+            </a:stretch>
+          </a:blipFill>
+        </p:spPr>
+      </p:sp>
+    </p:spTree>
+  </p:cSld>
+  <p:clrMapOvr>
+    <a:masterClrMapping/>
+  </p:clrMapOvr>
+</p:sld>
+</file>
+
+<file path=ppt/slides/slide32.xml><?xml version="1.0" encoding="utf-8"?>
+<p:sld xmlns:p="http://schemas.openxmlformats.org/presentationml/2006/main" xmlns:a="http://schemas.openxmlformats.org/drawingml/2006/main">
+  <p:cSld>
+    <p:bg>
+      <p:bgPr>
+        <a:solidFill>
+          <a:srgbClr val="1E3A8A"/>
+        </a:solidFill>
+      </p:bgPr>
+    </p:bg>
+    <p:spTree>
+      <p:nvGrpSpPr>
+        <p:cNvPr id="1" name=""/>
+        <p:cNvGrpSpPr/>
+        <p:nvPr/>
+      </p:nvGrpSpPr>
+      <p:grpSpPr>
+        <a:xfrm>
+          <a:off x="0" y="0"/>
+          <a:ext cx="0" cy="0"/>
+          <a:chOff x="0" y="0"/>
+          <a:chExt cx="0" cy="0"/>
+        </a:xfrm>
+      </p:grpSpPr>
+      <p:sp>
+        <p:nvSpPr>
+          <p:cNvPr name="TextBox 2" id="2"/>
+          <p:cNvSpPr txBox="true"/>
+          <p:nvPr/>
+        </p:nvSpPr>
+        <p:spPr>
+          <a:xfrm rot="0">
+            <a:off x="6199548" y="4333452"/>
+            <a:ext cx="5888905" cy="1572470"/>
+          </a:xfrm>
+          <a:prstGeom prst="rect">
+            <a:avLst/>
+          </a:prstGeom>
+        </p:spPr>
+        <p:txBody>
+          <a:bodyPr anchor="t" rtlCol="false" tIns="0" lIns="0" bIns="0" rIns="0">
+            <a:spAutoFit/>
+          </a:bodyPr>
+          <a:lstStyle/>
+          <a:p>
+            <a:pPr algn="ctr">
+              <a:lnSpc>
+                <a:spcPts val="12661"/>
+              </a:lnSpc>
+            </a:pPr>
+            <a:r>
+              <a:rPr lang="en-US" b="true" sz="10056">
+                <a:solidFill>
+                  <a:srgbClr val="FFFFFF"/>
+                </a:solidFill>
+                <a:latin typeface="Montserrat Bold"/>
+                <a:ea typeface="Montserrat Bold"/>
+                <a:cs typeface="Montserrat Bold"/>
+                <a:sym typeface="Montserrat Bold"/>
+              </a:rPr>
+              <a:t>Gabarito</a:t>
+            </a:r>
+          </a:p>
+        </p:txBody>
+      </p:sp>
+    </p:spTree>
+  </p:cSld>
+  <p:clrMapOvr>
+    <a:masterClrMapping/>
+  </p:clrMapOvr>
+</p:sld>
+</file>
+
+<file path=ppt/slides/slide33.xml><?xml version="1.0" encoding="utf-8"?>
+<p:sld xmlns:p="http://schemas.openxmlformats.org/presentationml/2006/main" xmlns:a="http://schemas.openxmlformats.org/drawingml/2006/main" xmlns:r="http://schemas.openxmlformats.org/officeDocument/2006/relationships">
+  <p:cSld>
+    <p:bg>
+      <p:bgPr>
+        <a:solidFill>
+          <a:srgbClr val="233D89"/>
+        </a:solidFill>
+      </p:bgPr>
+    </p:bg>
+    <p:spTree>
+      <p:nvGrpSpPr>
+        <p:cNvPr id="1" name=""/>
+        <p:cNvGrpSpPr/>
+        <p:nvPr/>
+      </p:nvGrpSpPr>
+      <p:grpSpPr>
+        <a:xfrm>
+          <a:off x="0" y="0"/>
+          <a:ext cx="0" cy="0"/>
+          <a:chOff x="0" y="0"/>
+          <a:chExt cx="0" cy="0"/>
+        </a:xfrm>
+      </p:grpSpPr>
+      <p:sp>
+        <p:nvSpPr>
+          <p:cNvPr name="Freeform 2" id="2"/>
+          <p:cNvSpPr/>
+          <p:nvPr/>
+        </p:nvSpPr>
+        <p:spPr>
+          <a:xfrm flipH="false" flipV="false" rot="0">
+            <a:off x="1243250" y="302848"/>
+            <a:ext cx="8148397" cy="9287962"/>
+          </a:xfrm>
+          <a:custGeom>
+            <a:avLst/>
+            <a:gdLst/>
+            <a:ahLst/>
+            <a:cxnLst/>
+            <a:rect r="r" b="b" t="t" l="l"/>
+            <a:pathLst>
+              <a:path h="9287962" w="8148397">
+                <a:moveTo>
+                  <a:pt x="0" y="0"/>
+                </a:moveTo>
+                <a:lnTo>
+                  <a:pt x="8148397" y="0"/>
+                </a:lnTo>
+                <a:lnTo>
+                  <a:pt x="8148397" y="9287962"/>
+                </a:lnTo>
+                <a:lnTo>
+                  <a:pt x="0" y="9287962"/>
+                </a:lnTo>
+                <a:lnTo>
+                  <a:pt x="0" y="0"/>
+                </a:lnTo>
+                <a:close/>
+              </a:path>
+            </a:pathLst>
+          </a:custGeom>
+          <a:blipFill>
+            <a:blip r:embed="rId2"/>
+            <a:stretch>
+              <a:fillRect l="0" t="0" r="0" b="0"/>
+            </a:stretch>
+          </a:blipFill>
+        </p:spPr>
+      </p:sp>
+    </p:spTree>
+  </p:cSld>
+  <p:clrMapOvr>
+    <a:masterClrMapping/>
+  </p:clrMapOvr>
+</p:sld>
+</file>
+
+<file path=ppt/slides/slide34.xml><?xml version="1.0" encoding="utf-8"?>
+<p:sld xmlns:p="http://schemas.openxmlformats.org/presentationml/2006/main" xmlns:a="http://schemas.openxmlformats.org/drawingml/2006/main" xmlns:r="http://schemas.openxmlformats.org/officeDocument/2006/relationships">
+  <p:cSld>
+    <p:bg>
+      <p:bgPr>
+        <a:solidFill>
+          <a:srgbClr val="233D89"/>
+        </a:solidFill>
+      </p:bgPr>
+    </p:bg>
+    <p:spTree>
+      <p:nvGrpSpPr>
+        <p:cNvPr id="1" name=""/>
+        <p:cNvGrpSpPr/>
+        <p:nvPr/>
+      </p:nvGrpSpPr>
+      <p:grpSpPr>
+        <a:xfrm>
+          <a:off x="0" y="0"/>
+          <a:ext cx="0" cy="0"/>
+          <a:chOff x="0" y="0"/>
+          <a:chExt cx="0" cy="0"/>
+        </a:xfrm>
+      </p:grpSpPr>
+      <p:sp>
+        <p:nvSpPr>
+          <p:cNvPr name="Freeform 2" id="2"/>
+          <p:cNvSpPr/>
+          <p:nvPr/>
+        </p:nvSpPr>
+        <p:spPr>
+          <a:xfrm flipH="false" flipV="false" rot="0">
+            <a:off x="1450288" y="461402"/>
+            <a:ext cx="9485850" cy="9017664"/>
+          </a:xfrm>
+          <a:custGeom>
+            <a:avLst/>
+            <a:gdLst/>
+            <a:ahLst/>
+            <a:cxnLst/>
+            <a:rect r="r" b="b" t="t" l="l"/>
+            <a:pathLst>
+              <a:path h="9017664" w="9485850">
+                <a:moveTo>
+                  <a:pt x="0" y="0"/>
+                </a:moveTo>
+                <a:lnTo>
+                  <a:pt x="9485850" y="0"/>
+                </a:lnTo>
+                <a:lnTo>
+                  <a:pt x="9485850" y="9017664"/>
+                </a:lnTo>
+                <a:lnTo>
+                  <a:pt x="0" y="9017664"/>
+                </a:lnTo>
+                <a:lnTo>
+                  <a:pt x="0" y="0"/>
+                </a:lnTo>
+                <a:close/>
+              </a:path>
+            </a:pathLst>
+          </a:custGeom>
+          <a:blipFill>
+            <a:blip r:embed="rId2"/>
+            <a:stretch>
+              <a:fillRect l="0" t="0" r="0" b="0"/>
+            </a:stretch>
+          </a:blipFill>
+        </p:spPr>
+      </p:sp>
+    </p:spTree>
+  </p:cSld>
+  <p:clrMapOvr>
+    <a:masterClrMapping/>
+  </p:clrMapOvr>
+</p:sld>
+</file>
+
+<file path=ppt/slides/slide35.xml><?xml version="1.0" encoding="utf-8"?>
+<p:sld xmlns:p="http://schemas.openxmlformats.org/presentationml/2006/main" xmlns:a="http://schemas.openxmlformats.org/drawingml/2006/main" xmlns:r="http://schemas.openxmlformats.org/officeDocument/2006/relationships">
+  <p:cSld>
+    <p:bg>
+      <p:bgPr>
+        <a:solidFill>
+          <a:srgbClr val="283D87"/>
+        </a:solidFill>
+      </p:bgPr>
+    </p:bg>
+    <p:spTree>
+      <p:nvGrpSpPr>
+        <p:cNvPr id="1" name=""/>
+        <p:cNvGrpSpPr/>
+        <p:nvPr/>
+      </p:nvGrpSpPr>
+      <p:grpSpPr>
+        <a:xfrm>
+          <a:off x="0" y="0"/>
+          <a:ext cx="0" cy="0"/>
+          <a:chOff x="0" y="0"/>
+          <a:chExt cx="0" cy="0"/>
+        </a:xfrm>
+      </p:grpSpPr>
+      <p:sp>
+        <p:nvSpPr>
+          <p:cNvPr name="Freeform 2" id="2"/>
+          <p:cNvSpPr/>
+          <p:nvPr/>
+        </p:nvSpPr>
+        <p:spPr>
+          <a:xfrm flipH="false" flipV="false" rot="0">
+            <a:off x="150912" y="2890385"/>
+            <a:ext cx="17986175" cy="4202955"/>
+          </a:xfrm>
+          <a:custGeom>
+            <a:avLst/>
+            <a:gdLst/>
+            <a:ahLst/>
+            <a:cxnLst/>
+            <a:rect r="r" b="b" t="t" l="l"/>
+            <a:pathLst>
+              <a:path h="4202955" w="17986175">
+                <a:moveTo>
+                  <a:pt x="0" y="0"/>
+                </a:moveTo>
+                <a:lnTo>
+                  <a:pt x="17986176" y="0"/>
+                </a:lnTo>
+                <a:lnTo>
+                  <a:pt x="17986176" y="4202956"/>
+                </a:lnTo>
+                <a:lnTo>
+                  <a:pt x="0" y="4202956"/>
+                </a:lnTo>
+                <a:lnTo>
+                  <a:pt x="0" y="0"/>
+                </a:lnTo>
+                <a:close/>
+              </a:path>
+            </a:pathLst>
+          </a:custGeom>
+          <a:blipFill>
+            <a:blip r:embed="rId2"/>
+            <a:stretch>
+              <a:fillRect l="0" t="0" r="0" b="0"/>
+            </a:stretch>
+          </a:blipFill>
+        </p:spPr>
+      </p:sp>
+    </p:spTree>
+  </p:cSld>
+  <p:clrMapOvr>
+    <a:masterClrMapping/>
+  </p:clrMapOvr>
+</p:sld>
+</file>
+
+<file path=ppt/slides/slide36.xml><?xml version="1.0" encoding="utf-8"?>
+<p:sld xmlns:p="http://schemas.openxmlformats.org/presentationml/2006/main" xmlns:a="http://schemas.openxmlformats.org/drawingml/2006/main" xmlns:r="http://schemas.openxmlformats.org/officeDocument/2006/relationships">
+  <p:cSld>
+    <p:bg>
+      <p:bgPr>
+        <a:solidFill>
+          <a:srgbClr val="283D87"/>
+        </a:solidFill>
+      </p:bgPr>
+    </p:bg>
+    <p:spTree>
+      <p:nvGrpSpPr>
+        <p:cNvPr id="1" name=""/>
+        <p:cNvGrpSpPr/>
+        <p:nvPr/>
+      </p:nvGrpSpPr>
+      <p:grpSpPr>
+        <a:xfrm>
+          <a:off x="0" y="0"/>
+          <a:ext cx="0" cy="0"/>
+          <a:chOff x="0" y="0"/>
+          <a:chExt cx="0" cy="0"/>
+        </a:xfrm>
+      </p:grpSpPr>
+      <p:sp>
+        <p:nvSpPr>
+          <p:cNvPr name="Freeform 2" id="2"/>
+          <p:cNvSpPr/>
+          <p:nvPr/>
+        </p:nvSpPr>
+        <p:spPr>
+          <a:xfrm flipH="false" flipV="false" rot="0">
+            <a:off x="241034" y="1970578"/>
+            <a:ext cx="17805932" cy="4874374"/>
+          </a:xfrm>
+          <a:custGeom>
+            <a:avLst/>
+            <a:gdLst/>
+            <a:ahLst/>
+            <a:cxnLst/>
+            <a:rect r="r" b="b" t="t" l="l"/>
+            <a:pathLst>
+              <a:path h="4874374" w="17805932">
+                <a:moveTo>
+                  <a:pt x="0" y="0"/>
+                </a:moveTo>
+                <a:lnTo>
+                  <a:pt x="17805932" y="0"/>
+                </a:lnTo>
+                <a:lnTo>
+                  <a:pt x="17805932" y="4874374"/>
+                </a:lnTo>
+                <a:lnTo>
+                  <a:pt x="0" y="4874374"/>
+                </a:lnTo>
+                <a:lnTo>
+                  <a:pt x="0" y="0"/>
+                </a:lnTo>
+                <a:close/>
+              </a:path>
+            </a:pathLst>
+          </a:custGeom>
+          <a:blipFill>
+            <a:blip r:embed="rId2"/>
+            <a:stretch>
+              <a:fillRect l="0" t="0" r="0" b="0"/>
+            </a:stretch>
+          </a:blipFill>
+        </p:spPr>
+      </p:sp>
+    </p:spTree>
+  </p:cSld>
+  <p:clrMapOvr>
+    <a:masterClrMapping/>
+  </p:clrMapOvr>
+</p:sld>
+</file>
+
+<file path=ppt/slides/slide37.xml><?xml version="1.0" encoding="utf-8"?>
+<p:sld xmlns:p="http://schemas.openxmlformats.org/presentationml/2006/main" xmlns:a="http://schemas.openxmlformats.org/drawingml/2006/main" xmlns:r="http://schemas.openxmlformats.org/officeDocument/2006/relationships">
+  <p:cSld>
+    <p:bg>
+      <p:bgPr>
+        <a:solidFill>
+          <a:srgbClr val="233D89"/>
+        </a:solidFill>
+      </p:bgPr>
+    </p:bg>
+    <p:spTree>
+      <p:nvGrpSpPr>
+        <p:cNvPr id="1" name=""/>
+        <p:cNvGrpSpPr/>
+        <p:nvPr/>
+      </p:nvGrpSpPr>
+      <p:grpSpPr>
+        <a:xfrm>
+          <a:off x="0" y="0"/>
+          <a:ext cx="0" cy="0"/>
+          <a:chOff x="0" y="0"/>
+          <a:chExt cx="0" cy="0"/>
+        </a:xfrm>
+      </p:grpSpPr>
+      <p:sp>
+        <p:nvSpPr>
+          <p:cNvPr name="Freeform 2" id="2"/>
+          <p:cNvSpPr/>
+          <p:nvPr/>
+        </p:nvSpPr>
+        <p:spPr>
+          <a:xfrm flipH="false" flipV="false" rot="0">
+            <a:off x="4528962" y="624966"/>
+            <a:ext cx="9832027" cy="9382626"/>
+          </a:xfrm>
+          <a:custGeom>
+            <a:avLst/>
+            <a:gdLst/>
+            <a:ahLst/>
+            <a:cxnLst/>
+            <a:rect r="r" b="b" t="t" l="l"/>
+            <a:pathLst>
+              <a:path h="9382626" w="9832027">
+                <a:moveTo>
+                  <a:pt x="0" y="0"/>
+                </a:moveTo>
+                <a:lnTo>
+                  <a:pt x="9832028" y="0"/>
+                </a:lnTo>
+                <a:lnTo>
+                  <a:pt x="9832028" y="9382626"/>
+                </a:lnTo>
+                <a:lnTo>
+                  <a:pt x="0" y="9382626"/>
+                </a:lnTo>
+                <a:lnTo>
+                  <a:pt x="0" y="0"/>
+                </a:lnTo>
+                <a:close/>
+              </a:path>
+            </a:pathLst>
+          </a:custGeom>
+          <a:blipFill>
+            <a:blip r:embed="rId2"/>
+            <a:stretch>
+              <a:fillRect l="0" t="0" r="0" b="0"/>
+            </a:stretch>
+          </a:blipFill>
+        </p:spPr>
+      </p:sp>
+    </p:spTree>
+  </p:cSld>
+  <p:clrMapOvr>
+    <a:masterClrMapping/>
+  </p:clrMapOvr>
+</p:sld>
+</file>
+
+<file path=ppt/slides/slide38.xml><?xml version="1.0" encoding="utf-8"?>
+<p:sld xmlns:p="http://schemas.openxmlformats.org/presentationml/2006/main" xmlns:a="http://schemas.openxmlformats.org/drawingml/2006/main" xmlns:r="http://schemas.openxmlformats.org/officeDocument/2006/relationships">
+  <p:cSld>
+    <p:bg>
+      <p:bgPr>
+        <a:solidFill>
+          <a:srgbClr val="233D89"/>
+        </a:solidFill>
+      </p:bgPr>
+    </p:bg>
+    <p:spTree>
+      <p:nvGrpSpPr>
+        <p:cNvPr id="1" name=""/>
+        <p:cNvGrpSpPr/>
+        <p:nvPr/>
+      </p:nvGrpSpPr>
+      <p:grpSpPr>
+        <a:xfrm>
+          <a:off x="0" y="0"/>
+          <a:ext cx="0" cy="0"/>
+          <a:chOff x="0" y="0"/>
+          <a:chExt cx="0" cy="0"/>
+        </a:xfrm>
+      </p:grpSpPr>
+      <p:sp>
+        <p:nvSpPr>
+          <p:cNvPr name="Freeform 2" id="2"/>
+          <p:cNvSpPr/>
+          <p:nvPr/>
+        </p:nvSpPr>
+        <p:spPr>
+          <a:xfrm flipH="false" flipV="false" rot="0">
+            <a:off x="4644143" y="509748"/>
+            <a:ext cx="9623518" cy="9267504"/>
+          </a:xfrm>
+          <a:custGeom>
+            <a:avLst/>
+            <a:gdLst/>
+            <a:ahLst/>
+            <a:cxnLst/>
+            <a:rect r="r" b="b" t="t" l="l"/>
+            <a:pathLst>
+              <a:path h="9267504" w="9623518">
+                <a:moveTo>
+                  <a:pt x="0" y="0"/>
+                </a:moveTo>
+                <a:lnTo>
+                  <a:pt x="9623518" y="0"/>
+                </a:lnTo>
+                <a:lnTo>
+                  <a:pt x="9623518" y="9267504"/>
+                </a:lnTo>
+                <a:lnTo>
+                  <a:pt x="0" y="9267504"/>
+                </a:lnTo>
+                <a:lnTo>
+                  <a:pt x="0" y="0"/>
+                </a:lnTo>
+                <a:close/>
+              </a:path>
+            </a:pathLst>
+          </a:custGeom>
+          <a:blipFill>
+            <a:blip r:embed="rId2"/>
+            <a:stretch>
+              <a:fillRect l="0" t="0" r="0" b="0"/>
+            </a:stretch>
+          </a:blipFill>
+        </p:spPr>
+      </p:sp>
+    </p:spTree>
+  </p:cSld>
+  <p:clrMapOvr>
+    <a:masterClrMapping/>
+  </p:clrMapOvr>
+</p:sld>
+</file>
+
+<file path=ppt/slides/slide39.xml><?xml version="1.0" encoding="utf-8"?>
+<p:sld xmlns:p="http://schemas.openxmlformats.org/presentationml/2006/main" xmlns:a="http://schemas.openxmlformats.org/drawingml/2006/main">
+  <p:cSld>
+    <p:bg>
+      <p:bgPr>
+        <a:solidFill>
+          <a:srgbClr val="1E3A8A"/>
+        </a:solidFill>
+      </p:bgPr>
+    </p:bg>
+    <p:spTree>
+      <p:nvGrpSpPr>
+        <p:cNvPr id="1" name=""/>
+        <p:cNvGrpSpPr/>
+        <p:nvPr/>
+      </p:nvGrpSpPr>
+      <p:grpSpPr>
+        <a:xfrm>
+          <a:off x="0" y="0"/>
+          <a:ext cx="0" cy="0"/>
+          <a:chOff x="0" y="0"/>
+          <a:chExt cx="0" cy="0"/>
+        </a:xfrm>
+      </p:grpSpPr>
+      <p:sp>
+        <p:nvSpPr>
+          <p:cNvPr name="TextBox 2" id="2"/>
+          <p:cNvSpPr txBox="true"/>
+          <p:nvPr/>
+        </p:nvSpPr>
+        <p:spPr>
+          <a:xfrm rot="0">
+            <a:off x="2335702" y="3518218"/>
+            <a:ext cx="13616597" cy="3145790"/>
+          </a:xfrm>
+          <a:prstGeom prst="rect">
+            <a:avLst/>
+          </a:prstGeom>
+        </p:spPr>
+        <p:txBody>
+          <a:bodyPr anchor="t" rtlCol="false" tIns="0" lIns="0" bIns="0" rIns="0">
+            <a:spAutoFit/>
+          </a:bodyPr>
+          <a:lstStyle/>
+          <a:p>
+            <a:pPr algn="l">
+              <a:lnSpc>
+                <a:spcPts val="25180"/>
+              </a:lnSpc>
+            </a:pPr>
+            <a:r>
+              <a:rPr lang="en-US" b="true" sz="20000">
+                <a:solidFill>
+                  <a:srgbClr val="FFFFFF"/>
+                </a:solidFill>
+                <a:latin typeface="Montserrat Bold"/>
+                <a:ea typeface="Montserrat Bold"/>
+                <a:cs typeface="Montserrat Bold"/>
+                <a:sym typeface="Montserrat Bold"/>
+              </a:rPr>
+              <a:t>Obrigado!</a:t>
             </a:r>
           </a:p>
         </p:txBody>

</xml_diff>

<commit_message>
Alterações nos Slides: Aquiteturas 6 a 10 e ultimos slides
</commit_message>
<xml_diff>
--- a/Apresentacao.pptx
+++ b/Apresentacao.pptx
@@ -3868,7 +3868,7 @@
         </p:nvGrpSpPr>
         <p:grpSpPr>
           <a:xfrm rot="0">
-            <a:off x="9484765" y="2821286"/>
+            <a:off x="9484765" y="2202608"/>
             <a:ext cx="8196855" cy="1348723"/>
             <a:chOff x="0" y="0"/>
             <a:chExt cx="11500046" cy="1892241"/>
@@ -4086,7 +4086,7 @@
         </p:nvSpPr>
         <p:spPr>
           <a:xfrm rot="0">
-            <a:off x="9730890" y="3030103"/>
+            <a:off x="9730890" y="2411424"/>
             <a:ext cx="7835486" cy="838206"/>
           </a:xfrm>
           <a:prstGeom prst="rect">
@@ -4146,7 +4146,7 @@
         </p:nvGrpSpPr>
         <p:grpSpPr>
           <a:xfrm rot="0">
-            <a:off x="10634694" y="4922664"/>
+            <a:off x="9605268" y="6835843"/>
             <a:ext cx="6931682" cy="2465362"/>
             <a:chOff x="0" y="0"/>
             <a:chExt cx="9725030" cy="3458872"/>
@@ -4244,7 +4244,7 @@
         </p:nvSpPr>
         <p:spPr>
           <a:xfrm rot="0">
-            <a:off x="10874921" y="5105400"/>
+            <a:off x="9845494" y="7018579"/>
             <a:ext cx="6453645" cy="2124081"/>
           </a:xfrm>
           <a:prstGeom prst="rect">
@@ -4273,6 +4273,145 @@
                 <a:sym typeface="Montserrat Bold"/>
               </a:rPr>
               <a:t>Mais comum em aplicações web e empresariais. O servidor centraliza a lógica de negócios e dados, enquanto os clientes executam a interface do usúario</a:t>
+            </a:r>
+          </a:p>
+        </p:txBody>
+      </p:sp>
+      <p:grpSp>
+        <p:nvGrpSpPr>
+          <p:cNvPr name="Group 12" id="12"/>
+          <p:cNvGrpSpPr/>
+          <p:nvPr/>
+        </p:nvGrpSpPr>
+        <p:grpSpPr>
+          <a:xfrm rot="0">
+            <a:off x="10327618" y="4075205"/>
+            <a:ext cx="6931682" cy="2465362"/>
+            <a:chOff x="0" y="0"/>
+            <a:chExt cx="9725030" cy="3458872"/>
+          </a:xfrm>
+        </p:grpSpPr>
+        <p:sp>
+          <p:nvSpPr>
+            <p:cNvPr name="Freeform 13" id="13"/>
+            <p:cNvSpPr/>
+            <p:nvPr/>
+          </p:nvSpPr>
+          <p:spPr>
+            <a:xfrm flipH="false" flipV="false" rot="0">
+              <a:off x="0" y="0"/>
+              <a:ext cx="9724951" cy="3458813"/>
+            </a:xfrm>
+            <a:custGeom>
+              <a:avLst/>
+              <a:gdLst/>
+              <a:ahLst/>
+              <a:cxnLst/>
+              <a:rect r="r" b="b" t="t" l="l"/>
+              <a:pathLst>
+                <a:path h="3458813" w="9724951">
+                  <a:moveTo>
+                    <a:pt x="335131" y="0"/>
+                  </a:moveTo>
+                  <a:lnTo>
+                    <a:pt x="9389820" y="0"/>
+                  </a:lnTo>
+                  <a:cubicBezTo>
+                    <a:pt x="9478702" y="0"/>
+                    <a:pt x="9563944" y="35308"/>
+                    <a:pt x="9626793" y="98158"/>
+                  </a:cubicBezTo>
+                  <a:cubicBezTo>
+                    <a:pt x="9689642" y="161007"/>
+                    <a:pt x="9724951" y="246249"/>
+                    <a:pt x="9724951" y="335131"/>
+                  </a:cubicBezTo>
+                  <a:lnTo>
+                    <a:pt x="9724951" y="3123682"/>
+                  </a:lnTo>
+                  <a:cubicBezTo>
+                    <a:pt x="9724951" y="3212564"/>
+                    <a:pt x="9689642" y="3297806"/>
+                    <a:pt x="9626793" y="3360655"/>
+                  </a:cubicBezTo>
+                  <a:cubicBezTo>
+                    <a:pt x="9563944" y="3423505"/>
+                    <a:pt x="9478702" y="3458813"/>
+                    <a:pt x="9389820" y="3458813"/>
+                  </a:cubicBezTo>
+                  <a:lnTo>
+                    <a:pt x="335131" y="3458813"/>
+                  </a:lnTo>
+                  <a:cubicBezTo>
+                    <a:pt x="246249" y="3458813"/>
+                    <a:pt x="161007" y="3423505"/>
+                    <a:pt x="98158" y="3360655"/>
+                  </a:cubicBezTo>
+                  <a:cubicBezTo>
+                    <a:pt x="35308" y="3297806"/>
+                    <a:pt x="0" y="3212564"/>
+                    <a:pt x="0" y="3123682"/>
+                  </a:cubicBezTo>
+                  <a:lnTo>
+                    <a:pt x="0" y="335131"/>
+                  </a:lnTo>
+                  <a:cubicBezTo>
+                    <a:pt x="0" y="246249"/>
+                    <a:pt x="35308" y="161007"/>
+                    <a:pt x="98158" y="98158"/>
+                  </a:cubicBezTo>
+                  <a:cubicBezTo>
+                    <a:pt x="161007" y="35308"/>
+                    <a:pt x="246249" y="0"/>
+                    <a:pt x="335131" y="0"/>
+                  </a:cubicBezTo>
+                  <a:close/>
+                </a:path>
+              </a:pathLst>
+            </a:custGeom>
+            <a:solidFill>
+              <a:srgbClr val="FFFFFF"/>
+            </a:solidFill>
+          </p:spPr>
+        </p:sp>
+      </p:grpSp>
+      <p:sp>
+        <p:nvSpPr>
+          <p:cNvPr name="TextBox 14" id="14"/>
+          <p:cNvSpPr txBox="true"/>
+          <p:nvPr/>
+        </p:nvSpPr>
+        <p:spPr>
+          <a:xfrm rot="0">
+            <a:off x="10573743" y="4226796"/>
+            <a:ext cx="6453645" cy="2124081"/>
+          </a:xfrm>
+          <a:prstGeom prst="rect">
+            <a:avLst/>
+          </a:prstGeom>
+        </p:spPr>
+        <p:txBody>
+          <a:bodyPr anchor="t" rtlCol="false" tIns="0" lIns="0" bIns="0" rIns="0">
+            <a:spAutoFit/>
+          </a:bodyPr>
+          <a:lstStyle/>
+          <a:p>
+            <a:pPr algn="just">
+              <a:lnSpc>
+                <a:spcPts val="3449"/>
+              </a:lnSpc>
+            </a:pPr>
+            <a:r>
+              <a:rPr lang="en-US" b="true" sz="2499">
+                <a:solidFill>
+                  <a:srgbClr val="47423E"/>
+                </a:solidFill>
+                <a:latin typeface="Montserrat Bold"/>
+                <a:ea typeface="Montserrat Bold"/>
+                <a:cs typeface="Montserrat Bold"/>
+                <a:sym typeface="Montserrat Bold"/>
+              </a:rPr>
+              <a:t>Esse modelo funcionava bem para realizar atualizações mais simples em dados e se precisasse exibir informações. Enquanto até cálculos, ficam mais difíceis de implementar</a:t>
             </a:r>
           </a:p>
         </p:txBody>
@@ -4317,10 +4456,10 @@
         </p:nvGrpSpPr>
         <p:grpSpPr>
           <a:xfrm rot="0">
-            <a:off x="579563" y="7556485"/>
-            <a:ext cx="6152288" cy="1665748"/>
+            <a:off x="11306346" y="2876969"/>
+            <a:ext cx="6277910" cy="1705040"/>
             <a:chOff x="0" y="0"/>
-            <a:chExt cx="12370046" cy="3349233"/>
+            <a:chExt cx="12622627" cy="3428235"/>
           </a:xfrm>
         </p:grpSpPr>
         <p:sp>
@@ -4332,7 +4471,7 @@
           <p:spPr>
             <a:xfrm flipH="false" flipV="false" rot="0">
               <a:off x="0" y="0"/>
-              <a:ext cx="12369946" cy="3349175"/>
+              <a:ext cx="12622524" cy="3428176"/>
             </a:xfrm>
             <a:custGeom>
               <a:avLst/>
@@ -4341,61 +4480,46 @@
               <a:cxnLst/>
               <a:rect r="r" b="b" t="t" l="l"/>
               <a:pathLst>
-                <a:path h="3349175" w="12369946">
+                <a:path h="3428176" w="12622524">
                   <a:moveTo>
-                    <a:pt x="377586" y="0"/>
+                    <a:pt x="370031" y="0"/>
                   </a:moveTo>
                   <a:lnTo>
-                    <a:pt x="11992359" y="0"/>
-                  </a:lnTo>
-                  <a:cubicBezTo>
-                    <a:pt x="12092501" y="0"/>
-                    <a:pt x="12188542" y="39781"/>
-                    <a:pt x="12259353" y="110593"/>
-                  </a:cubicBezTo>
-                  <a:cubicBezTo>
-                    <a:pt x="12330164" y="181404"/>
-                    <a:pt x="12369946" y="277444"/>
-                    <a:pt x="12369946" y="377586"/>
-                  </a:cubicBezTo>
-                  <a:lnTo>
-                    <a:pt x="12369946" y="2971589"/>
-                  </a:lnTo>
-                  <a:cubicBezTo>
-                    <a:pt x="12369946" y="3071731"/>
-                    <a:pt x="12330164" y="3167772"/>
-                    <a:pt x="12259353" y="3238583"/>
-                  </a:cubicBezTo>
-                  <a:cubicBezTo>
-                    <a:pt x="12188542" y="3309394"/>
-                    <a:pt x="12092501" y="3349175"/>
-                    <a:pt x="11992359" y="3349175"/>
-                  </a:cubicBezTo>
-                  <a:lnTo>
-                    <a:pt x="377586" y="3349175"/>
-                  </a:lnTo>
-                  <a:cubicBezTo>
-                    <a:pt x="277444" y="3349175"/>
-                    <a:pt x="181404" y="3309394"/>
-                    <a:pt x="110593" y="3238583"/>
-                  </a:cubicBezTo>
-                  <a:cubicBezTo>
-                    <a:pt x="39781" y="3167772"/>
-                    <a:pt x="0" y="3071731"/>
-                    <a:pt x="0" y="2971589"/>
-                  </a:cubicBezTo>
-                  <a:lnTo>
-                    <a:pt x="0" y="377586"/>
-                  </a:lnTo>
-                  <a:cubicBezTo>
-                    <a:pt x="0" y="277444"/>
-                    <a:pt x="39781" y="181404"/>
-                    <a:pt x="110593" y="110593"/>
-                  </a:cubicBezTo>
-                  <a:cubicBezTo>
-                    <a:pt x="181404" y="39781"/>
-                    <a:pt x="277444" y="0"/>
-                    <a:pt x="377586" y="0"/>
+                    <a:pt x="12252493" y="0"/>
+                  </a:lnTo>
+                  <a:cubicBezTo>
+                    <a:pt x="12456856" y="0"/>
+                    <a:pt x="12622524" y="165668"/>
+                    <a:pt x="12622524" y="370031"/>
+                  </a:cubicBezTo>
+                  <a:lnTo>
+                    <a:pt x="12622524" y="3058145"/>
+                  </a:lnTo>
+                  <a:cubicBezTo>
+                    <a:pt x="12622524" y="3156284"/>
+                    <a:pt x="12583539" y="3250402"/>
+                    <a:pt x="12514145" y="3319797"/>
+                  </a:cubicBezTo>
+                  <a:cubicBezTo>
+                    <a:pt x="12444750" y="3389191"/>
+                    <a:pt x="12350631" y="3428176"/>
+                    <a:pt x="12252493" y="3428176"/>
+                  </a:cubicBezTo>
+                  <a:lnTo>
+                    <a:pt x="370031" y="3428176"/>
+                  </a:lnTo>
+                  <a:cubicBezTo>
+                    <a:pt x="165668" y="3428176"/>
+                    <a:pt x="0" y="3262507"/>
+                    <a:pt x="0" y="3058145"/>
+                  </a:cubicBezTo>
+                  <a:lnTo>
+                    <a:pt x="0" y="370031"/>
+                  </a:lnTo>
+                  <a:cubicBezTo>
+                    <a:pt x="0" y="165668"/>
+                    <a:pt x="165668" y="0"/>
+                    <a:pt x="370031" y="0"/>
                   </a:cubicBezTo>
                   <a:close/>
                 </a:path>
@@ -4415,8 +4539,8 @@
         </p:nvSpPr>
         <p:spPr>
           <a:xfrm flipH="false" flipV="false" rot="0">
-            <a:off x="453941" y="2055481"/>
-            <a:ext cx="11749268" cy="4801244"/>
+            <a:off x="356435" y="2876969"/>
+            <a:ext cx="10357693" cy="4232588"/>
           </a:xfrm>
           <a:custGeom>
             <a:avLst/>
@@ -4425,18 +4549,18 @@
             <a:cxnLst/>
             <a:rect r="r" b="b" t="t" l="l"/>
             <a:pathLst>
-              <a:path h="4801244" w="11749268">
+              <a:path h="4232588" w="10357693">
                 <a:moveTo>
                   <a:pt x="0" y="0"/>
                 </a:moveTo>
                 <a:lnTo>
-                  <a:pt x="11749269" y="0"/>
+                  <a:pt x="10357693" y="0"/>
                 </a:lnTo>
                 <a:lnTo>
-                  <a:pt x="11749269" y="4801244"/>
+                  <a:pt x="10357693" y="4232588"/>
                 </a:lnTo>
                 <a:lnTo>
-                  <a:pt x="0" y="4801244"/>
+                  <a:pt x="0" y="4232588"/>
                 </a:lnTo>
                 <a:lnTo>
                   <a:pt x="0" y="0"/>
@@ -4596,7 +4720,7 @@
         </p:nvSpPr>
         <p:spPr>
           <a:xfrm rot="0">
-            <a:off x="688667" y="7704588"/>
+            <a:off x="11541072" y="3025072"/>
             <a:ext cx="5934079" cy="1266831"/>
           </a:xfrm>
           <a:prstGeom prst="rect">
@@ -4637,10 +4761,10 @@
         </p:nvGrpSpPr>
         <p:grpSpPr>
           <a:xfrm rot="0">
-            <a:off x="7625268" y="7560016"/>
-            <a:ext cx="7942031" cy="1313267"/>
+            <a:off x="11700910" y="5457757"/>
+            <a:ext cx="5401675" cy="1704091"/>
             <a:chOff x="0" y="0"/>
-            <a:chExt cx="15968578" cy="2640519"/>
+            <a:chExt cx="10860834" cy="3426328"/>
           </a:xfrm>
         </p:grpSpPr>
         <p:sp>
@@ -4652,7 +4776,7 @@
           <p:spPr>
             <a:xfrm flipH="false" flipV="false" rot="0">
               <a:off x="0" y="0"/>
-              <a:ext cx="15968449" cy="2640473"/>
+              <a:ext cx="10860746" cy="3426269"/>
             </a:xfrm>
             <a:custGeom>
               <a:avLst/>
@@ -4661,61 +4785,41 @@
               <a:cxnLst/>
               <a:rect r="r" b="b" t="t" l="l"/>
               <a:pathLst>
-                <a:path h="2640473" w="15968449">
+                <a:path h="3426269" w="10860746">
                   <a:moveTo>
-                    <a:pt x="292497" y="0"/>
+                    <a:pt x="430056" y="0"/>
                   </a:moveTo>
                   <a:lnTo>
-                    <a:pt x="15675952" y="0"/>
-                  </a:lnTo>
-                  <a:cubicBezTo>
-                    <a:pt x="15753527" y="0"/>
-                    <a:pt x="15827924" y="30817"/>
-                    <a:pt x="15882778" y="85670"/>
-                  </a:cubicBezTo>
-                  <a:cubicBezTo>
-                    <a:pt x="15937632" y="140524"/>
-                    <a:pt x="15968449" y="214922"/>
-                    <a:pt x="15968449" y="292497"/>
-                  </a:cubicBezTo>
-                  <a:lnTo>
-                    <a:pt x="15968449" y="2347976"/>
-                  </a:lnTo>
-                  <a:cubicBezTo>
-                    <a:pt x="15968449" y="2425551"/>
-                    <a:pt x="15937632" y="2499949"/>
-                    <a:pt x="15882778" y="2554803"/>
-                  </a:cubicBezTo>
-                  <a:cubicBezTo>
-                    <a:pt x="15827924" y="2609657"/>
-                    <a:pt x="15753527" y="2640473"/>
-                    <a:pt x="15675952" y="2640473"/>
-                  </a:cubicBezTo>
-                  <a:lnTo>
-                    <a:pt x="292497" y="2640473"/>
-                  </a:lnTo>
-                  <a:cubicBezTo>
-                    <a:pt x="214922" y="2640473"/>
-                    <a:pt x="140524" y="2609657"/>
-                    <a:pt x="85670" y="2554803"/>
-                  </a:cubicBezTo>
-                  <a:cubicBezTo>
-                    <a:pt x="30817" y="2499949"/>
-                    <a:pt x="0" y="2425551"/>
-                    <a:pt x="0" y="2347976"/>
-                  </a:cubicBezTo>
-                  <a:lnTo>
-                    <a:pt x="0" y="292497"/>
-                  </a:lnTo>
-                  <a:cubicBezTo>
-                    <a:pt x="0" y="214922"/>
-                    <a:pt x="30817" y="140524"/>
-                    <a:pt x="85670" y="85670"/>
-                  </a:cubicBezTo>
-                  <a:cubicBezTo>
-                    <a:pt x="140524" y="30817"/>
-                    <a:pt x="214922" y="0"/>
-                    <a:pt x="292497" y="0"/>
+                    <a:pt x="10430690" y="0"/>
+                  </a:lnTo>
+                  <a:cubicBezTo>
+                    <a:pt x="10668203" y="0"/>
+                    <a:pt x="10860746" y="192542"/>
+                    <a:pt x="10860746" y="430056"/>
+                  </a:cubicBezTo>
+                  <a:lnTo>
+                    <a:pt x="10860746" y="2996214"/>
+                  </a:lnTo>
+                  <a:cubicBezTo>
+                    <a:pt x="10860746" y="3233727"/>
+                    <a:pt x="10668203" y="3426269"/>
+                    <a:pt x="10430690" y="3426269"/>
+                  </a:cubicBezTo>
+                  <a:lnTo>
+                    <a:pt x="430056" y="3426269"/>
+                  </a:lnTo>
+                  <a:cubicBezTo>
+                    <a:pt x="192542" y="3426269"/>
+                    <a:pt x="0" y="3233727"/>
+                    <a:pt x="0" y="2996214"/>
+                  </a:cubicBezTo>
+                  <a:lnTo>
+                    <a:pt x="0" y="430056"/>
+                  </a:lnTo>
+                  <a:cubicBezTo>
+                    <a:pt x="0" y="192542"/>
+                    <a:pt x="192542" y="0"/>
+                    <a:pt x="430056" y="0"/>
                   </a:cubicBezTo>
                   <a:close/>
                 </a:path>
@@ -4735,8 +4839,8 @@
         </p:nvSpPr>
         <p:spPr>
           <a:xfrm rot="0">
-            <a:off x="7734372" y="7704557"/>
-            <a:ext cx="7654032" cy="838206"/>
+            <a:off x="11893762" y="5657337"/>
+            <a:ext cx="5015971" cy="1266831"/>
           </a:xfrm>
           <a:prstGeom prst="rect">
             <a:avLst/>
@@ -4764,6 +4868,145 @@
                 <a:sym typeface="Montserrat Bold"/>
               </a:rPr>
               <a:t>Frequentemente utilizada em processamento de dados e pipelines de ETL</a:t>
+            </a:r>
+          </a:p>
+        </p:txBody>
+      </p:sp>
+      <p:grpSp>
+        <p:nvGrpSpPr>
+          <p:cNvPr name="Group 12" id="12"/>
+          <p:cNvGrpSpPr/>
+          <p:nvPr/>
+        </p:nvGrpSpPr>
+        <p:grpSpPr>
+          <a:xfrm rot="0">
+            <a:off x="5285537" y="7799916"/>
+            <a:ext cx="9476058" cy="1704091"/>
+            <a:chOff x="0" y="0"/>
+            <a:chExt cx="19052957" cy="3426328"/>
+          </a:xfrm>
+        </p:grpSpPr>
+        <p:sp>
+          <p:nvSpPr>
+            <p:cNvPr name="Freeform 13" id="13"/>
+            <p:cNvSpPr/>
+            <p:nvPr/>
+          </p:nvSpPr>
+          <p:spPr>
+            <a:xfrm flipH="false" flipV="false" rot="0">
+              <a:off x="0" y="0"/>
+              <a:ext cx="19052803" cy="3426269"/>
+            </a:xfrm>
+            <a:custGeom>
+              <a:avLst/>
+              <a:gdLst/>
+              <a:ahLst/>
+              <a:cxnLst/>
+              <a:rect r="r" b="b" t="t" l="l"/>
+              <a:pathLst>
+                <a:path h="3426269" w="19052803">
+                  <a:moveTo>
+                    <a:pt x="245146" y="0"/>
+                  </a:moveTo>
+                  <a:lnTo>
+                    <a:pt x="18807657" y="0"/>
+                  </a:lnTo>
+                  <a:cubicBezTo>
+                    <a:pt x="18872673" y="0"/>
+                    <a:pt x="18935027" y="25828"/>
+                    <a:pt x="18981001" y="71802"/>
+                  </a:cubicBezTo>
+                  <a:cubicBezTo>
+                    <a:pt x="19026975" y="117776"/>
+                    <a:pt x="19052803" y="180129"/>
+                    <a:pt x="19052803" y="245146"/>
+                  </a:cubicBezTo>
+                  <a:lnTo>
+                    <a:pt x="19052803" y="3181123"/>
+                  </a:lnTo>
+                  <a:cubicBezTo>
+                    <a:pt x="19052803" y="3246140"/>
+                    <a:pt x="19026975" y="3308494"/>
+                    <a:pt x="18981001" y="3354467"/>
+                  </a:cubicBezTo>
+                  <a:cubicBezTo>
+                    <a:pt x="18935027" y="3400441"/>
+                    <a:pt x="18872673" y="3426269"/>
+                    <a:pt x="18807657" y="3426269"/>
+                  </a:cubicBezTo>
+                  <a:lnTo>
+                    <a:pt x="245146" y="3426269"/>
+                  </a:lnTo>
+                  <a:cubicBezTo>
+                    <a:pt x="180129" y="3426269"/>
+                    <a:pt x="117776" y="3400441"/>
+                    <a:pt x="71802" y="3354467"/>
+                  </a:cubicBezTo>
+                  <a:cubicBezTo>
+                    <a:pt x="25828" y="3308494"/>
+                    <a:pt x="0" y="3246140"/>
+                    <a:pt x="0" y="3181123"/>
+                  </a:cubicBezTo>
+                  <a:lnTo>
+                    <a:pt x="0" y="245146"/>
+                  </a:lnTo>
+                  <a:cubicBezTo>
+                    <a:pt x="0" y="180129"/>
+                    <a:pt x="25828" y="117776"/>
+                    <a:pt x="71802" y="71802"/>
+                  </a:cubicBezTo>
+                  <a:cubicBezTo>
+                    <a:pt x="117776" y="25828"/>
+                    <a:pt x="180129" y="0"/>
+                    <a:pt x="245146" y="0"/>
+                  </a:cubicBezTo>
+                  <a:close/>
+                </a:path>
+              </a:pathLst>
+            </a:custGeom>
+            <a:solidFill>
+              <a:srgbClr val="FFFFFF"/>
+            </a:solidFill>
+          </p:spPr>
+        </p:sp>
+      </p:grpSp>
+      <p:sp>
+        <p:nvSpPr>
+          <p:cNvPr name="TextBox 14" id="14"/>
+          <p:cNvSpPr txBox="true"/>
+          <p:nvPr/>
+        </p:nvSpPr>
+        <p:spPr>
+          <a:xfrm rot="0">
+            <a:off x="5681780" y="7999496"/>
+            <a:ext cx="8794676" cy="1266831"/>
+          </a:xfrm>
+          <a:prstGeom prst="rect">
+            <a:avLst/>
+          </a:prstGeom>
+        </p:spPr>
+        <p:txBody>
+          <a:bodyPr anchor="t" rtlCol="false" tIns="0" lIns="0" bIns="0" rIns="0">
+            <a:spAutoFit/>
+          </a:bodyPr>
+          <a:lstStyle/>
+          <a:p>
+            <a:pPr algn="just">
+              <a:lnSpc>
+                <a:spcPts val="3449"/>
+              </a:lnSpc>
+            </a:pPr>
+            <a:r>
+              <a:rPr lang="en-US" b="true" sz="2499">
+                <a:solidFill>
+                  <a:srgbClr val="47423E"/>
+                </a:solidFill>
+                <a:latin typeface="Montserrat Bold"/>
+                <a:ea typeface="Montserrat Bold"/>
+                <a:cs typeface="Montserrat Bold"/>
+                <a:sym typeface="Montserrat Bold"/>
+              </a:rPr>
+              <a:t>Cada componente é independente, pode ser modificado ou substituído sem afetar outros filtros. O que facilita a manutenção  e evolução do sistema</a:t>
             </a:r>
           </a:p>
         </p:txBody>
@@ -4808,7 +5051,7 @@
         </p:nvSpPr>
         <p:spPr>
           <a:xfrm flipH="false" flipV="false" rot="0">
-            <a:off x="235596" y="2630053"/>
+            <a:off x="111664" y="2135572"/>
             <a:ext cx="9354889" cy="5262125"/>
           </a:xfrm>
           <a:custGeom>
@@ -4826,10 +5069,10 @@
                   <a:pt x="9354889" y="0"/>
                 </a:lnTo>
                 <a:lnTo>
-                  <a:pt x="9354889" y="5262124"/>
+                  <a:pt x="9354889" y="5262125"/>
                 </a:lnTo>
                 <a:lnTo>
-                  <a:pt x="0" y="5262124"/>
+                  <a:pt x="0" y="5262125"/>
                 </a:lnTo>
                 <a:lnTo>
                   <a:pt x="0" y="0"/>
@@ -4907,7 +5150,7 @@
         </p:nvGrpSpPr>
         <p:grpSpPr>
           <a:xfrm rot="0">
-            <a:off x="10615363" y="2777956"/>
+            <a:off x="10252455" y="2606752"/>
             <a:ext cx="7352676" cy="1651790"/>
             <a:chOff x="0" y="0"/>
             <a:chExt cx="14783596" cy="3321168"/>
@@ -5067,7 +5310,7 @@
         </p:nvSpPr>
         <p:spPr>
           <a:xfrm rot="0">
-            <a:off x="10805655" y="2951386"/>
+            <a:off x="10442747" y="2780182"/>
             <a:ext cx="6998007" cy="1266831"/>
           </a:xfrm>
           <a:prstGeom prst="rect">
@@ -5108,7 +5351,7 @@
         </p:nvGrpSpPr>
         <p:grpSpPr>
           <a:xfrm rot="0">
-            <a:off x="10615363" y="4953621"/>
+            <a:off x="10279371" y="4885575"/>
             <a:ext cx="7352676" cy="1972824"/>
             <a:chOff x="0" y="0"/>
             <a:chExt cx="14783596" cy="3966655"/>
@@ -5186,7 +5429,7 @@
         </p:nvSpPr>
         <p:spPr>
           <a:xfrm rot="0">
-            <a:off x="10849107" y="5073255"/>
+            <a:off x="10513115" y="5005209"/>
             <a:ext cx="6885188" cy="1695456"/>
           </a:xfrm>
           <a:prstGeom prst="rect">
@@ -5215,6 +5458,125 @@
                 <a:sym typeface="Montserrat Bold"/>
               </a:rPr>
               <a:t>Mais comum em sistemas distribuídos, especialmente em ambientes que necessitam de alta escalabilidade e resistência</a:t>
+            </a:r>
+          </a:p>
+        </p:txBody>
+      </p:sp>
+      <p:grpSp>
+        <p:nvGrpSpPr>
+          <p:cNvPr name="Group 12" id="12"/>
+          <p:cNvGrpSpPr/>
+          <p:nvPr/>
+        </p:nvGrpSpPr>
+        <p:grpSpPr>
+          <a:xfrm rot="0">
+            <a:off x="3088478" y="7626297"/>
+            <a:ext cx="14708538" cy="2270927"/>
+            <a:chOff x="0" y="0"/>
+            <a:chExt cx="29573599" cy="4566036"/>
+          </a:xfrm>
+        </p:grpSpPr>
+        <p:sp>
+          <p:nvSpPr>
+            <p:cNvPr name="Freeform 13" id="13"/>
+            <p:cNvSpPr/>
+            <p:nvPr/>
+          </p:nvSpPr>
+          <p:spPr>
+            <a:xfrm flipH="false" flipV="false" rot="0">
+              <a:off x="0" y="0"/>
+              <a:ext cx="29573358" cy="4565957"/>
+            </a:xfrm>
+            <a:custGeom>
+              <a:avLst/>
+              <a:gdLst/>
+              <a:ahLst/>
+              <a:cxnLst/>
+              <a:rect r="r" b="b" t="t" l="l"/>
+              <a:pathLst>
+                <a:path h="4565957" w="29573358">
+                  <a:moveTo>
+                    <a:pt x="157937" y="0"/>
+                  </a:moveTo>
+                  <a:lnTo>
+                    <a:pt x="29415420" y="0"/>
+                  </a:lnTo>
+                  <a:cubicBezTo>
+                    <a:pt x="29502646" y="0"/>
+                    <a:pt x="29573358" y="70711"/>
+                    <a:pt x="29573358" y="157937"/>
+                  </a:cubicBezTo>
+                  <a:lnTo>
+                    <a:pt x="29573358" y="4408020"/>
+                  </a:lnTo>
+                  <a:cubicBezTo>
+                    <a:pt x="29573358" y="4495247"/>
+                    <a:pt x="29502646" y="4565957"/>
+                    <a:pt x="29415420" y="4565957"/>
+                  </a:cubicBezTo>
+                  <a:lnTo>
+                    <a:pt x="157937" y="4565957"/>
+                  </a:lnTo>
+                  <a:cubicBezTo>
+                    <a:pt x="70711" y="4565957"/>
+                    <a:pt x="0" y="4495247"/>
+                    <a:pt x="0" y="4408020"/>
+                  </a:cubicBezTo>
+                  <a:lnTo>
+                    <a:pt x="0" y="157937"/>
+                  </a:lnTo>
+                  <a:cubicBezTo>
+                    <a:pt x="0" y="70711"/>
+                    <a:pt x="70711" y="0"/>
+                    <a:pt x="157937" y="0"/>
+                  </a:cubicBezTo>
+                  <a:close/>
+                </a:path>
+              </a:pathLst>
+            </a:custGeom>
+            <a:solidFill>
+              <a:srgbClr val="FFFFFF"/>
+            </a:solidFill>
+          </p:spPr>
+        </p:sp>
+      </p:grpSp>
+      <p:sp>
+        <p:nvSpPr>
+          <p:cNvPr name="TextBox 14" id="14"/>
+          <p:cNvSpPr txBox="true"/>
+          <p:nvPr/>
+        </p:nvSpPr>
+        <p:spPr>
+          <a:xfrm rot="0">
+            <a:off x="3238456" y="7883472"/>
+            <a:ext cx="14366674" cy="1695456"/>
+          </a:xfrm>
+          <a:prstGeom prst="rect">
+            <a:avLst/>
+          </a:prstGeom>
+        </p:spPr>
+        <p:txBody>
+          <a:bodyPr anchor="t" rtlCol="false" tIns="0" lIns="0" bIns="0" rIns="0">
+            <a:spAutoFit/>
+          </a:bodyPr>
+          <a:lstStyle/>
+          <a:p>
+            <a:pPr algn="just">
+              <a:lnSpc>
+                <a:spcPts val="3449"/>
+              </a:lnSpc>
+            </a:pPr>
+            <a:r>
+              <a:rPr lang="en-US" b="true" sz="2499">
+                <a:solidFill>
+                  <a:srgbClr val="47423E"/>
+                </a:solidFill>
+                <a:latin typeface="Montserrat Bold"/>
+                <a:ea typeface="Montserrat Bold"/>
+                <a:cs typeface="Montserrat Bold"/>
+                <a:sym typeface="Montserrat Bold"/>
+              </a:rPr>
+              <a:t>O acoplamento fraco permite uma maior agilidade. Os microsserviços podem ser dimensionados de forma idependente, falhas nao afetam outros serviços e reduz a complexidade de fluxo de trabalho. Os eventos podem ser armazenados em buffers e registrados de maneira flexivel. Os eventos baseados em push operam em tempo real.</a:t>
             </a:r>
           </a:p>
         </p:txBody>
@@ -5538,7 +5900,7 @@
         </p:nvSpPr>
         <p:spPr>
           <a:xfrm rot="0">
-            <a:off x="10805655" y="2838869"/>
+            <a:off x="10822447" y="2882083"/>
             <a:ext cx="6732805" cy="1695456"/>
           </a:xfrm>
           <a:prstGeom prst="rect">
@@ -5579,7 +5941,7 @@
         </p:nvGrpSpPr>
         <p:grpSpPr>
           <a:xfrm rot="0">
-            <a:off x="10538333" y="4954520"/>
+            <a:off x="10555125" y="5358922"/>
             <a:ext cx="7267449" cy="1753631"/>
             <a:chOff x="0" y="0"/>
             <a:chExt cx="11500046" cy="2774964"/>
@@ -5677,7 +6039,7 @@
         </p:nvSpPr>
         <p:spPr>
           <a:xfrm rot="0">
-            <a:off x="10805655" y="5105400"/>
+            <a:off x="10822447" y="5509801"/>
             <a:ext cx="6732805" cy="1266831"/>
           </a:xfrm>
           <a:prstGeom prst="rect">
@@ -5706,6 +6068,125 @@
                 <a:sym typeface="Montserrat Bold"/>
               </a:rPr>
               <a:t>A escolha para sistemas que precisam escalar horizontalmente sem centralizar a carga de trabalho</a:t>
+            </a:r>
+          </a:p>
+        </p:txBody>
+      </p:sp>
+      <p:grpSp>
+        <p:nvGrpSpPr>
+          <p:cNvPr name="Group 12" id="12"/>
+          <p:cNvGrpSpPr/>
+          <p:nvPr/>
+        </p:nvGrpSpPr>
+        <p:grpSpPr>
+          <a:xfrm rot="0">
+            <a:off x="4873250" y="7900938"/>
+            <a:ext cx="11468806" cy="1753631"/>
+            <a:chOff x="0" y="0"/>
+            <a:chExt cx="18148293" cy="2774964"/>
+          </a:xfrm>
+        </p:grpSpPr>
+        <p:sp>
+          <p:nvSpPr>
+            <p:cNvPr name="Freeform 13" id="13"/>
+            <p:cNvSpPr/>
+            <p:nvPr/>
+          </p:nvSpPr>
+          <p:spPr>
+            <a:xfrm flipH="false" flipV="false" rot="0">
+              <a:off x="0" y="0"/>
+              <a:ext cx="18148145" cy="2774916"/>
+            </a:xfrm>
+            <a:custGeom>
+              <a:avLst/>
+              <a:gdLst/>
+              <a:ahLst/>
+              <a:cxnLst/>
+              <a:rect r="r" b="b" t="t" l="l"/>
+              <a:pathLst>
+                <a:path h="2774916" w="18148145">
+                  <a:moveTo>
+                    <a:pt x="202551" y="0"/>
+                  </a:moveTo>
+                  <a:lnTo>
+                    <a:pt x="17945595" y="0"/>
+                  </a:lnTo>
+                  <a:cubicBezTo>
+                    <a:pt x="18057461" y="0"/>
+                    <a:pt x="18148145" y="90685"/>
+                    <a:pt x="18148145" y="202551"/>
+                  </a:cubicBezTo>
+                  <a:lnTo>
+                    <a:pt x="18148145" y="2572365"/>
+                  </a:lnTo>
+                  <a:cubicBezTo>
+                    <a:pt x="18148145" y="2684231"/>
+                    <a:pt x="18057461" y="2774916"/>
+                    <a:pt x="17945595" y="2774916"/>
+                  </a:cubicBezTo>
+                  <a:lnTo>
+                    <a:pt x="202551" y="2774916"/>
+                  </a:lnTo>
+                  <a:cubicBezTo>
+                    <a:pt x="90685" y="2774916"/>
+                    <a:pt x="0" y="2684231"/>
+                    <a:pt x="0" y="2572365"/>
+                  </a:cubicBezTo>
+                  <a:lnTo>
+                    <a:pt x="0" y="202551"/>
+                  </a:lnTo>
+                  <a:cubicBezTo>
+                    <a:pt x="0" y="90685"/>
+                    <a:pt x="90685" y="0"/>
+                    <a:pt x="202551" y="0"/>
+                  </a:cubicBezTo>
+                  <a:close/>
+                </a:path>
+              </a:pathLst>
+            </a:custGeom>
+            <a:solidFill>
+              <a:srgbClr val="FFFFFF"/>
+            </a:solidFill>
+          </p:spPr>
+        </p:sp>
+      </p:grpSp>
+      <p:sp>
+        <p:nvSpPr>
+          <p:cNvPr name="TextBox 14" id="14"/>
+          <p:cNvSpPr txBox="true"/>
+          <p:nvPr/>
+        </p:nvSpPr>
+        <p:spPr>
+          <a:xfrm rot="0">
+            <a:off x="5129026" y="8125288"/>
+            <a:ext cx="10852534" cy="1266831"/>
+          </a:xfrm>
+          <a:prstGeom prst="rect">
+            <a:avLst/>
+          </a:prstGeom>
+        </p:spPr>
+        <p:txBody>
+          <a:bodyPr anchor="t" rtlCol="false" tIns="0" lIns="0" bIns="0" rIns="0">
+            <a:spAutoFit/>
+          </a:bodyPr>
+          <a:lstStyle/>
+          <a:p>
+            <a:pPr algn="just">
+              <a:lnSpc>
+                <a:spcPts val="3449"/>
+              </a:lnSpc>
+            </a:pPr>
+            <a:r>
+              <a:rPr lang="en-US" b="true" sz="2499">
+                <a:solidFill>
+                  <a:srgbClr val="47423E"/>
+                </a:solidFill>
+                <a:latin typeface="Montserrat Bold"/>
+                <a:ea typeface="Montserrat Bold"/>
+                <a:cs typeface="Montserrat Bold"/>
+                <a:sym typeface="Montserrat Bold"/>
+              </a:rPr>
+              <a:t>Perde seu banco de dados central e no lugar são utilizados grids de dados replicados em memória. Com serviços replicando banco de dados com o mesmo nome para outros serviçoes</a:t>
             </a:r>
           </a:p>
         </p:txBody>
@@ -6070,7 +6551,7 @@
         </p:nvGrpSpPr>
         <p:grpSpPr>
           <a:xfrm rot="0">
-            <a:off x="9444002" y="4971991"/>
+            <a:off x="9625456" y="5695054"/>
             <a:ext cx="7153041" cy="2655806"/>
             <a:chOff x="0" y="0"/>
             <a:chExt cx="11659305" cy="4328922"/>
@@ -6148,7 +6629,7 @@
         </p:nvSpPr>
         <p:spPr>
           <a:xfrm rot="0">
-            <a:off x="9744848" y="5218804"/>
+            <a:off x="9926302" y="5941867"/>
             <a:ext cx="6453645" cy="2124081"/>
           </a:xfrm>
           <a:prstGeom prst="rect">

</xml_diff>

<commit_message>
adição da folha guia ao README
</commit_message>
<xml_diff>
--- a/Apresentacao.pptx
+++ b/Apresentacao.pptx
@@ -44,25 +44,26 @@
     <p:sldId id="292" r:id="rId42"/>
     <p:sldId id="293" r:id="rId43"/>
     <p:sldId id="294" r:id="rId44"/>
+    <p:sldId id="295" r:id="rId45"/>
   </p:sldIdLst>
   <p:sldSz cx="18288000" cy="10287000"/>
   <p:notesSz cx="6858000" cy="9144000"/>
   <p:embeddedFontLst>
     <p:embeddedFont>
       <p:font typeface="Anton" charset="1" panose="00000500000000000000"/>
-      <p:regular r:id="rId45"/>
+      <p:regular r:id="rId46"/>
     </p:embeddedFont>
     <p:embeddedFont>
       <p:font typeface="Montserrat Bold" charset="1" panose="00000800000000000000"/>
-      <p:regular r:id="rId46"/>
+      <p:regular r:id="rId47"/>
     </p:embeddedFont>
     <p:embeddedFont>
       <p:font typeface="Montserrat" charset="1" panose="00000500000000000000"/>
-      <p:regular r:id="rId47"/>
+      <p:regular r:id="rId48"/>
     </p:embeddedFont>
     <p:embeddedFont>
       <p:font typeface="Montserrat Medium" charset="1" panose="00000600000000000000"/>
-      <p:regular r:id="rId48"/>
+      <p:regular r:id="rId49"/>
     </p:embeddedFont>
   </p:embeddedFontLst>
   <p:defaultTextStyle>
@@ -13905,7 +13906,7 @@
                 <a:cs typeface="Montserrat"/>
                 <a:sym typeface="Montserrat"/>
               </a:rPr>
-              <a:t>Tera um exemplo e leve resumo de cada uma arquiteturas. </a:t>
+              <a:t>Tera um exemplo, meio guia dos 3 modelos.</a:t>
             </a:r>
           </a:p>
           <a:p>
@@ -14193,8 +14194,8 @@
         </p:nvSpPr>
         <p:spPr>
           <a:xfrm flipH="false" flipV="false" rot="0">
-            <a:off x="266228" y="2227353"/>
-            <a:ext cx="17755545" cy="5149108"/>
+            <a:off x="5341721" y="1377292"/>
+            <a:ext cx="10118851" cy="8318462"/>
           </a:xfrm>
           <a:custGeom>
             <a:avLst/>
@@ -14203,18 +14204,18 @@
             <a:cxnLst/>
             <a:rect r="r" b="b" t="t" l="l"/>
             <a:pathLst>
-              <a:path h="5149108" w="17755545">
+              <a:path h="8318462" w="10118851">
                 <a:moveTo>
                   <a:pt x="0" y="0"/>
                 </a:moveTo>
                 <a:lnTo>
-                  <a:pt x="17755544" y="0"/>
+                  <a:pt x="10118851" y="0"/>
                 </a:lnTo>
                 <a:lnTo>
-                  <a:pt x="17755544" y="5149108"/>
+                  <a:pt x="10118851" y="8318462"/>
                 </a:lnTo>
                 <a:lnTo>
-                  <a:pt x="0" y="5149108"/>
+                  <a:pt x="0" y="8318462"/>
                 </a:lnTo>
                 <a:lnTo>
                   <a:pt x="0" y="0"/>
@@ -14231,236 +14232,47 @@
           </a:blipFill>
         </p:spPr>
       </p:sp>
-      <p:grpSp>
-        <p:nvGrpSpPr>
-          <p:cNvPr name="Group 3" id="3"/>
-          <p:cNvGrpSpPr/>
+      <p:sp>
+        <p:nvSpPr>
+          <p:cNvPr name="TextBox 3" id="3"/>
+          <p:cNvSpPr txBox="true"/>
           <p:nvPr/>
-        </p:nvGrpSpPr>
-        <p:grpSpPr>
+        </p:nvSpPr>
+        <p:spPr>
           <a:xfrm rot="0">
-            <a:off x="621952" y="3823778"/>
-            <a:ext cx="16960349" cy="3086100"/>
-            <a:chOff x="0" y="0"/>
-            <a:chExt cx="4466923" cy="812800"/>
+            <a:off x="1028700" y="904875"/>
+            <a:ext cx="3474433" cy="2422525"/>
           </a:xfrm>
-        </p:grpSpPr>
-        <p:sp>
-          <p:nvSpPr>
-            <p:cNvPr name="Freeform 4" id="4"/>
-            <p:cNvSpPr/>
-            <p:nvPr/>
-          </p:nvSpPr>
-          <p:spPr>
-            <a:xfrm flipH="false" flipV="false" rot="0">
-              <a:off x="0" y="0"/>
-              <a:ext cx="4466923" cy="812800"/>
-            </a:xfrm>
-            <a:custGeom>
-              <a:avLst/>
-              <a:gdLst/>
-              <a:ahLst/>
-              <a:cxnLst/>
-              <a:rect r="r" b="b" t="t" l="l"/>
-              <a:pathLst>
-                <a:path h="812800" w="4466923">
-                  <a:moveTo>
-                    <a:pt x="7760" y="0"/>
-                  </a:moveTo>
-                  <a:lnTo>
-                    <a:pt x="4459163" y="0"/>
-                  </a:lnTo>
-                  <a:cubicBezTo>
-                    <a:pt x="4461221" y="0"/>
-                    <a:pt x="4463195" y="818"/>
-                    <a:pt x="4464650" y="2273"/>
-                  </a:cubicBezTo>
-                  <a:cubicBezTo>
-                    <a:pt x="4466106" y="3728"/>
-                    <a:pt x="4466923" y="5702"/>
-                    <a:pt x="4466923" y="7760"/>
-                  </a:cubicBezTo>
-                  <a:lnTo>
-                    <a:pt x="4466923" y="805040"/>
-                  </a:lnTo>
-                  <a:cubicBezTo>
-                    <a:pt x="4466923" y="807098"/>
-                    <a:pt x="4466106" y="809072"/>
-                    <a:pt x="4464650" y="810527"/>
-                  </a:cubicBezTo>
-                  <a:cubicBezTo>
-                    <a:pt x="4463195" y="811982"/>
-                    <a:pt x="4461221" y="812800"/>
-                    <a:pt x="4459163" y="812800"/>
-                  </a:cubicBezTo>
-                  <a:lnTo>
-                    <a:pt x="7760" y="812800"/>
-                  </a:lnTo>
-                  <a:cubicBezTo>
-                    <a:pt x="5702" y="812800"/>
-                    <a:pt x="3728" y="811982"/>
-                    <a:pt x="2273" y="810527"/>
-                  </a:cubicBezTo>
-                  <a:cubicBezTo>
-                    <a:pt x="818" y="809072"/>
-                    <a:pt x="0" y="807098"/>
-                    <a:pt x="0" y="805040"/>
-                  </a:cubicBezTo>
-                  <a:lnTo>
-                    <a:pt x="0" y="7760"/>
-                  </a:lnTo>
-                  <a:cubicBezTo>
-                    <a:pt x="0" y="5702"/>
-                    <a:pt x="818" y="3728"/>
-                    <a:pt x="2273" y="2273"/>
-                  </a:cubicBezTo>
-                  <a:cubicBezTo>
-                    <a:pt x="3728" y="818"/>
-                    <a:pt x="5702" y="0"/>
-                    <a:pt x="7760" y="0"/>
-                  </a:cubicBezTo>
-                  <a:close/>
-                </a:path>
-              </a:pathLst>
-            </a:custGeom>
-            <a:solidFill>
-              <a:srgbClr val="233D89"/>
-            </a:solidFill>
-          </p:spPr>
-        </p:sp>
-        <p:sp>
-          <p:nvSpPr>
-            <p:cNvPr name="TextBox 5" id="5"/>
-            <p:cNvSpPr txBox="true"/>
-            <p:nvPr/>
-          </p:nvSpPr>
-          <p:spPr>
-            <a:xfrm>
-              <a:off x="0" y="-38100"/>
-              <a:ext cx="4466923" cy="850900"/>
-            </a:xfrm>
-            <a:prstGeom prst="rect">
-              <a:avLst/>
-            </a:prstGeom>
-          </p:spPr>
-          <p:txBody>
-            <a:bodyPr anchor="ctr" rtlCol="false" tIns="50800" lIns="50800" bIns="50800" rIns="50800"/>
-            <a:lstStyle/>
-            <a:p>
-              <a:pPr algn="ctr">
-                <a:lnSpc>
-                  <a:spcPts val="3449"/>
-                </a:lnSpc>
-              </a:pPr>
-            </a:p>
-          </p:txBody>
-        </p:sp>
-      </p:grpSp>
-      <p:grpSp>
-        <p:nvGrpSpPr>
-          <p:cNvPr name="Group 6" id="6"/>
-          <p:cNvGrpSpPr/>
-          <p:nvPr/>
-        </p:nvGrpSpPr>
-        <p:grpSpPr>
-          <a:xfrm rot="0">
-            <a:off x="7027534" y="2929328"/>
-            <a:ext cx="10776956" cy="3086100"/>
-            <a:chOff x="0" y="0"/>
-            <a:chExt cx="2838375" cy="812800"/>
-          </a:xfrm>
-        </p:grpSpPr>
-        <p:sp>
-          <p:nvSpPr>
-            <p:cNvPr name="Freeform 7" id="7"/>
-            <p:cNvSpPr/>
-            <p:nvPr/>
-          </p:nvSpPr>
-          <p:spPr>
-            <a:xfrm flipH="false" flipV="false" rot="0">
-              <a:off x="0" y="0"/>
-              <a:ext cx="2838375" cy="812800"/>
-            </a:xfrm>
-            <a:custGeom>
-              <a:avLst/>
-              <a:gdLst/>
-              <a:ahLst/>
-              <a:cxnLst/>
-              <a:rect r="r" b="b" t="t" l="l"/>
-              <a:pathLst>
-                <a:path h="812800" w="2838375">
-                  <a:moveTo>
-                    <a:pt x="12212" y="0"/>
-                  </a:moveTo>
-                  <a:lnTo>
-                    <a:pt x="2826163" y="0"/>
-                  </a:lnTo>
-                  <a:cubicBezTo>
-                    <a:pt x="2832908" y="0"/>
-                    <a:pt x="2838375" y="5468"/>
-                    <a:pt x="2838375" y="12212"/>
-                  </a:cubicBezTo>
-                  <a:lnTo>
-                    <a:pt x="2838375" y="800588"/>
-                  </a:lnTo>
-                  <a:cubicBezTo>
-                    <a:pt x="2838375" y="807332"/>
-                    <a:pt x="2832908" y="812800"/>
-                    <a:pt x="2826163" y="812800"/>
-                  </a:cubicBezTo>
-                  <a:lnTo>
-                    <a:pt x="12212" y="812800"/>
-                  </a:lnTo>
-                  <a:cubicBezTo>
-                    <a:pt x="5468" y="812800"/>
-                    <a:pt x="0" y="807332"/>
-                    <a:pt x="0" y="800588"/>
-                  </a:cubicBezTo>
-                  <a:lnTo>
-                    <a:pt x="0" y="12212"/>
-                  </a:lnTo>
-                  <a:cubicBezTo>
-                    <a:pt x="0" y="5468"/>
-                    <a:pt x="5468" y="0"/>
-                    <a:pt x="12212" y="0"/>
-                  </a:cubicBezTo>
-                  <a:close/>
-                </a:path>
-              </a:pathLst>
-            </a:custGeom>
-            <a:solidFill>
-              <a:srgbClr val="233D89"/>
-            </a:solidFill>
-          </p:spPr>
-        </p:sp>
-        <p:sp>
-          <p:nvSpPr>
-            <p:cNvPr name="TextBox 8" id="8"/>
-            <p:cNvSpPr txBox="true"/>
-            <p:nvPr/>
-          </p:nvSpPr>
-          <p:spPr>
-            <a:xfrm>
-              <a:off x="0" y="-38100"/>
-              <a:ext cx="2838375" cy="850900"/>
-            </a:xfrm>
-            <a:prstGeom prst="rect">
-              <a:avLst/>
-            </a:prstGeom>
-          </p:spPr>
-          <p:txBody>
-            <a:bodyPr anchor="ctr" rtlCol="false" tIns="50800" lIns="50800" bIns="50800" rIns="50800"/>
-            <a:lstStyle/>
-            <a:p>
-              <a:pPr algn="ctr">
-                <a:lnSpc>
-                  <a:spcPts val="3449"/>
-                </a:lnSpc>
-              </a:pPr>
-            </a:p>
-          </p:txBody>
-        </p:sp>
-      </p:grpSp>
+          <a:prstGeom prst="rect">
+            <a:avLst/>
+          </a:prstGeom>
+        </p:spPr>
+        <p:txBody>
+          <a:bodyPr anchor="t" rtlCol="false" tIns="0" lIns="0" bIns="0" rIns="0">
+            <a:spAutoFit/>
+          </a:bodyPr>
+          <a:lstStyle/>
+          <a:p>
+            <a:pPr algn="ctr">
+              <a:lnSpc>
+                <a:spcPts val="9799"/>
+              </a:lnSpc>
+            </a:pPr>
+            <a:r>
+              <a:rPr lang="en-US" sz="6999">
+                <a:solidFill>
+                  <a:srgbClr val="FFFFFF"/>
+                </a:solidFill>
+                <a:latin typeface="Anton"/>
+                <a:ea typeface="Anton"/>
+                <a:cs typeface="Anton"/>
+                <a:sym typeface="Anton"/>
+              </a:rPr>
+              <a:t>Exemplos:</a:t>
+            </a:r>
+          </a:p>
+        </p:txBody>
+      </p:sp>
     </p:spTree>
   </p:cSld>
   <p:clrMapOvr>
@@ -15055,7 +14867,7 @@
         </p:nvSpPr>
         <p:spPr>
           <a:xfrm flipH="false" flipV="false" rot="0">
-            <a:off x="266228" y="2227353"/>
+            <a:off x="266228" y="4109192"/>
             <a:ext cx="17755545" cy="5149108"/>
           </a:xfrm>
           <a:custGeom>
@@ -15101,10 +14913,10 @@
         </p:nvGrpSpPr>
         <p:grpSpPr>
           <a:xfrm rot="0">
-            <a:off x="621952" y="3823778"/>
-            <a:ext cx="16960349" cy="3086100"/>
+            <a:off x="646563" y="5840027"/>
+            <a:ext cx="16994873" cy="3086100"/>
             <a:chOff x="0" y="0"/>
-            <a:chExt cx="4466923" cy="812800"/>
+            <a:chExt cx="4476016" cy="812800"/>
           </a:xfrm>
         </p:grpSpPr>
         <p:sp>
@@ -15116,7 +14928,7 @@
           <p:spPr>
             <a:xfrm flipH="false" flipV="false" rot="0">
               <a:off x="0" y="0"/>
-              <a:ext cx="4466923" cy="812800"/>
+              <a:ext cx="4476016" cy="812800"/>
             </a:xfrm>
             <a:custGeom>
               <a:avLst/>
@@ -15125,61 +14937,61 @@
               <a:cxnLst/>
               <a:rect r="r" b="b" t="t" l="l"/>
               <a:pathLst>
-                <a:path h="812800" w="4466923">
+                <a:path h="812800" w="4476016">
                   <a:moveTo>
-                    <a:pt x="7760" y="0"/>
+                    <a:pt x="7744" y="0"/>
                   </a:moveTo>
                   <a:lnTo>
-                    <a:pt x="4459163" y="0"/>
-                  </a:lnTo>
-                  <a:cubicBezTo>
-                    <a:pt x="4461221" y="0"/>
-                    <a:pt x="4463195" y="818"/>
-                    <a:pt x="4464650" y="2273"/>
-                  </a:cubicBezTo>
-                  <a:cubicBezTo>
-                    <a:pt x="4466106" y="3728"/>
-                    <a:pt x="4466923" y="5702"/>
-                    <a:pt x="4466923" y="7760"/>
-                  </a:cubicBezTo>
-                  <a:lnTo>
-                    <a:pt x="4466923" y="805040"/>
-                  </a:lnTo>
-                  <a:cubicBezTo>
-                    <a:pt x="4466923" y="807098"/>
-                    <a:pt x="4466106" y="809072"/>
-                    <a:pt x="4464650" y="810527"/>
-                  </a:cubicBezTo>
-                  <a:cubicBezTo>
-                    <a:pt x="4463195" y="811982"/>
-                    <a:pt x="4461221" y="812800"/>
-                    <a:pt x="4459163" y="812800"/>
-                  </a:cubicBezTo>
-                  <a:lnTo>
-                    <a:pt x="7760" y="812800"/>
-                  </a:lnTo>
-                  <a:cubicBezTo>
-                    <a:pt x="5702" y="812800"/>
-                    <a:pt x="3728" y="811982"/>
-                    <a:pt x="2273" y="810527"/>
-                  </a:cubicBezTo>
-                  <a:cubicBezTo>
-                    <a:pt x="818" y="809072"/>
-                    <a:pt x="0" y="807098"/>
-                    <a:pt x="0" y="805040"/>
-                  </a:cubicBezTo>
-                  <a:lnTo>
-                    <a:pt x="0" y="7760"/>
-                  </a:lnTo>
-                  <a:cubicBezTo>
-                    <a:pt x="0" y="5702"/>
-                    <a:pt x="818" y="3728"/>
-                    <a:pt x="2273" y="2273"/>
-                  </a:cubicBezTo>
-                  <a:cubicBezTo>
-                    <a:pt x="3728" y="818"/>
-                    <a:pt x="5702" y="0"/>
-                    <a:pt x="7760" y="0"/>
+                    <a:pt x="4468272" y="0"/>
+                  </a:lnTo>
+                  <a:cubicBezTo>
+                    <a:pt x="4470326" y="0"/>
+                    <a:pt x="4472295" y="816"/>
+                    <a:pt x="4473748" y="2268"/>
+                  </a:cubicBezTo>
+                  <a:cubicBezTo>
+                    <a:pt x="4475200" y="3721"/>
+                    <a:pt x="4476016" y="5690"/>
+                    <a:pt x="4476016" y="7744"/>
+                  </a:cubicBezTo>
+                  <a:lnTo>
+                    <a:pt x="4476016" y="805056"/>
+                  </a:lnTo>
+                  <a:cubicBezTo>
+                    <a:pt x="4476016" y="807110"/>
+                    <a:pt x="4475200" y="809079"/>
+                    <a:pt x="4473748" y="810532"/>
+                  </a:cubicBezTo>
+                  <a:cubicBezTo>
+                    <a:pt x="4472295" y="811984"/>
+                    <a:pt x="4470326" y="812800"/>
+                    <a:pt x="4468272" y="812800"/>
+                  </a:cubicBezTo>
+                  <a:lnTo>
+                    <a:pt x="7744" y="812800"/>
+                  </a:lnTo>
+                  <a:cubicBezTo>
+                    <a:pt x="5690" y="812800"/>
+                    <a:pt x="3721" y="811984"/>
+                    <a:pt x="2268" y="810532"/>
+                  </a:cubicBezTo>
+                  <a:cubicBezTo>
+                    <a:pt x="816" y="809079"/>
+                    <a:pt x="0" y="807110"/>
+                    <a:pt x="0" y="805056"/>
+                  </a:cubicBezTo>
+                  <a:lnTo>
+                    <a:pt x="0" y="7744"/>
+                  </a:lnTo>
+                  <a:cubicBezTo>
+                    <a:pt x="0" y="5690"/>
+                    <a:pt x="816" y="3721"/>
+                    <a:pt x="2268" y="2268"/>
+                  </a:cubicBezTo>
+                  <a:cubicBezTo>
+                    <a:pt x="3721" y="816"/>
+                    <a:pt x="5690" y="0"/>
+                    <a:pt x="7744" y="0"/>
                   </a:cubicBezTo>
                   <a:close/>
                 </a:path>
@@ -15199,7 +15011,7 @@
           <p:spPr>
             <a:xfrm>
               <a:off x="0" y="-38100"/>
-              <a:ext cx="4466923" cy="850900"/>
+              <a:ext cx="4476016" cy="850900"/>
             </a:xfrm>
             <a:prstGeom prst="rect">
               <a:avLst/>
@@ -15226,10 +15038,10 @@
         </p:nvGrpSpPr>
         <p:grpSpPr>
           <a:xfrm rot="0">
-            <a:off x="11563883" y="2957244"/>
-            <a:ext cx="6324355" cy="3086100"/>
+            <a:off x="7345264" y="4109192"/>
+            <a:ext cx="10296173" cy="3086100"/>
             <a:chOff x="0" y="0"/>
-            <a:chExt cx="1665674" cy="812800"/>
+            <a:chExt cx="2711749" cy="812800"/>
           </a:xfrm>
         </p:grpSpPr>
         <p:sp>
@@ -15241,7 +15053,7 @@
           <p:spPr>
             <a:xfrm flipH="false" flipV="false" rot="0">
               <a:off x="0" y="0"/>
-              <a:ext cx="1665674" cy="812800"/>
+              <a:ext cx="2711749" cy="812800"/>
             </a:xfrm>
             <a:custGeom>
               <a:avLst/>
@@ -15250,61 +15062,61 @@
               <a:cxnLst/>
               <a:rect r="r" b="b" t="t" l="l"/>
               <a:pathLst>
-                <a:path h="812800" w="1665674">
+                <a:path h="812800" w="2711749">
                   <a:moveTo>
-                    <a:pt x="20810" y="0"/>
+                    <a:pt x="12783" y="0"/>
                   </a:moveTo>
                   <a:lnTo>
-                    <a:pt x="1644863" y="0"/>
-                  </a:lnTo>
-                  <a:cubicBezTo>
-                    <a:pt x="1650383" y="0"/>
-                    <a:pt x="1655676" y="2193"/>
-                    <a:pt x="1659579" y="6095"/>
-                  </a:cubicBezTo>
-                  <a:cubicBezTo>
-                    <a:pt x="1663481" y="9998"/>
-                    <a:pt x="1665674" y="15291"/>
-                    <a:pt x="1665674" y="20810"/>
-                  </a:cubicBezTo>
-                  <a:lnTo>
-                    <a:pt x="1665674" y="791990"/>
-                  </a:lnTo>
-                  <a:cubicBezTo>
-                    <a:pt x="1665674" y="797509"/>
-                    <a:pt x="1663481" y="802802"/>
-                    <a:pt x="1659579" y="806705"/>
-                  </a:cubicBezTo>
-                  <a:cubicBezTo>
-                    <a:pt x="1655676" y="810607"/>
-                    <a:pt x="1650383" y="812800"/>
-                    <a:pt x="1644863" y="812800"/>
-                  </a:cubicBezTo>
-                  <a:lnTo>
-                    <a:pt x="20810" y="812800"/>
-                  </a:lnTo>
-                  <a:cubicBezTo>
-                    <a:pt x="15291" y="812800"/>
-                    <a:pt x="9998" y="810607"/>
-                    <a:pt x="6095" y="806705"/>
-                  </a:cubicBezTo>
-                  <a:cubicBezTo>
-                    <a:pt x="2193" y="802802"/>
-                    <a:pt x="0" y="797509"/>
-                    <a:pt x="0" y="791990"/>
-                  </a:cubicBezTo>
-                  <a:lnTo>
-                    <a:pt x="0" y="20810"/>
-                  </a:lnTo>
-                  <a:cubicBezTo>
-                    <a:pt x="0" y="15291"/>
-                    <a:pt x="2193" y="9998"/>
-                    <a:pt x="6095" y="6095"/>
-                  </a:cubicBezTo>
-                  <a:cubicBezTo>
-                    <a:pt x="9998" y="2193"/>
-                    <a:pt x="15291" y="0"/>
-                    <a:pt x="20810" y="0"/>
+                    <a:pt x="2698966" y="0"/>
+                  </a:lnTo>
+                  <a:cubicBezTo>
+                    <a:pt x="2702357" y="0"/>
+                    <a:pt x="2705608" y="1347"/>
+                    <a:pt x="2708005" y="3744"/>
+                  </a:cubicBezTo>
+                  <a:cubicBezTo>
+                    <a:pt x="2710402" y="6141"/>
+                    <a:pt x="2711749" y="9392"/>
+                    <a:pt x="2711749" y="12783"/>
+                  </a:cubicBezTo>
+                  <a:lnTo>
+                    <a:pt x="2711749" y="800017"/>
+                  </a:lnTo>
+                  <a:cubicBezTo>
+                    <a:pt x="2711749" y="803408"/>
+                    <a:pt x="2710402" y="806659"/>
+                    <a:pt x="2708005" y="809056"/>
+                  </a:cubicBezTo>
+                  <a:cubicBezTo>
+                    <a:pt x="2705608" y="811453"/>
+                    <a:pt x="2702357" y="812800"/>
+                    <a:pt x="2698966" y="812800"/>
+                  </a:cubicBezTo>
+                  <a:lnTo>
+                    <a:pt x="12783" y="812800"/>
+                  </a:lnTo>
+                  <a:cubicBezTo>
+                    <a:pt x="9392" y="812800"/>
+                    <a:pt x="6141" y="811453"/>
+                    <a:pt x="3744" y="809056"/>
+                  </a:cubicBezTo>
+                  <a:cubicBezTo>
+                    <a:pt x="1347" y="806659"/>
+                    <a:pt x="0" y="803408"/>
+                    <a:pt x="0" y="800017"/>
+                  </a:cubicBezTo>
+                  <a:lnTo>
+                    <a:pt x="0" y="12783"/>
+                  </a:lnTo>
+                  <a:cubicBezTo>
+                    <a:pt x="0" y="9392"/>
+                    <a:pt x="1347" y="6141"/>
+                    <a:pt x="3744" y="3744"/>
+                  </a:cubicBezTo>
+                  <a:cubicBezTo>
+                    <a:pt x="6141" y="1347"/>
+                    <a:pt x="9392" y="0"/>
+                    <a:pt x="12783" y="0"/>
                   </a:cubicBezTo>
                   <a:close/>
                 </a:path>
@@ -15324,7 +15136,7 @@
           <p:spPr>
             <a:xfrm>
               <a:off x="0" y="-38100"/>
-              <a:ext cx="1665674" cy="850900"/>
+              <a:ext cx="2711749" cy="850900"/>
             </a:xfrm>
             <a:prstGeom prst="rect">
               <a:avLst/>
@@ -15383,7 +15195,7 @@
         </p:nvSpPr>
         <p:spPr>
           <a:xfrm flipH="false" flipV="false" rot="0">
-            <a:off x="266228" y="2227353"/>
+            <a:off x="266228" y="4109192"/>
             <a:ext cx="17755545" cy="5149108"/>
           </a:xfrm>
           <a:custGeom>
@@ -15429,10 +15241,10 @@
         </p:nvGrpSpPr>
         <p:grpSpPr>
           <a:xfrm rot="0">
-            <a:off x="663826" y="4577510"/>
-            <a:ext cx="16960349" cy="3086100"/>
+            <a:off x="646563" y="5840027"/>
+            <a:ext cx="16994873" cy="3086100"/>
             <a:chOff x="0" y="0"/>
-            <a:chExt cx="4466923" cy="812800"/>
+            <a:chExt cx="4476016" cy="812800"/>
           </a:xfrm>
         </p:grpSpPr>
         <p:sp>
@@ -15444,7 +15256,7 @@
           <p:spPr>
             <a:xfrm flipH="false" flipV="false" rot="0">
               <a:off x="0" y="0"/>
-              <a:ext cx="4466923" cy="812800"/>
+              <a:ext cx="4476016" cy="812800"/>
             </a:xfrm>
             <a:custGeom>
               <a:avLst/>
@@ -15453,61 +15265,61 @@
               <a:cxnLst/>
               <a:rect r="r" b="b" t="t" l="l"/>
               <a:pathLst>
-                <a:path h="812800" w="4466923">
+                <a:path h="812800" w="4476016">
                   <a:moveTo>
-                    <a:pt x="7760" y="0"/>
+                    <a:pt x="7744" y="0"/>
                   </a:moveTo>
                   <a:lnTo>
-                    <a:pt x="4459163" y="0"/>
-                  </a:lnTo>
-                  <a:cubicBezTo>
-                    <a:pt x="4461221" y="0"/>
-                    <a:pt x="4463195" y="818"/>
-                    <a:pt x="4464650" y="2273"/>
-                  </a:cubicBezTo>
-                  <a:cubicBezTo>
-                    <a:pt x="4466106" y="3728"/>
-                    <a:pt x="4466923" y="5702"/>
-                    <a:pt x="4466923" y="7760"/>
-                  </a:cubicBezTo>
-                  <a:lnTo>
-                    <a:pt x="4466923" y="805040"/>
-                  </a:lnTo>
-                  <a:cubicBezTo>
-                    <a:pt x="4466923" y="807098"/>
-                    <a:pt x="4466106" y="809072"/>
-                    <a:pt x="4464650" y="810527"/>
-                  </a:cubicBezTo>
-                  <a:cubicBezTo>
-                    <a:pt x="4463195" y="811982"/>
-                    <a:pt x="4461221" y="812800"/>
-                    <a:pt x="4459163" y="812800"/>
-                  </a:cubicBezTo>
-                  <a:lnTo>
-                    <a:pt x="7760" y="812800"/>
-                  </a:lnTo>
-                  <a:cubicBezTo>
-                    <a:pt x="5702" y="812800"/>
-                    <a:pt x="3728" y="811982"/>
-                    <a:pt x="2273" y="810527"/>
-                  </a:cubicBezTo>
-                  <a:cubicBezTo>
-                    <a:pt x="818" y="809072"/>
-                    <a:pt x="0" y="807098"/>
-                    <a:pt x="0" y="805040"/>
-                  </a:cubicBezTo>
-                  <a:lnTo>
-                    <a:pt x="0" y="7760"/>
-                  </a:lnTo>
-                  <a:cubicBezTo>
-                    <a:pt x="0" y="5702"/>
-                    <a:pt x="818" y="3728"/>
-                    <a:pt x="2273" y="2273"/>
-                  </a:cubicBezTo>
-                  <a:cubicBezTo>
-                    <a:pt x="3728" y="818"/>
-                    <a:pt x="5702" y="0"/>
-                    <a:pt x="7760" y="0"/>
+                    <a:pt x="4468272" y="0"/>
+                  </a:lnTo>
+                  <a:cubicBezTo>
+                    <a:pt x="4470326" y="0"/>
+                    <a:pt x="4472295" y="816"/>
+                    <a:pt x="4473748" y="2268"/>
+                  </a:cubicBezTo>
+                  <a:cubicBezTo>
+                    <a:pt x="4475200" y="3721"/>
+                    <a:pt x="4476016" y="5690"/>
+                    <a:pt x="4476016" y="7744"/>
+                  </a:cubicBezTo>
+                  <a:lnTo>
+                    <a:pt x="4476016" y="805056"/>
+                  </a:lnTo>
+                  <a:cubicBezTo>
+                    <a:pt x="4476016" y="807110"/>
+                    <a:pt x="4475200" y="809079"/>
+                    <a:pt x="4473748" y="810532"/>
+                  </a:cubicBezTo>
+                  <a:cubicBezTo>
+                    <a:pt x="4472295" y="811984"/>
+                    <a:pt x="4470326" y="812800"/>
+                    <a:pt x="4468272" y="812800"/>
+                  </a:cubicBezTo>
+                  <a:lnTo>
+                    <a:pt x="7744" y="812800"/>
+                  </a:lnTo>
+                  <a:cubicBezTo>
+                    <a:pt x="5690" y="812800"/>
+                    <a:pt x="3721" y="811984"/>
+                    <a:pt x="2268" y="810532"/>
+                  </a:cubicBezTo>
+                  <a:cubicBezTo>
+                    <a:pt x="816" y="809079"/>
+                    <a:pt x="0" y="807110"/>
+                    <a:pt x="0" y="805056"/>
+                  </a:cubicBezTo>
+                  <a:lnTo>
+                    <a:pt x="0" y="7744"/>
+                  </a:lnTo>
+                  <a:cubicBezTo>
+                    <a:pt x="0" y="5690"/>
+                    <a:pt x="816" y="3721"/>
+                    <a:pt x="2268" y="2268"/>
+                  </a:cubicBezTo>
+                  <a:cubicBezTo>
+                    <a:pt x="3721" y="816"/>
+                    <a:pt x="5690" y="0"/>
+                    <a:pt x="7744" y="0"/>
                   </a:cubicBezTo>
                   <a:close/>
                 </a:path>
@@ -15527,7 +15339,7 @@
           <p:spPr>
             <a:xfrm>
               <a:off x="0" y="-38100"/>
-              <a:ext cx="4466923" cy="850900"/>
+              <a:ext cx="4476016" cy="850900"/>
             </a:xfrm>
             <a:prstGeom prst="rect">
               <a:avLst/>
@@ -15554,10 +15366,10 @@
         </p:nvGrpSpPr>
         <p:grpSpPr>
           <a:xfrm rot="0">
-            <a:off x="1327651" y="3921484"/>
-            <a:ext cx="16960349" cy="3086100"/>
+            <a:off x="11574537" y="4109192"/>
+            <a:ext cx="6066900" cy="3086100"/>
             <a:chOff x="0" y="0"/>
-            <a:chExt cx="4466923" cy="812800"/>
+            <a:chExt cx="1597867" cy="812800"/>
           </a:xfrm>
         </p:grpSpPr>
         <p:sp>
@@ -15569,7 +15381,7 @@
           <p:spPr>
             <a:xfrm flipH="false" flipV="false" rot="0">
               <a:off x="0" y="0"/>
-              <a:ext cx="4466923" cy="812800"/>
+              <a:ext cx="1597867" cy="812800"/>
             </a:xfrm>
             <a:custGeom>
               <a:avLst/>
@@ -15578,61 +15390,46 @@
               <a:cxnLst/>
               <a:rect r="r" b="b" t="t" l="l"/>
               <a:pathLst>
-                <a:path h="812800" w="4466923">
+                <a:path h="812800" w="1597867">
                   <a:moveTo>
-                    <a:pt x="7760" y="0"/>
+                    <a:pt x="21694" y="0"/>
                   </a:moveTo>
                   <a:lnTo>
-                    <a:pt x="4459163" y="0"/>
-                  </a:lnTo>
-                  <a:cubicBezTo>
-                    <a:pt x="4461221" y="0"/>
-                    <a:pt x="4463195" y="818"/>
-                    <a:pt x="4464650" y="2273"/>
-                  </a:cubicBezTo>
-                  <a:cubicBezTo>
-                    <a:pt x="4466106" y="3728"/>
-                    <a:pt x="4466923" y="5702"/>
-                    <a:pt x="4466923" y="7760"/>
-                  </a:cubicBezTo>
-                  <a:lnTo>
-                    <a:pt x="4466923" y="805040"/>
-                  </a:lnTo>
-                  <a:cubicBezTo>
-                    <a:pt x="4466923" y="807098"/>
-                    <a:pt x="4466106" y="809072"/>
-                    <a:pt x="4464650" y="810527"/>
-                  </a:cubicBezTo>
-                  <a:cubicBezTo>
-                    <a:pt x="4463195" y="811982"/>
-                    <a:pt x="4461221" y="812800"/>
-                    <a:pt x="4459163" y="812800"/>
-                  </a:cubicBezTo>
-                  <a:lnTo>
-                    <a:pt x="7760" y="812800"/>
-                  </a:lnTo>
-                  <a:cubicBezTo>
-                    <a:pt x="5702" y="812800"/>
-                    <a:pt x="3728" y="811982"/>
-                    <a:pt x="2273" y="810527"/>
-                  </a:cubicBezTo>
-                  <a:cubicBezTo>
-                    <a:pt x="818" y="809072"/>
-                    <a:pt x="0" y="807098"/>
-                    <a:pt x="0" y="805040"/>
-                  </a:cubicBezTo>
-                  <a:lnTo>
-                    <a:pt x="0" y="7760"/>
-                  </a:lnTo>
-                  <a:cubicBezTo>
-                    <a:pt x="0" y="5702"/>
-                    <a:pt x="818" y="3728"/>
-                    <a:pt x="2273" y="2273"/>
-                  </a:cubicBezTo>
-                  <a:cubicBezTo>
-                    <a:pt x="3728" y="818"/>
-                    <a:pt x="5702" y="0"/>
-                    <a:pt x="7760" y="0"/>
+                    <a:pt x="1576173" y="0"/>
+                  </a:lnTo>
+                  <a:cubicBezTo>
+                    <a:pt x="1588154" y="0"/>
+                    <a:pt x="1597867" y="9713"/>
+                    <a:pt x="1597867" y="21694"/>
+                  </a:cubicBezTo>
+                  <a:lnTo>
+                    <a:pt x="1597867" y="791106"/>
+                  </a:lnTo>
+                  <a:cubicBezTo>
+                    <a:pt x="1597867" y="796860"/>
+                    <a:pt x="1595581" y="802378"/>
+                    <a:pt x="1591513" y="806446"/>
+                  </a:cubicBezTo>
+                  <a:cubicBezTo>
+                    <a:pt x="1587444" y="810514"/>
+                    <a:pt x="1581927" y="812800"/>
+                    <a:pt x="1576173" y="812800"/>
+                  </a:cubicBezTo>
+                  <a:lnTo>
+                    <a:pt x="21694" y="812800"/>
+                  </a:lnTo>
+                  <a:cubicBezTo>
+                    <a:pt x="9713" y="812800"/>
+                    <a:pt x="0" y="803087"/>
+                    <a:pt x="0" y="791106"/>
+                  </a:cubicBezTo>
+                  <a:lnTo>
+                    <a:pt x="0" y="21694"/>
+                  </a:lnTo>
+                  <a:cubicBezTo>
+                    <a:pt x="0" y="9713"/>
+                    <a:pt x="9713" y="0"/>
+                    <a:pt x="21694" y="0"/>
                   </a:cubicBezTo>
                   <a:close/>
                 </a:path>
@@ -15652,7 +15449,7 @@
           <p:spPr>
             <a:xfrm>
               <a:off x="0" y="-38100"/>
-              <a:ext cx="4466923" cy="850900"/>
+              <a:ext cx="1597867" cy="850900"/>
             </a:xfrm>
             <a:prstGeom prst="rect">
               <a:avLst/>
@@ -15711,7 +15508,7 @@
         </p:nvSpPr>
         <p:spPr>
           <a:xfrm flipH="false" flipV="false" rot="0">
-            <a:off x="266228" y="2227353"/>
+            <a:off x="266228" y="4109192"/>
             <a:ext cx="17755545" cy="5149108"/>
           </a:xfrm>
           <a:custGeom>
@@ -15757,10 +15554,10 @@
         </p:nvGrpSpPr>
         <p:grpSpPr>
           <a:xfrm rot="0">
-            <a:off x="663826" y="4577510"/>
-            <a:ext cx="16960349" cy="3086100"/>
+            <a:off x="646563" y="5840027"/>
+            <a:ext cx="16994873" cy="3086100"/>
             <a:chOff x="0" y="0"/>
-            <a:chExt cx="4466923" cy="812800"/>
+            <a:chExt cx="4476016" cy="812800"/>
           </a:xfrm>
         </p:grpSpPr>
         <p:sp>
@@ -15772,7 +15569,7 @@
           <p:spPr>
             <a:xfrm flipH="false" flipV="false" rot="0">
               <a:off x="0" y="0"/>
-              <a:ext cx="4466923" cy="812800"/>
+              <a:ext cx="4476016" cy="812800"/>
             </a:xfrm>
             <a:custGeom>
               <a:avLst/>
@@ -15781,61 +15578,61 @@
               <a:cxnLst/>
               <a:rect r="r" b="b" t="t" l="l"/>
               <a:pathLst>
-                <a:path h="812800" w="4466923">
+                <a:path h="812800" w="4476016">
                   <a:moveTo>
-                    <a:pt x="7760" y="0"/>
+                    <a:pt x="7744" y="0"/>
                   </a:moveTo>
                   <a:lnTo>
-                    <a:pt x="4459163" y="0"/>
-                  </a:lnTo>
-                  <a:cubicBezTo>
-                    <a:pt x="4461221" y="0"/>
-                    <a:pt x="4463195" y="818"/>
-                    <a:pt x="4464650" y="2273"/>
-                  </a:cubicBezTo>
-                  <a:cubicBezTo>
-                    <a:pt x="4466106" y="3728"/>
-                    <a:pt x="4466923" y="5702"/>
-                    <a:pt x="4466923" y="7760"/>
-                  </a:cubicBezTo>
-                  <a:lnTo>
-                    <a:pt x="4466923" y="805040"/>
-                  </a:lnTo>
-                  <a:cubicBezTo>
-                    <a:pt x="4466923" y="807098"/>
-                    <a:pt x="4466106" y="809072"/>
-                    <a:pt x="4464650" y="810527"/>
-                  </a:cubicBezTo>
-                  <a:cubicBezTo>
-                    <a:pt x="4463195" y="811982"/>
-                    <a:pt x="4461221" y="812800"/>
-                    <a:pt x="4459163" y="812800"/>
-                  </a:cubicBezTo>
-                  <a:lnTo>
-                    <a:pt x="7760" y="812800"/>
-                  </a:lnTo>
-                  <a:cubicBezTo>
-                    <a:pt x="5702" y="812800"/>
-                    <a:pt x="3728" y="811982"/>
-                    <a:pt x="2273" y="810527"/>
-                  </a:cubicBezTo>
-                  <a:cubicBezTo>
-                    <a:pt x="818" y="809072"/>
-                    <a:pt x="0" y="807098"/>
-                    <a:pt x="0" y="805040"/>
-                  </a:cubicBezTo>
-                  <a:lnTo>
-                    <a:pt x="0" y="7760"/>
-                  </a:lnTo>
-                  <a:cubicBezTo>
-                    <a:pt x="0" y="5702"/>
-                    <a:pt x="818" y="3728"/>
-                    <a:pt x="2273" y="2273"/>
-                  </a:cubicBezTo>
-                  <a:cubicBezTo>
-                    <a:pt x="3728" y="818"/>
-                    <a:pt x="5702" y="0"/>
-                    <a:pt x="7760" y="0"/>
+                    <a:pt x="4468272" y="0"/>
+                  </a:lnTo>
+                  <a:cubicBezTo>
+                    <a:pt x="4470326" y="0"/>
+                    <a:pt x="4472295" y="816"/>
+                    <a:pt x="4473748" y="2268"/>
+                  </a:cubicBezTo>
+                  <a:cubicBezTo>
+                    <a:pt x="4475200" y="3721"/>
+                    <a:pt x="4476016" y="5690"/>
+                    <a:pt x="4476016" y="7744"/>
+                  </a:cubicBezTo>
+                  <a:lnTo>
+                    <a:pt x="4476016" y="805056"/>
+                  </a:lnTo>
+                  <a:cubicBezTo>
+                    <a:pt x="4476016" y="807110"/>
+                    <a:pt x="4475200" y="809079"/>
+                    <a:pt x="4473748" y="810532"/>
+                  </a:cubicBezTo>
+                  <a:cubicBezTo>
+                    <a:pt x="4472295" y="811984"/>
+                    <a:pt x="4470326" y="812800"/>
+                    <a:pt x="4468272" y="812800"/>
+                  </a:cubicBezTo>
+                  <a:lnTo>
+                    <a:pt x="7744" y="812800"/>
+                  </a:lnTo>
+                  <a:cubicBezTo>
+                    <a:pt x="5690" y="812800"/>
+                    <a:pt x="3721" y="811984"/>
+                    <a:pt x="2268" y="810532"/>
+                  </a:cubicBezTo>
+                  <a:cubicBezTo>
+                    <a:pt x="816" y="809079"/>
+                    <a:pt x="0" y="807110"/>
+                    <a:pt x="0" y="805056"/>
+                  </a:cubicBezTo>
+                  <a:lnTo>
+                    <a:pt x="0" y="7744"/>
+                  </a:lnTo>
+                  <a:cubicBezTo>
+                    <a:pt x="0" y="5690"/>
+                    <a:pt x="816" y="3721"/>
+                    <a:pt x="2268" y="2268"/>
+                  </a:cubicBezTo>
+                  <a:cubicBezTo>
+                    <a:pt x="3721" y="816"/>
+                    <a:pt x="5690" y="0"/>
+                    <a:pt x="7744" y="0"/>
                   </a:cubicBezTo>
                   <a:close/>
                 </a:path>
@@ -15855,132 +15652,7 @@
           <p:spPr>
             <a:xfrm>
               <a:off x="0" y="-38100"/>
-              <a:ext cx="4466923" cy="850900"/>
-            </a:xfrm>
-            <a:prstGeom prst="rect">
-              <a:avLst/>
-            </a:prstGeom>
-          </p:spPr>
-          <p:txBody>
-            <a:bodyPr anchor="ctr" rtlCol="false" tIns="50800" lIns="50800" bIns="50800" rIns="50800"/>
-            <a:lstStyle/>
-            <a:p>
-              <a:pPr algn="ctr">
-                <a:lnSpc>
-                  <a:spcPts val="3449"/>
-                </a:lnSpc>
-              </a:pPr>
-            </a:p>
-          </p:txBody>
-        </p:sp>
-      </p:grpSp>
-      <p:grpSp>
-        <p:nvGrpSpPr>
-          <p:cNvPr name="Group 6" id="6"/>
-          <p:cNvGrpSpPr/>
-          <p:nvPr/>
-        </p:nvGrpSpPr>
-        <p:grpSpPr>
-          <a:xfrm rot="0">
-            <a:off x="5646830" y="3865652"/>
-            <a:ext cx="16960349" cy="3086100"/>
-            <a:chOff x="0" y="0"/>
-            <a:chExt cx="4466923" cy="812800"/>
-          </a:xfrm>
-        </p:grpSpPr>
-        <p:sp>
-          <p:nvSpPr>
-            <p:cNvPr name="Freeform 7" id="7"/>
-            <p:cNvSpPr/>
-            <p:nvPr/>
-          </p:nvSpPr>
-          <p:spPr>
-            <a:xfrm flipH="false" flipV="false" rot="0">
-              <a:off x="0" y="0"/>
-              <a:ext cx="4466923" cy="812800"/>
-            </a:xfrm>
-            <a:custGeom>
-              <a:avLst/>
-              <a:gdLst/>
-              <a:ahLst/>
-              <a:cxnLst/>
-              <a:rect r="r" b="b" t="t" l="l"/>
-              <a:pathLst>
-                <a:path h="812800" w="4466923">
-                  <a:moveTo>
-                    <a:pt x="7760" y="0"/>
-                  </a:moveTo>
-                  <a:lnTo>
-                    <a:pt x="4459163" y="0"/>
-                  </a:lnTo>
-                  <a:cubicBezTo>
-                    <a:pt x="4461221" y="0"/>
-                    <a:pt x="4463195" y="818"/>
-                    <a:pt x="4464650" y="2273"/>
-                  </a:cubicBezTo>
-                  <a:cubicBezTo>
-                    <a:pt x="4466106" y="3728"/>
-                    <a:pt x="4466923" y="5702"/>
-                    <a:pt x="4466923" y="7760"/>
-                  </a:cubicBezTo>
-                  <a:lnTo>
-                    <a:pt x="4466923" y="805040"/>
-                  </a:lnTo>
-                  <a:cubicBezTo>
-                    <a:pt x="4466923" y="807098"/>
-                    <a:pt x="4466106" y="809072"/>
-                    <a:pt x="4464650" y="810527"/>
-                  </a:cubicBezTo>
-                  <a:cubicBezTo>
-                    <a:pt x="4463195" y="811982"/>
-                    <a:pt x="4461221" y="812800"/>
-                    <a:pt x="4459163" y="812800"/>
-                  </a:cubicBezTo>
-                  <a:lnTo>
-                    <a:pt x="7760" y="812800"/>
-                  </a:lnTo>
-                  <a:cubicBezTo>
-                    <a:pt x="5702" y="812800"/>
-                    <a:pt x="3728" y="811982"/>
-                    <a:pt x="2273" y="810527"/>
-                  </a:cubicBezTo>
-                  <a:cubicBezTo>
-                    <a:pt x="818" y="809072"/>
-                    <a:pt x="0" y="807098"/>
-                    <a:pt x="0" y="805040"/>
-                  </a:cubicBezTo>
-                  <a:lnTo>
-                    <a:pt x="0" y="7760"/>
-                  </a:lnTo>
-                  <a:cubicBezTo>
-                    <a:pt x="0" y="5702"/>
-                    <a:pt x="818" y="3728"/>
-                    <a:pt x="2273" y="2273"/>
-                  </a:cubicBezTo>
-                  <a:cubicBezTo>
-                    <a:pt x="3728" y="818"/>
-                    <a:pt x="5702" y="0"/>
-                    <a:pt x="7760" y="0"/>
-                  </a:cubicBezTo>
-                  <a:close/>
-                </a:path>
-              </a:pathLst>
-            </a:custGeom>
-            <a:solidFill>
-              <a:srgbClr val="233D89"/>
-            </a:solidFill>
-          </p:spPr>
-        </p:sp>
-        <p:sp>
-          <p:nvSpPr>
-            <p:cNvPr name="TextBox 8" id="8"/>
-            <p:cNvSpPr txBox="true"/>
-            <p:nvPr/>
-          </p:nvSpPr>
-          <p:spPr>
-            <a:xfrm>
-              <a:off x="0" y="-38100"/>
-              <a:ext cx="4466923" cy="850900"/>
+              <a:ext cx="4476016" cy="850900"/>
             </a:xfrm>
             <a:prstGeom prst="rect">
               <a:avLst/>
@@ -16039,7 +15711,7 @@
         </p:nvSpPr>
         <p:spPr>
           <a:xfrm flipH="false" flipV="false" rot="0">
-            <a:off x="266228" y="2227353"/>
+            <a:off x="266228" y="4109192"/>
             <a:ext cx="17755545" cy="5149108"/>
           </a:xfrm>
           <a:custGeom>
@@ -16085,10 +15757,10 @@
         </p:nvGrpSpPr>
         <p:grpSpPr>
           <a:xfrm rot="0">
-            <a:off x="761532" y="4717090"/>
-            <a:ext cx="16960349" cy="3086100"/>
+            <a:off x="646563" y="6537927"/>
+            <a:ext cx="16994873" cy="3086100"/>
             <a:chOff x="0" y="0"/>
-            <a:chExt cx="4466923" cy="812800"/>
+            <a:chExt cx="4476016" cy="812800"/>
           </a:xfrm>
         </p:grpSpPr>
         <p:sp>
@@ -16100,7 +15772,7 @@
           <p:spPr>
             <a:xfrm flipH="false" flipV="false" rot="0">
               <a:off x="0" y="0"/>
-              <a:ext cx="4466923" cy="812800"/>
+              <a:ext cx="4476016" cy="812800"/>
             </a:xfrm>
             <a:custGeom>
               <a:avLst/>
@@ -16109,61 +15781,61 @@
               <a:cxnLst/>
               <a:rect r="r" b="b" t="t" l="l"/>
               <a:pathLst>
-                <a:path h="812800" w="4466923">
+                <a:path h="812800" w="4476016">
                   <a:moveTo>
-                    <a:pt x="7760" y="0"/>
+                    <a:pt x="7744" y="0"/>
                   </a:moveTo>
                   <a:lnTo>
-                    <a:pt x="4459163" y="0"/>
-                  </a:lnTo>
-                  <a:cubicBezTo>
-                    <a:pt x="4461221" y="0"/>
-                    <a:pt x="4463195" y="818"/>
-                    <a:pt x="4464650" y="2273"/>
-                  </a:cubicBezTo>
-                  <a:cubicBezTo>
-                    <a:pt x="4466106" y="3728"/>
-                    <a:pt x="4466923" y="5702"/>
-                    <a:pt x="4466923" y="7760"/>
-                  </a:cubicBezTo>
-                  <a:lnTo>
-                    <a:pt x="4466923" y="805040"/>
-                  </a:lnTo>
-                  <a:cubicBezTo>
-                    <a:pt x="4466923" y="807098"/>
-                    <a:pt x="4466106" y="809072"/>
-                    <a:pt x="4464650" y="810527"/>
-                  </a:cubicBezTo>
-                  <a:cubicBezTo>
-                    <a:pt x="4463195" y="811982"/>
-                    <a:pt x="4461221" y="812800"/>
-                    <a:pt x="4459163" y="812800"/>
-                  </a:cubicBezTo>
-                  <a:lnTo>
-                    <a:pt x="7760" y="812800"/>
-                  </a:lnTo>
-                  <a:cubicBezTo>
-                    <a:pt x="5702" y="812800"/>
-                    <a:pt x="3728" y="811982"/>
-                    <a:pt x="2273" y="810527"/>
-                  </a:cubicBezTo>
-                  <a:cubicBezTo>
-                    <a:pt x="818" y="809072"/>
-                    <a:pt x="0" y="807098"/>
-                    <a:pt x="0" y="805040"/>
-                  </a:cubicBezTo>
-                  <a:lnTo>
-                    <a:pt x="0" y="7760"/>
-                  </a:lnTo>
-                  <a:cubicBezTo>
-                    <a:pt x="0" y="5702"/>
-                    <a:pt x="818" y="3728"/>
-                    <a:pt x="2273" y="2273"/>
-                  </a:cubicBezTo>
-                  <a:cubicBezTo>
-                    <a:pt x="3728" y="818"/>
-                    <a:pt x="5702" y="0"/>
-                    <a:pt x="7760" y="0"/>
+                    <a:pt x="4468272" y="0"/>
+                  </a:lnTo>
+                  <a:cubicBezTo>
+                    <a:pt x="4470326" y="0"/>
+                    <a:pt x="4472295" y="816"/>
+                    <a:pt x="4473748" y="2268"/>
+                  </a:cubicBezTo>
+                  <a:cubicBezTo>
+                    <a:pt x="4475200" y="3721"/>
+                    <a:pt x="4476016" y="5690"/>
+                    <a:pt x="4476016" y="7744"/>
+                  </a:cubicBezTo>
+                  <a:lnTo>
+                    <a:pt x="4476016" y="805056"/>
+                  </a:lnTo>
+                  <a:cubicBezTo>
+                    <a:pt x="4476016" y="807110"/>
+                    <a:pt x="4475200" y="809079"/>
+                    <a:pt x="4473748" y="810532"/>
+                  </a:cubicBezTo>
+                  <a:cubicBezTo>
+                    <a:pt x="4472295" y="811984"/>
+                    <a:pt x="4470326" y="812800"/>
+                    <a:pt x="4468272" y="812800"/>
+                  </a:cubicBezTo>
+                  <a:lnTo>
+                    <a:pt x="7744" y="812800"/>
+                  </a:lnTo>
+                  <a:cubicBezTo>
+                    <a:pt x="5690" y="812800"/>
+                    <a:pt x="3721" y="811984"/>
+                    <a:pt x="2268" y="810532"/>
+                  </a:cubicBezTo>
+                  <a:cubicBezTo>
+                    <a:pt x="816" y="809079"/>
+                    <a:pt x="0" y="807110"/>
+                    <a:pt x="0" y="805056"/>
+                  </a:cubicBezTo>
+                  <a:lnTo>
+                    <a:pt x="0" y="7744"/>
+                  </a:lnTo>
+                  <a:cubicBezTo>
+                    <a:pt x="0" y="5690"/>
+                    <a:pt x="816" y="3721"/>
+                    <a:pt x="2268" y="2268"/>
+                  </a:cubicBezTo>
+                  <a:cubicBezTo>
+                    <a:pt x="3721" y="816"/>
+                    <a:pt x="5690" y="0"/>
+                    <a:pt x="7744" y="0"/>
                   </a:cubicBezTo>
                   <a:close/>
                 </a:path>
@@ -16183,7 +15855,7 @@
           <p:spPr>
             <a:xfrm>
               <a:off x="0" y="-38100"/>
-              <a:ext cx="4466923" cy="850900"/>
+              <a:ext cx="4476016" cy="850900"/>
             </a:xfrm>
             <a:prstGeom prst="rect">
               <a:avLst/>
@@ -16210,10 +15882,10 @@
         </p:nvGrpSpPr>
         <p:grpSpPr>
           <a:xfrm rot="0">
-            <a:off x="11662727" y="3823778"/>
-            <a:ext cx="5919573" cy="3086100"/>
+            <a:off x="6913704" y="5769099"/>
+            <a:ext cx="10727733" cy="3086100"/>
             <a:chOff x="0" y="0"/>
-            <a:chExt cx="1559065" cy="812800"/>
+            <a:chExt cx="2825411" cy="812800"/>
           </a:xfrm>
         </p:grpSpPr>
         <p:sp>
@@ -16225,7 +15897,7 @@
           <p:spPr>
             <a:xfrm flipH="false" flipV="false" rot="0">
               <a:off x="0" y="0"/>
-              <a:ext cx="1559065" cy="812800"/>
+              <a:ext cx="2825411" cy="812800"/>
             </a:xfrm>
             <a:custGeom>
               <a:avLst/>
@@ -16234,41 +15906,46 @@
               <a:cxnLst/>
               <a:rect r="r" b="b" t="t" l="l"/>
               <a:pathLst>
-                <a:path h="812800" w="1559065">
+                <a:path h="812800" w="2825411">
                   <a:moveTo>
-                    <a:pt x="22233" y="0"/>
+                    <a:pt x="12268" y="0"/>
                   </a:moveTo>
                   <a:lnTo>
-                    <a:pt x="1536831" y="0"/>
-                  </a:lnTo>
-                  <a:cubicBezTo>
-                    <a:pt x="1549110" y="0"/>
-                    <a:pt x="1559065" y="9954"/>
-                    <a:pt x="1559065" y="22233"/>
-                  </a:cubicBezTo>
-                  <a:lnTo>
-                    <a:pt x="1559065" y="790567"/>
-                  </a:lnTo>
-                  <a:cubicBezTo>
-                    <a:pt x="1559065" y="802846"/>
-                    <a:pt x="1549110" y="812800"/>
-                    <a:pt x="1536831" y="812800"/>
-                  </a:cubicBezTo>
-                  <a:lnTo>
-                    <a:pt x="22233" y="812800"/>
-                  </a:lnTo>
-                  <a:cubicBezTo>
-                    <a:pt x="9954" y="812800"/>
-                    <a:pt x="0" y="802846"/>
-                    <a:pt x="0" y="790567"/>
-                  </a:cubicBezTo>
-                  <a:lnTo>
-                    <a:pt x="0" y="22233"/>
-                  </a:lnTo>
-                  <a:cubicBezTo>
-                    <a:pt x="0" y="9954"/>
-                    <a:pt x="9954" y="0"/>
-                    <a:pt x="22233" y="0"/>
+                    <a:pt x="2813143" y="0"/>
+                  </a:lnTo>
+                  <a:cubicBezTo>
+                    <a:pt x="2816397" y="0"/>
+                    <a:pt x="2819517" y="1293"/>
+                    <a:pt x="2821818" y="3593"/>
+                  </a:cubicBezTo>
+                  <a:cubicBezTo>
+                    <a:pt x="2824119" y="5894"/>
+                    <a:pt x="2825411" y="9015"/>
+                    <a:pt x="2825411" y="12268"/>
+                  </a:cubicBezTo>
+                  <a:lnTo>
+                    <a:pt x="2825411" y="800532"/>
+                  </a:lnTo>
+                  <a:cubicBezTo>
+                    <a:pt x="2825411" y="807307"/>
+                    <a:pt x="2819918" y="812800"/>
+                    <a:pt x="2813143" y="812800"/>
+                  </a:cubicBezTo>
+                  <a:lnTo>
+                    <a:pt x="12268" y="812800"/>
+                  </a:lnTo>
+                  <a:cubicBezTo>
+                    <a:pt x="5493" y="812800"/>
+                    <a:pt x="0" y="807307"/>
+                    <a:pt x="0" y="800532"/>
+                  </a:cubicBezTo>
+                  <a:lnTo>
+                    <a:pt x="0" y="12268"/>
+                  </a:lnTo>
+                  <a:cubicBezTo>
+                    <a:pt x="0" y="5493"/>
+                    <a:pt x="5493" y="0"/>
+                    <a:pt x="12268" y="0"/>
                   </a:cubicBezTo>
                   <a:close/>
                 </a:path>
@@ -16288,7 +15965,7 @@
           <p:spPr>
             <a:xfrm>
               <a:off x="0" y="-38100"/>
-              <a:ext cx="1559065" cy="850900"/>
+              <a:ext cx="2825411" cy="850900"/>
             </a:xfrm>
             <a:prstGeom prst="rect">
               <a:avLst/>
@@ -16347,7 +16024,7 @@
         </p:nvSpPr>
         <p:spPr>
           <a:xfrm flipH="false" flipV="false" rot="0">
-            <a:off x="266228" y="2227353"/>
+            <a:off x="266228" y="4109192"/>
             <a:ext cx="17755545" cy="5149108"/>
           </a:xfrm>
           <a:custGeom>
@@ -16393,10 +16070,10 @@
         </p:nvGrpSpPr>
         <p:grpSpPr>
           <a:xfrm rot="0">
-            <a:off x="859238" y="4661258"/>
-            <a:ext cx="16960349" cy="3086100"/>
+            <a:off x="646563" y="6537927"/>
+            <a:ext cx="16994873" cy="3086100"/>
             <a:chOff x="0" y="0"/>
-            <a:chExt cx="4466923" cy="812800"/>
+            <a:chExt cx="4476016" cy="812800"/>
           </a:xfrm>
         </p:grpSpPr>
         <p:sp>
@@ -16408,7 +16085,7 @@
           <p:spPr>
             <a:xfrm flipH="false" flipV="false" rot="0">
               <a:off x="0" y="0"/>
-              <a:ext cx="4466923" cy="812800"/>
+              <a:ext cx="4476016" cy="812800"/>
             </a:xfrm>
             <a:custGeom>
               <a:avLst/>
@@ -16417,61 +16094,61 @@
               <a:cxnLst/>
               <a:rect r="r" b="b" t="t" l="l"/>
               <a:pathLst>
-                <a:path h="812800" w="4466923">
+                <a:path h="812800" w="4476016">
                   <a:moveTo>
-                    <a:pt x="7760" y="0"/>
+                    <a:pt x="7744" y="0"/>
                   </a:moveTo>
                   <a:lnTo>
-                    <a:pt x="4459163" y="0"/>
-                  </a:lnTo>
-                  <a:cubicBezTo>
-                    <a:pt x="4461221" y="0"/>
-                    <a:pt x="4463195" y="818"/>
-                    <a:pt x="4464650" y="2273"/>
-                  </a:cubicBezTo>
-                  <a:cubicBezTo>
-                    <a:pt x="4466106" y="3728"/>
-                    <a:pt x="4466923" y="5702"/>
-                    <a:pt x="4466923" y="7760"/>
-                  </a:cubicBezTo>
-                  <a:lnTo>
-                    <a:pt x="4466923" y="805040"/>
-                  </a:lnTo>
-                  <a:cubicBezTo>
-                    <a:pt x="4466923" y="807098"/>
-                    <a:pt x="4466106" y="809072"/>
-                    <a:pt x="4464650" y="810527"/>
-                  </a:cubicBezTo>
-                  <a:cubicBezTo>
-                    <a:pt x="4463195" y="811982"/>
-                    <a:pt x="4461221" y="812800"/>
-                    <a:pt x="4459163" y="812800"/>
-                  </a:cubicBezTo>
-                  <a:lnTo>
-                    <a:pt x="7760" y="812800"/>
-                  </a:lnTo>
-                  <a:cubicBezTo>
-                    <a:pt x="5702" y="812800"/>
-                    <a:pt x="3728" y="811982"/>
-                    <a:pt x="2273" y="810527"/>
-                  </a:cubicBezTo>
-                  <a:cubicBezTo>
-                    <a:pt x="818" y="809072"/>
-                    <a:pt x="0" y="807098"/>
-                    <a:pt x="0" y="805040"/>
-                  </a:cubicBezTo>
-                  <a:lnTo>
-                    <a:pt x="0" y="7760"/>
-                  </a:lnTo>
-                  <a:cubicBezTo>
-                    <a:pt x="0" y="5702"/>
-                    <a:pt x="818" y="3728"/>
-                    <a:pt x="2273" y="2273"/>
-                  </a:cubicBezTo>
-                  <a:cubicBezTo>
-                    <a:pt x="3728" y="818"/>
-                    <a:pt x="5702" y="0"/>
-                    <a:pt x="7760" y="0"/>
+                    <a:pt x="4468272" y="0"/>
+                  </a:lnTo>
+                  <a:cubicBezTo>
+                    <a:pt x="4470326" y="0"/>
+                    <a:pt x="4472295" y="816"/>
+                    <a:pt x="4473748" y="2268"/>
+                  </a:cubicBezTo>
+                  <a:cubicBezTo>
+                    <a:pt x="4475200" y="3721"/>
+                    <a:pt x="4476016" y="5690"/>
+                    <a:pt x="4476016" y="7744"/>
+                  </a:cubicBezTo>
+                  <a:lnTo>
+                    <a:pt x="4476016" y="805056"/>
+                  </a:lnTo>
+                  <a:cubicBezTo>
+                    <a:pt x="4476016" y="807110"/>
+                    <a:pt x="4475200" y="809079"/>
+                    <a:pt x="4473748" y="810532"/>
+                  </a:cubicBezTo>
+                  <a:cubicBezTo>
+                    <a:pt x="4472295" y="811984"/>
+                    <a:pt x="4470326" y="812800"/>
+                    <a:pt x="4468272" y="812800"/>
+                  </a:cubicBezTo>
+                  <a:lnTo>
+                    <a:pt x="7744" y="812800"/>
+                  </a:lnTo>
+                  <a:cubicBezTo>
+                    <a:pt x="5690" y="812800"/>
+                    <a:pt x="3721" y="811984"/>
+                    <a:pt x="2268" y="810532"/>
+                  </a:cubicBezTo>
+                  <a:cubicBezTo>
+                    <a:pt x="816" y="809079"/>
+                    <a:pt x="0" y="807110"/>
+                    <a:pt x="0" y="805056"/>
+                  </a:cubicBezTo>
+                  <a:lnTo>
+                    <a:pt x="0" y="7744"/>
+                  </a:lnTo>
+                  <a:cubicBezTo>
+                    <a:pt x="0" y="5690"/>
+                    <a:pt x="816" y="3721"/>
+                    <a:pt x="2268" y="2268"/>
+                  </a:cubicBezTo>
+                  <a:cubicBezTo>
+                    <a:pt x="3721" y="816"/>
+                    <a:pt x="5690" y="0"/>
+                    <a:pt x="7744" y="0"/>
                   </a:cubicBezTo>
                   <a:close/>
                 </a:path>
@@ -16491,7 +16168,132 @@
           <p:spPr>
             <a:xfrm>
               <a:off x="0" y="-38100"/>
-              <a:ext cx="4466923" cy="850900"/>
+              <a:ext cx="4476016" cy="850900"/>
+            </a:xfrm>
+            <a:prstGeom prst="rect">
+              <a:avLst/>
+            </a:prstGeom>
+          </p:spPr>
+          <p:txBody>
+            <a:bodyPr anchor="ctr" rtlCol="false" tIns="50800" lIns="50800" bIns="50800" rIns="50800"/>
+            <a:lstStyle/>
+            <a:p>
+              <a:pPr algn="ctr">
+                <a:lnSpc>
+                  <a:spcPts val="3449"/>
+                </a:lnSpc>
+              </a:pPr>
+            </a:p>
+          </p:txBody>
+        </p:sp>
+      </p:grpSp>
+      <p:grpSp>
+        <p:nvGrpSpPr>
+          <p:cNvPr name="Group 6" id="6"/>
+          <p:cNvGrpSpPr/>
+          <p:nvPr/>
+        </p:nvGrpSpPr>
+        <p:grpSpPr>
+          <a:xfrm rot="0">
+            <a:off x="11296515" y="5769099"/>
+            <a:ext cx="6344922" cy="3086100"/>
+            <a:chOff x="0" y="0"/>
+            <a:chExt cx="1671091" cy="812800"/>
+          </a:xfrm>
+        </p:grpSpPr>
+        <p:sp>
+          <p:nvSpPr>
+            <p:cNvPr name="Freeform 7" id="7"/>
+            <p:cNvSpPr/>
+            <p:nvPr/>
+          </p:nvSpPr>
+          <p:spPr>
+            <a:xfrm flipH="false" flipV="false" rot="0">
+              <a:off x="0" y="0"/>
+              <a:ext cx="1671090" cy="812800"/>
+            </a:xfrm>
+            <a:custGeom>
+              <a:avLst/>
+              <a:gdLst/>
+              <a:ahLst/>
+              <a:cxnLst/>
+              <a:rect r="r" b="b" t="t" l="l"/>
+              <a:pathLst>
+                <a:path h="812800" w="1671090">
+                  <a:moveTo>
+                    <a:pt x="20743" y="0"/>
+                  </a:moveTo>
+                  <a:lnTo>
+                    <a:pt x="1650348" y="0"/>
+                  </a:lnTo>
+                  <a:cubicBezTo>
+                    <a:pt x="1655849" y="0"/>
+                    <a:pt x="1661125" y="2185"/>
+                    <a:pt x="1665015" y="6075"/>
+                  </a:cubicBezTo>
+                  <a:cubicBezTo>
+                    <a:pt x="1668905" y="9966"/>
+                    <a:pt x="1671090" y="15242"/>
+                    <a:pt x="1671090" y="20743"/>
+                  </a:cubicBezTo>
+                  <a:lnTo>
+                    <a:pt x="1671090" y="792057"/>
+                  </a:lnTo>
+                  <a:cubicBezTo>
+                    <a:pt x="1671090" y="797558"/>
+                    <a:pt x="1668905" y="802834"/>
+                    <a:pt x="1665015" y="806724"/>
+                  </a:cubicBezTo>
+                  <a:cubicBezTo>
+                    <a:pt x="1661125" y="810615"/>
+                    <a:pt x="1655849" y="812800"/>
+                    <a:pt x="1650348" y="812800"/>
+                  </a:cubicBezTo>
+                  <a:lnTo>
+                    <a:pt x="20743" y="812800"/>
+                  </a:lnTo>
+                  <a:cubicBezTo>
+                    <a:pt x="15242" y="812800"/>
+                    <a:pt x="9966" y="810615"/>
+                    <a:pt x="6075" y="806724"/>
+                  </a:cubicBezTo>
+                  <a:cubicBezTo>
+                    <a:pt x="2185" y="802834"/>
+                    <a:pt x="0" y="797558"/>
+                    <a:pt x="0" y="792057"/>
+                  </a:cubicBezTo>
+                  <a:lnTo>
+                    <a:pt x="0" y="20743"/>
+                  </a:lnTo>
+                  <a:cubicBezTo>
+                    <a:pt x="0" y="15242"/>
+                    <a:pt x="2185" y="9966"/>
+                    <a:pt x="6075" y="6075"/>
+                  </a:cubicBezTo>
+                  <a:cubicBezTo>
+                    <a:pt x="9966" y="2185"/>
+                    <a:pt x="15242" y="0"/>
+                    <a:pt x="20743" y="0"/>
+                  </a:cubicBezTo>
+                  <a:close/>
+                </a:path>
+              </a:pathLst>
+            </a:custGeom>
+            <a:solidFill>
+              <a:srgbClr val="233D89"/>
+            </a:solidFill>
+          </p:spPr>
+        </p:sp>
+        <p:sp>
+          <p:nvSpPr>
+            <p:cNvPr name="TextBox 8" id="8"/>
+            <p:cNvSpPr txBox="true"/>
+            <p:nvPr/>
+          </p:nvSpPr>
+          <p:spPr>
+            <a:xfrm>
+              <a:off x="0" y="-38100"/>
+              <a:ext cx="1671091" cy="850900"/>
             </a:xfrm>
             <a:prstGeom prst="rect">
               <a:avLst/>
@@ -16550,7 +16352,7 @@
         </p:nvSpPr>
         <p:spPr>
           <a:xfrm flipH="false" flipV="false" rot="0">
-            <a:off x="266228" y="2227353"/>
+            <a:off x="266228" y="4109192"/>
             <a:ext cx="17755545" cy="5149108"/>
           </a:xfrm>
           <a:custGeom>
@@ -16596,10 +16398,10 @@
         </p:nvGrpSpPr>
         <p:grpSpPr>
           <a:xfrm rot="0">
-            <a:off x="775490" y="5442906"/>
-            <a:ext cx="16960349" cy="3086100"/>
+            <a:off x="646563" y="6537927"/>
+            <a:ext cx="16994873" cy="3086100"/>
             <a:chOff x="0" y="0"/>
-            <a:chExt cx="4466923" cy="812800"/>
+            <a:chExt cx="4476016" cy="812800"/>
           </a:xfrm>
         </p:grpSpPr>
         <p:sp>
@@ -16611,7 +16413,7 @@
           <p:spPr>
             <a:xfrm flipH="false" flipV="false" rot="0">
               <a:off x="0" y="0"/>
-              <a:ext cx="4466923" cy="812800"/>
+              <a:ext cx="4476016" cy="812800"/>
             </a:xfrm>
             <a:custGeom>
               <a:avLst/>
@@ -16620,61 +16422,61 @@
               <a:cxnLst/>
               <a:rect r="r" b="b" t="t" l="l"/>
               <a:pathLst>
-                <a:path h="812800" w="4466923">
+                <a:path h="812800" w="4476016">
                   <a:moveTo>
-                    <a:pt x="7760" y="0"/>
+                    <a:pt x="7744" y="0"/>
                   </a:moveTo>
                   <a:lnTo>
-                    <a:pt x="4459163" y="0"/>
-                  </a:lnTo>
-                  <a:cubicBezTo>
-                    <a:pt x="4461221" y="0"/>
-                    <a:pt x="4463195" y="818"/>
-                    <a:pt x="4464650" y="2273"/>
-                  </a:cubicBezTo>
-                  <a:cubicBezTo>
-                    <a:pt x="4466106" y="3728"/>
-                    <a:pt x="4466923" y="5702"/>
-                    <a:pt x="4466923" y="7760"/>
-                  </a:cubicBezTo>
-                  <a:lnTo>
-                    <a:pt x="4466923" y="805040"/>
-                  </a:lnTo>
-                  <a:cubicBezTo>
-                    <a:pt x="4466923" y="807098"/>
-                    <a:pt x="4466106" y="809072"/>
-                    <a:pt x="4464650" y="810527"/>
-                  </a:cubicBezTo>
-                  <a:cubicBezTo>
-                    <a:pt x="4463195" y="811982"/>
-                    <a:pt x="4461221" y="812800"/>
-                    <a:pt x="4459163" y="812800"/>
-                  </a:cubicBezTo>
-                  <a:lnTo>
-                    <a:pt x="7760" y="812800"/>
-                  </a:lnTo>
-                  <a:cubicBezTo>
-                    <a:pt x="5702" y="812800"/>
-                    <a:pt x="3728" y="811982"/>
-                    <a:pt x="2273" y="810527"/>
-                  </a:cubicBezTo>
-                  <a:cubicBezTo>
-                    <a:pt x="818" y="809072"/>
-                    <a:pt x="0" y="807098"/>
-                    <a:pt x="0" y="805040"/>
-                  </a:cubicBezTo>
-                  <a:lnTo>
-                    <a:pt x="0" y="7760"/>
-                  </a:lnTo>
-                  <a:cubicBezTo>
-                    <a:pt x="0" y="5702"/>
-                    <a:pt x="818" y="3728"/>
-                    <a:pt x="2273" y="2273"/>
-                  </a:cubicBezTo>
-                  <a:cubicBezTo>
-                    <a:pt x="3728" y="818"/>
-                    <a:pt x="5702" y="0"/>
-                    <a:pt x="7760" y="0"/>
+                    <a:pt x="4468272" y="0"/>
+                  </a:lnTo>
+                  <a:cubicBezTo>
+                    <a:pt x="4470326" y="0"/>
+                    <a:pt x="4472295" y="816"/>
+                    <a:pt x="4473748" y="2268"/>
+                  </a:cubicBezTo>
+                  <a:cubicBezTo>
+                    <a:pt x="4475200" y="3721"/>
+                    <a:pt x="4476016" y="5690"/>
+                    <a:pt x="4476016" y="7744"/>
+                  </a:cubicBezTo>
+                  <a:lnTo>
+                    <a:pt x="4476016" y="805056"/>
+                  </a:lnTo>
+                  <a:cubicBezTo>
+                    <a:pt x="4476016" y="807110"/>
+                    <a:pt x="4475200" y="809079"/>
+                    <a:pt x="4473748" y="810532"/>
+                  </a:cubicBezTo>
+                  <a:cubicBezTo>
+                    <a:pt x="4472295" y="811984"/>
+                    <a:pt x="4470326" y="812800"/>
+                    <a:pt x="4468272" y="812800"/>
+                  </a:cubicBezTo>
+                  <a:lnTo>
+                    <a:pt x="7744" y="812800"/>
+                  </a:lnTo>
+                  <a:cubicBezTo>
+                    <a:pt x="5690" y="812800"/>
+                    <a:pt x="3721" y="811984"/>
+                    <a:pt x="2268" y="810532"/>
+                  </a:cubicBezTo>
+                  <a:cubicBezTo>
+                    <a:pt x="816" y="809079"/>
+                    <a:pt x="0" y="807110"/>
+                    <a:pt x="0" y="805056"/>
+                  </a:cubicBezTo>
+                  <a:lnTo>
+                    <a:pt x="0" y="7744"/>
+                  </a:lnTo>
+                  <a:cubicBezTo>
+                    <a:pt x="0" y="5690"/>
+                    <a:pt x="816" y="3721"/>
+                    <a:pt x="2268" y="2268"/>
+                  </a:cubicBezTo>
+                  <a:cubicBezTo>
+                    <a:pt x="3721" y="816"/>
+                    <a:pt x="5690" y="0"/>
+                    <a:pt x="7744" y="0"/>
                   </a:cubicBezTo>
                   <a:close/>
                 </a:path>
@@ -16694,117 +16496,7 @@
           <p:spPr>
             <a:xfrm>
               <a:off x="0" y="-38100"/>
-              <a:ext cx="4466923" cy="850900"/>
-            </a:xfrm>
-            <a:prstGeom prst="rect">
-              <a:avLst/>
-            </a:prstGeom>
-          </p:spPr>
-          <p:txBody>
-            <a:bodyPr anchor="ctr" rtlCol="false" tIns="50800" lIns="50800" bIns="50800" rIns="50800"/>
-            <a:lstStyle/>
-            <a:p>
-              <a:pPr algn="ctr">
-                <a:lnSpc>
-                  <a:spcPts val="3449"/>
-                </a:lnSpc>
-              </a:pPr>
-            </a:p>
-          </p:txBody>
-        </p:sp>
-      </p:grpSp>
-      <p:grpSp>
-        <p:nvGrpSpPr>
-          <p:cNvPr name="Group 6" id="6"/>
-          <p:cNvGrpSpPr/>
-          <p:nvPr/>
-        </p:nvGrpSpPr>
-        <p:grpSpPr>
-          <a:xfrm rot="0">
-            <a:off x="6692542" y="4606495"/>
-            <a:ext cx="10330300" cy="3086100"/>
-            <a:chOff x="0" y="0"/>
-            <a:chExt cx="2720738" cy="812800"/>
-          </a:xfrm>
-        </p:grpSpPr>
-        <p:sp>
-          <p:nvSpPr>
-            <p:cNvPr name="Freeform 7" id="7"/>
-            <p:cNvSpPr/>
-            <p:nvPr/>
-          </p:nvSpPr>
-          <p:spPr>
-            <a:xfrm flipH="false" flipV="false" rot="0">
-              <a:off x="0" y="0"/>
-              <a:ext cx="2720738" cy="812800"/>
-            </a:xfrm>
-            <a:custGeom>
-              <a:avLst/>
-              <a:gdLst/>
-              <a:ahLst/>
-              <a:cxnLst/>
-              <a:rect r="r" b="b" t="t" l="l"/>
-              <a:pathLst>
-                <a:path h="812800" w="2720738">
-                  <a:moveTo>
-                    <a:pt x="12740" y="0"/>
-                  </a:moveTo>
-                  <a:lnTo>
-                    <a:pt x="2707997" y="0"/>
-                  </a:lnTo>
-                  <a:cubicBezTo>
-                    <a:pt x="2715034" y="0"/>
-                    <a:pt x="2720738" y="5704"/>
-                    <a:pt x="2720738" y="12740"/>
-                  </a:cubicBezTo>
-                  <a:lnTo>
-                    <a:pt x="2720738" y="800060"/>
-                  </a:lnTo>
-                  <a:cubicBezTo>
-                    <a:pt x="2720738" y="803439"/>
-                    <a:pt x="2719395" y="806679"/>
-                    <a:pt x="2717006" y="809068"/>
-                  </a:cubicBezTo>
-                  <a:cubicBezTo>
-                    <a:pt x="2714617" y="811458"/>
-                    <a:pt x="2711376" y="812800"/>
-                    <a:pt x="2707997" y="812800"/>
-                  </a:cubicBezTo>
-                  <a:lnTo>
-                    <a:pt x="12740" y="812800"/>
-                  </a:lnTo>
-                  <a:cubicBezTo>
-                    <a:pt x="5704" y="812800"/>
-                    <a:pt x="0" y="807096"/>
-                    <a:pt x="0" y="800060"/>
-                  </a:cubicBezTo>
-                  <a:lnTo>
-                    <a:pt x="0" y="12740"/>
-                  </a:lnTo>
-                  <a:cubicBezTo>
-                    <a:pt x="0" y="5704"/>
-                    <a:pt x="5704" y="0"/>
-                    <a:pt x="12740" y="0"/>
-                  </a:cubicBezTo>
-                  <a:close/>
-                </a:path>
-              </a:pathLst>
-            </a:custGeom>
-            <a:solidFill>
-              <a:srgbClr val="233D89"/>
-            </a:solidFill>
-          </p:spPr>
-        </p:sp>
-        <p:sp>
-          <p:nvSpPr>
-            <p:cNvPr name="TextBox 8" id="8"/>
-            <p:cNvSpPr txBox="true"/>
-            <p:nvPr/>
-          </p:nvSpPr>
-          <p:spPr>
-            <a:xfrm>
-              <a:off x="0" y="-38100"/>
-              <a:ext cx="2720738" cy="850900"/>
+              <a:ext cx="4476016" cy="850900"/>
             </a:xfrm>
             <a:prstGeom prst="rect">
               <a:avLst/>
@@ -16863,7 +16555,7 @@
         </p:nvSpPr>
         <p:spPr>
           <a:xfrm flipH="false" flipV="false" rot="0">
-            <a:off x="266228" y="2227353"/>
+            <a:off x="266228" y="4109192"/>
             <a:ext cx="17755545" cy="5149108"/>
           </a:xfrm>
           <a:custGeom>
@@ -16909,10 +16601,10 @@
         </p:nvGrpSpPr>
         <p:grpSpPr>
           <a:xfrm rot="0">
-            <a:off x="775490" y="5442906"/>
-            <a:ext cx="16960349" cy="3086100"/>
+            <a:off x="646563" y="7200900"/>
+            <a:ext cx="16994873" cy="3086100"/>
             <a:chOff x="0" y="0"/>
-            <a:chExt cx="4466923" cy="812800"/>
+            <a:chExt cx="4476016" cy="812800"/>
           </a:xfrm>
         </p:grpSpPr>
         <p:sp>
@@ -16924,7 +16616,7 @@
           <p:spPr>
             <a:xfrm flipH="false" flipV="false" rot="0">
               <a:off x="0" y="0"/>
-              <a:ext cx="4466923" cy="812800"/>
+              <a:ext cx="4476016" cy="812800"/>
             </a:xfrm>
             <a:custGeom>
               <a:avLst/>
@@ -16933,61 +16625,61 @@
               <a:cxnLst/>
               <a:rect r="r" b="b" t="t" l="l"/>
               <a:pathLst>
-                <a:path h="812800" w="4466923">
+                <a:path h="812800" w="4476016">
                   <a:moveTo>
-                    <a:pt x="7760" y="0"/>
+                    <a:pt x="7744" y="0"/>
                   </a:moveTo>
                   <a:lnTo>
-                    <a:pt x="4459163" y="0"/>
-                  </a:lnTo>
-                  <a:cubicBezTo>
-                    <a:pt x="4461221" y="0"/>
-                    <a:pt x="4463195" y="818"/>
-                    <a:pt x="4464650" y="2273"/>
-                  </a:cubicBezTo>
-                  <a:cubicBezTo>
-                    <a:pt x="4466106" y="3728"/>
-                    <a:pt x="4466923" y="5702"/>
-                    <a:pt x="4466923" y="7760"/>
-                  </a:cubicBezTo>
-                  <a:lnTo>
-                    <a:pt x="4466923" y="805040"/>
-                  </a:lnTo>
-                  <a:cubicBezTo>
-                    <a:pt x="4466923" y="807098"/>
-                    <a:pt x="4466106" y="809072"/>
-                    <a:pt x="4464650" y="810527"/>
-                  </a:cubicBezTo>
-                  <a:cubicBezTo>
-                    <a:pt x="4463195" y="811982"/>
-                    <a:pt x="4461221" y="812800"/>
-                    <a:pt x="4459163" y="812800"/>
-                  </a:cubicBezTo>
-                  <a:lnTo>
-                    <a:pt x="7760" y="812800"/>
-                  </a:lnTo>
-                  <a:cubicBezTo>
-                    <a:pt x="5702" y="812800"/>
-                    <a:pt x="3728" y="811982"/>
-                    <a:pt x="2273" y="810527"/>
-                  </a:cubicBezTo>
-                  <a:cubicBezTo>
-                    <a:pt x="818" y="809072"/>
-                    <a:pt x="0" y="807098"/>
-                    <a:pt x="0" y="805040"/>
-                  </a:cubicBezTo>
-                  <a:lnTo>
-                    <a:pt x="0" y="7760"/>
-                  </a:lnTo>
-                  <a:cubicBezTo>
-                    <a:pt x="0" y="5702"/>
-                    <a:pt x="818" y="3728"/>
-                    <a:pt x="2273" y="2273"/>
-                  </a:cubicBezTo>
-                  <a:cubicBezTo>
-                    <a:pt x="3728" y="818"/>
-                    <a:pt x="5702" y="0"/>
-                    <a:pt x="7760" y="0"/>
+                    <a:pt x="4468272" y="0"/>
+                  </a:lnTo>
+                  <a:cubicBezTo>
+                    <a:pt x="4470326" y="0"/>
+                    <a:pt x="4472295" y="816"/>
+                    <a:pt x="4473748" y="2268"/>
+                  </a:cubicBezTo>
+                  <a:cubicBezTo>
+                    <a:pt x="4475200" y="3721"/>
+                    <a:pt x="4476016" y="5690"/>
+                    <a:pt x="4476016" y="7744"/>
+                  </a:cubicBezTo>
+                  <a:lnTo>
+                    <a:pt x="4476016" y="805056"/>
+                  </a:lnTo>
+                  <a:cubicBezTo>
+                    <a:pt x="4476016" y="807110"/>
+                    <a:pt x="4475200" y="809079"/>
+                    <a:pt x="4473748" y="810532"/>
+                  </a:cubicBezTo>
+                  <a:cubicBezTo>
+                    <a:pt x="4472295" y="811984"/>
+                    <a:pt x="4470326" y="812800"/>
+                    <a:pt x="4468272" y="812800"/>
+                  </a:cubicBezTo>
+                  <a:lnTo>
+                    <a:pt x="7744" y="812800"/>
+                  </a:lnTo>
+                  <a:cubicBezTo>
+                    <a:pt x="5690" y="812800"/>
+                    <a:pt x="3721" y="811984"/>
+                    <a:pt x="2268" y="810532"/>
+                  </a:cubicBezTo>
+                  <a:cubicBezTo>
+                    <a:pt x="816" y="809079"/>
+                    <a:pt x="0" y="807110"/>
+                    <a:pt x="0" y="805056"/>
+                  </a:cubicBezTo>
+                  <a:lnTo>
+                    <a:pt x="0" y="7744"/>
+                  </a:lnTo>
+                  <a:cubicBezTo>
+                    <a:pt x="0" y="5690"/>
+                    <a:pt x="816" y="3721"/>
+                    <a:pt x="2268" y="2268"/>
+                  </a:cubicBezTo>
+                  <a:cubicBezTo>
+                    <a:pt x="3721" y="816"/>
+                    <a:pt x="5690" y="0"/>
+                    <a:pt x="7744" y="0"/>
                   </a:cubicBezTo>
                   <a:close/>
                 </a:path>
@@ -17007,7 +16699,7 @@
           <p:spPr>
             <a:xfrm>
               <a:off x="0" y="-38100"/>
-              <a:ext cx="4466923" cy="850900"/>
+              <a:ext cx="4476016" cy="850900"/>
             </a:xfrm>
             <a:prstGeom prst="rect">
               <a:avLst/>
@@ -17034,10 +16726,10 @@
         </p:nvGrpSpPr>
         <p:grpSpPr>
           <a:xfrm rot="0">
-            <a:off x="11410345" y="4606495"/>
-            <a:ext cx="5612497" cy="3086100"/>
+            <a:off x="6173930" y="6515820"/>
+            <a:ext cx="11467507" cy="3086100"/>
             <a:chOff x="0" y="0"/>
-            <a:chExt cx="1478189" cy="812800"/>
+            <a:chExt cx="3020249" cy="812800"/>
           </a:xfrm>
         </p:grpSpPr>
         <p:sp>
@@ -17049,7 +16741,7 @@
           <p:spPr>
             <a:xfrm flipH="false" flipV="false" rot="0">
               <a:off x="0" y="0"/>
-              <a:ext cx="1478189" cy="812800"/>
+              <a:ext cx="3020249" cy="812800"/>
             </a:xfrm>
             <a:custGeom>
               <a:avLst/>
@@ -17058,61 +16750,41 @@
               <a:cxnLst/>
               <a:rect r="r" b="b" t="t" l="l"/>
               <a:pathLst>
-                <a:path h="812800" w="1478189">
+                <a:path h="812800" w="3020249">
                   <a:moveTo>
-                    <a:pt x="23450" y="0"/>
+                    <a:pt x="11477" y="0"/>
                   </a:moveTo>
                   <a:lnTo>
-                    <a:pt x="1454739" y="0"/>
-                  </a:lnTo>
-                  <a:cubicBezTo>
-                    <a:pt x="1460958" y="0"/>
-                    <a:pt x="1466923" y="2471"/>
-                    <a:pt x="1471320" y="6868"/>
-                  </a:cubicBezTo>
-                  <a:cubicBezTo>
-                    <a:pt x="1475718" y="11266"/>
-                    <a:pt x="1478189" y="17231"/>
-                    <a:pt x="1478189" y="23450"/>
-                  </a:cubicBezTo>
-                  <a:lnTo>
-                    <a:pt x="1478189" y="789350"/>
-                  </a:lnTo>
-                  <a:cubicBezTo>
-                    <a:pt x="1478189" y="795569"/>
-                    <a:pt x="1475718" y="801534"/>
-                    <a:pt x="1471320" y="805932"/>
-                  </a:cubicBezTo>
-                  <a:cubicBezTo>
-                    <a:pt x="1466923" y="810329"/>
-                    <a:pt x="1460958" y="812800"/>
-                    <a:pt x="1454739" y="812800"/>
-                  </a:cubicBezTo>
-                  <a:lnTo>
-                    <a:pt x="23450" y="812800"/>
-                  </a:lnTo>
-                  <a:cubicBezTo>
-                    <a:pt x="17231" y="812800"/>
-                    <a:pt x="11266" y="810329"/>
-                    <a:pt x="6868" y="805932"/>
-                  </a:cubicBezTo>
-                  <a:cubicBezTo>
-                    <a:pt x="2471" y="801534"/>
-                    <a:pt x="0" y="795569"/>
-                    <a:pt x="0" y="789350"/>
-                  </a:cubicBezTo>
-                  <a:lnTo>
-                    <a:pt x="0" y="23450"/>
-                  </a:lnTo>
-                  <a:cubicBezTo>
-                    <a:pt x="0" y="17231"/>
-                    <a:pt x="2471" y="11266"/>
-                    <a:pt x="6868" y="6868"/>
-                  </a:cubicBezTo>
-                  <a:cubicBezTo>
-                    <a:pt x="11266" y="2471"/>
-                    <a:pt x="17231" y="0"/>
-                    <a:pt x="23450" y="0"/>
+                    <a:pt x="3008772" y="0"/>
+                  </a:lnTo>
+                  <a:cubicBezTo>
+                    <a:pt x="3015110" y="0"/>
+                    <a:pt x="3020249" y="5138"/>
+                    <a:pt x="3020249" y="11477"/>
+                  </a:cubicBezTo>
+                  <a:lnTo>
+                    <a:pt x="3020249" y="801323"/>
+                  </a:lnTo>
+                  <a:cubicBezTo>
+                    <a:pt x="3020249" y="807662"/>
+                    <a:pt x="3015110" y="812800"/>
+                    <a:pt x="3008772" y="812800"/>
+                  </a:cubicBezTo>
+                  <a:lnTo>
+                    <a:pt x="11477" y="812800"/>
+                  </a:lnTo>
+                  <a:cubicBezTo>
+                    <a:pt x="5138" y="812800"/>
+                    <a:pt x="0" y="807662"/>
+                    <a:pt x="0" y="801323"/>
+                  </a:cubicBezTo>
+                  <a:lnTo>
+                    <a:pt x="0" y="11477"/>
+                  </a:lnTo>
+                  <a:cubicBezTo>
+                    <a:pt x="0" y="5138"/>
+                    <a:pt x="5138" y="0"/>
+                    <a:pt x="11477" y="0"/>
                   </a:cubicBezTo>
                   <a:close/>
                 </a:path>
@@ -17132,7 +16804,7 @@
           <p:spPr>
             <a:xfrm>
               <a:off x="0" y="-38100"/>
-              <a:ext cx="1478189" cy="850900"/>
+              <a:ext cx="3020249" cy="850900"/>
             </a:xfrm>
             <a:prstGeom prst="rect">
               <a:avLst/>
@@ -17191,7 +16863,7 @@
         </p:nvSpPr>
         <p:spPr>
           <a:xfrm flipH="false" flipV="false" rot="0">
-            <a:off x="266228" y="2227353"/>
+            <a:off x="266228" y="4109192"/>
             <a:ext cx="17755545" cy="5149108"/>
           </a:xfrm>
           <a:custGeom>
@@ -17237,10 +16909,10 @@
         </p:nvGrpSpPr>
         <p:grpSpPr>
           <a:xfrm rot="0">
-            <a:off x="775490" y="5442906"/>
-            <a:ext cx="16960349" cy="3086100"/>
+            <a:off x="646563" y="7200900"/>
+            <a:ext cx="16994873" cy="3086100"/>
             <a:chOff x="0" y="0"/>
-            <a:chExt cx="4466923" cy="812800"/>
+            <a:chExt cx="4476016" cy="812800"/>
           </a:xfrm>
         </p:grpSpPr>
         <p:sp>
@@ -17252,7 +16924,7 @@
           <p:spPr>
             <a:xfrm flipH="false" flipV="false" rot="0">
               <a:off x="0" y="0"/>
-              <a:ext cx="4466923" cy="812800"/>
+              <a:ext cx="4476016" cy="812800"/>
             </a:xfrm>
             <a:custGeom>
               <a:avLst/>
@@ -17261,61 +16933,61 @@
               <a:cxnLst/>
               <a:rect r="r" b="b" t="t" l="l"/>
               <a:pathLst>
-                <a:path h="812800" w="4466923">
+                <a:path h="812800" w="4476016">
                   <a:moveTo>
-                    <a:pt x="7760" y="0"/>
+                    <a:pt x="7744" y="0"/>
                   </a:moveTo>
                   <a:lnTo>
-                    <a:pt x="4459163" y="0"/>
-                  </a:lnTo>
-                  <a:cubicBezTo>
-                    <a:pt x="4461221" y="0"/>
-                    <a:pt x="4463195" y="818"/>
-                    <a:pt x="4464650" y="2273"/>
-                  </a:cubicBezTo>
-                  <a:cubicBezTo>
-                    <a:pt x="4466106" y="3728"/>
-                    <a:pt x="4466923" y="5702"/>
-                    <a:pt x="4466923" y="7760"/>
-                  </a:cubicBezTo>
-                  <a:lnTo>
-                    <a:pt x="4466923" y="805040"/>
-                  </a:lnTo>
-                  <a:cubicBezTo>
-                    <a:pt x="4466923" y="807098"/>
-                    <a:pt x="4466106" y="809072"/>
-                    <a:pt x="4464650" y="810527"/>
-                  </a:cubicBezTo>
-                  <a:cubicBezTo>
-                    <a:pt x="4463195" y="811982"/>
-                    <a:pt x="4461221" y="812800"/>
-                    <a:pt x="4459163" y="812800"/>
-                  </a:cubicBezTo>
-                  <a:lnTo>
-                    <a:pt x="7760" y="812800"/>
-                  </a:lnTo>
-                  <a:cubicBezTo>
-                    <a:pt x="5702" y="812800"/>
-                    <a:pt x="3728" y="811982"/>
-                    <a:pt x="2273" y="810527"/>
-                  </a:cubicBezTo>
-                  <a:cubicBezTo>
-                    <a:pt x="818" y="809072"/>
-                    <a:pt x="0" y="807098"/>
-                    <a:pt x="0" y="805040"/>
-                  </a:cubicBezTo>
-                  <a:lnTo>
-                    <a:pt x="0" y="7760"/>
-                  </a:lnTo>
-                  <a:cubicBezTo>
-                    <a:pt x="0" y="5702"/>
-                    <a:pt x="818" y="3728"/>
-                    <a:pt x="2273" y="2273"/>
-                  </a:cubicBezTo>
-                  <a:cubicBezTo>
-                    <a:pt x="3728" y="818"/>
-                    <a:pt x="5702" y="0"/>
-                    <a:pt x="7760" y="0"/>
+                    <a:pt x="4468272" y="0"/>
+                  </a:lnTo>
+                  <a:cubicBezTo>
+                    <a:pt x="4470326" y="0"/>
+                    <a:pt x="4472295" y="816"/>
+                    <a:pt x="4473748" y="2268"/>
+                  </a:cubicBezTo>
+                  <a:cubicBezTo>
+                    <a:pt x="4475200" y="3721"/>
+                    <a:pt x="4476016" y="5690"/>
+                    <a:pt x="4476016" y="7744"/>
+                  </a:cubicBezTo>
+                  <a:lnTo>
+                    <a:pt x="4476016" y="805056"/>
+                  </a:lnTo>
+                  <a:cubicBezTo>
+                    <a:pt x="4476016" y="807110"/>
+                    <a:pt x="4475200" y="809079"/>
+                    <a:pt x="4473748" y="810532"/>
+                  </a:cubicBezTo>
+                  <a:cubicBezTo>
+                    <a:pt x="4472295" y="811984"/>
+                    <a:pt x="4470326" y="812800"/>
+                    <a:pt x="4468272" y="812800"/>
+                  </a:cubicBezTo>
+                  <a:lnTo>
+                    <a:pt x="7744" y="812800"/>
+                  </a:lnTo>
+                  <a:cubicBezTo>
+                    <a:pt x="5690" y="812800"/>
+                    <a:pt x="3721" y="811984"/>
+                    <a:pt x="2268" y="810532"/>
+                  </a:cubicBezTo>
+                  <a:cubicBezTo>
+                    <a:pt x="816" y="809079"/>
+                    <a:pt x="0" y="807110"/>
+                    <a:pt x="0" y="805056"/>
+                  </a:cubicBezTo>
+                  <a:lnTo>
+                    <a:pt x="0" y="7744"/>
+                  </a:lnTo>
+                  <a:cubicBezTo>
+                    <a:pt x="0" y="5690"/>
+                    <a:pt x="816" y="3721"/>
+                    <a:pt x="2268" y="2268"/>
+                  </a:cubicBezTo>
+                  <a:cubicBezTo>
+                    <a:pt x="3721" y="816"/>
+                    <a:pt x="5690" y="0"/>
+                    <a:pt x="7744" y="0"/>
                   </a:cubicBezTo>
                   <a:close/>
                 </a:path>
@@ -17335,7 +17007,132 @@
           <p:spPr>
             <a:xfrm>
               <a:off x="0" y="-38100"/>
-              <a:ext cx="4466923" cy="850900"/>
+              <a:ext cx="4476016" cy="850900"/>
+            </a:xfrm>
+            <a:prstGeom prst="rect">
+              <a:avLst/>
+            </a:prstGeom>
+          </p:spPr>
+          <p:txBody>
+            <a:bodyPr anchor="ctr" rtlCol="false" tIns="50800" lIns="50800" bIns="50800" rIns="50800"/>
+            <a:lstStyle/>
+            <a:p>
+              <a:pPr algn="ctr">
+                <a:lnSpc>
+                  <a:spcPts val="3449"/>
+                </a:lnSpc>
+              </a:pPr>
+            </a:p>
+          </p:txBody>
+        </p:sp>
+      </p:grpSp>
+      <p:grpSp>
+        <p:nvGrpSpPr>
+          <p:cNvPr name="Group 6" id="6"/>
+          <p:cNvGrpSpPr/>
+          <p:nvPr/>
+        </p:nvGrpSpPr>
+        <p:grpSpPr>
+          <a:xfrm rot="0">
+            <a:off x="11408179" y="6515820"/>
+            <a:ext cx="6233258" cy="3086100"/>
+            <a:chOff x="0" y="0"/>
+            <a:chExt cx="1641681" cy="812800"/>
+          </a:xfrm>
+        </p:grpSpPr>
+        <p:sp>
+          <p:nvSpPr>
+            <p:cNvPr name="Freeform 7" id="7"/>
+            <p:cNvSpPr/>
+            <p:nvPr/>
+          </p:nvSpPr>
+          <p:spPr>
+            <a:xfrm flipH="false" flipV="false" rot="0">
+              <a:off x="0" y="0"/>
+              <a:ext cx="1641681" cy="812800"/>
+            </a:xfrm>
+            <a:custGeom>
+              <a:avLst/>
+              <a:gdLst/>
+              <a:ahLst/>
+              <a:cxnLst/>
+              <a:rect r="r" b="b" t="t" l="l"/>
+              <a:pathLst>
+                <a:path h="812800" w="1641681">
+                  <a:moveTo>
+                    <a:pt x="21115" y="0"/>
+                  </a:moveTo>
+                  <a:lnTo>
+                    <a:pt x="1620566" y="0"/>
+                  </a:lnTo>
+                  <a:cubicBezTo>
+                    <a:pt x="1626166" y="0"/>
+                    <a:pt x="1631537" y="2225"/>
+                    <a:pt x="1635497" y="6184"/>
+                  </a:cubicBezTo>
+                  <a:cubicBezTo>
+                    <a:pt x="1639457" y="10144"/>
+                    <a:pt x="1641681" y="15515"/>
+                    <a:pt x="1641681" y="21115"/>
+                  </a:cubicBezTo>
+                  <a:lnTo>
+                    <a:pt x="1641681" y="791685"/>
+                  </a:lnTo>
+                  <a:cubicBezTo>
+                    <a:pt x="1641681" y="797285"/>
+                    <a:pt x="1639457" y="802656"/>
+                    <a:pt x="1635497" y="806616"/>
+                  </a:cubicBezTo>
+                  <a:cubicBezTo>
+                    <a:pt x="1631537" y="810575"/>
+                    <a:pt x="1626166" y="812800"/>
+                    <a:pt x="1620566" y="812800"/>
+                  </a:cubicBezTo>
+                  <a:lnTo>
+                    <a:pt x="21115" y="812800"/>
+                  </a:lnTo>
+                  <a:cubicBezTo>
+                    <a:pt x="15515" y="812800"/>
+                    <a:pt x="10144" y="810575"/>
+                    <a:pt x="6184" y="806616"/>
+                  </a:cubicBezTo>
+                  <a:cubicBezTo>
+                    <a:pt x="2225" y="802656"/>
+                    <a:pt x="0" y="797285"/>
+                    <a:pt x="0" y="791685"/>
+                  </a:cubicBezTo>
+                  <a:lnTo>
+                    <a:pt x="0" y="21115"/>
+                  </a:lnTo>
+                  <a:cubicBezTo>
+                    <a:pt x="0" y="15515"/>
+                    <a:pt x="2225" y="10144"/>
+                    <a:pt x="6184" y="6184"/>
+                  </a:cubicBezTo>
+                  <a:cubicBezTo>
+                    <a:pt x="10144" y="2225"/>
+                    <a:pt x="15515" y="0"/>
+                    <a:pt x="21115" y="0"/>
+                  </a:cubicBezTo>
+                  <a:close/>
+                </a:path>
+              </a:pathLst>
+            </a:custGeom>
+            <a:solidFill>
+              <a:srgbClr val="233D89"/>
+            </a:solidFill>
+          </p:spPr>
+        </p:sp>
+        <p:sp>
+          <p:nvSpPr>
+            <p:cNvPr name="TextBox 8" id="8"/>
+            <p:cNvSpPr txBox="true"/>
+            <p:nvPr/>
+          </p:nvSpPr>
+          <p:spPr>
+            <a:xfrm>
+              <a:off x="0" y="-38100"/>
+              <a:ext cx="1641681" cy="850900"/>
             </a:xfrm>
             <a:prstGeom prst="rect">
               <a:avLst/>
@@ -17394,7 +17191,7 @@
         </p:nvSpPr>
         <p:spPr>
           <a:xfrm flipH="false" flipV="false" rot="0">
-            <a:off x="266228" y="2227353"/>
+            <a:off x="266228" y="4109192"/>
             <a:ext cx="17755545" cy="5149108"/>
           </a:xfrm>
           <a:custGeom>
@@ -17440,10 +17237,10 @@
         </p:nvGrpSpPr>
         <p:grpSpPr>
           <a:xfrm rot="0">
-            <a:off x="621952" y="6126847"/>
-            <a:ext cx="5905615" cy="1425098"/>
+            <a:off x="646563" y="7200900"/>
+            <a:ext cx="16994873" cy="3086100"/>
             <a:chOff x="0" y="0"/>
-            <a:chExt cx="1555388" cy="375335"/>
+            <a:chExt cx="4476016" cy="812800"/>
           </a:xfrm>
         </p:grpSpPr>
         <p:sp>
@@ -17455,7 +17252,7 @@
           <p:spPr>
             <a:xfrm flipH="false" flipV="false" rot="0">
               <a:off x="0" y="0"/>
-              <a:ext cx="1555388" cy="375335"/>
+              <a:ext cx="4476016" cy="812800"/>
             </a:xfrm>
             <a:custGeom>
               <a:avLst/>
@@ -17464,51 +17261,61 @@
               <a:cxnLst/>
               <a:rect r="r" b="b" t="t" l="l"/>
               <a:pathLst>
-                <a:path h="375335" w="1555388">
+                <a:path h="812800" w="4476016">
                   <a:moveTo>
-                    <a:pt x="22286" y="0"/>
+                    <a:pt x="7744" y="0"/>
                   </a:moveTo>
                   <a:lnTo>
-                    <a:pt x="1533102" y="0"/>
-                  </a:lnTo>
-                  <a:cubicBezTo>
-                    <a:pt x="1539013" y="0"/>
-                    <a:pt x="1544682" y="2348"/>
-                    <a:pt x="1548861" y="6527"/>
-                  </a:cubicBezTo>
-                  <a:cubicBezTo>
-                    <a:pt x="1553040" y="10707"/>
-                    <a:pt x="1555388" y="16375"/>
-                    <a:pt x="1555388" y="22286"/>
-                  </a:cubicBezTo>
-                  <a:lnTo>
-                    <a:pt x="1555388" y="353049"/>
-                  </a:lnTo>
-                  <a:cubicBezTo>
-                    <a:pt x="1555388" y="365357"/>
-                    <a:pt x="1545411" y="375335"/>
-                    <a:pt x="1533102" y="375335"/>
-                  </a:cubicBezTo>
-                  <a:lnTo>
-                    <a:pt x="22286" y="375335"/>
-                  </a:lnTo>
-                  <a:cubicBezTo>
-                    <a:pt x="16375" y="375335"/>
-                    <a:pt x="10707" y="372987"/>
-                    <a:pt x="6527" y="368807"/>
-                  </a:cubicBezTo>
-                  <a:cubicBezTo>
-                    <a:pt x="2348" y="364628"/>
-                    <a:pt x="0" y="358959"/>
-                    <a:pt x="0" y="353049"/>
-                  </a:cubicBezTo>
-                  <a:lnTo>
-                    <a:pt x="0" y="22286"/>
-                  </a:lnTo>
-                  <a:cubicBezTo>
-                    <a:pt x="0" y="9978"/>
-                    <a:pt x="9978" y="0"/>
-                    <a:pt x="22286" y="0"/>
+                    <a:pt x="4468272" y="0"/>
+                  </a:lnTo>
+                  <a:cubicBezTo>
+                    <a:pt x="4470326" y="0"/>
+                    <a:pt x="4472295" y="816"/>
+                    <a:pt x="4473748" y="2268"/>
+                  </a:cubicBezTo>
+                  <a:cubicBezTo>
+                    <a:pt x="4475200" y="3721"/>
+                    <a:pt x="4476016" y="5690"/>
+                    <a:pt x="4476016" y="7744"/>
+                  </a:cubicBezTo>
+                  <a:lnTo>
+                    <a:pt x="4476016" y="805056"/>
+                  </a:lnTo>
+                  <a:cubicBezTo>
+                    <a:pt x="4476016" y="807110"/>
+                    <a:pt x="4475200" y="809079"/>
+                    <a:pt x="4473748" y="810532"/>
+                  </a:cubicBezTo>
+                  <a:cubicBezTo>
+                    <a:pt x="4472295" y="811984"/>
+                    <a:pt x="4470326" y="812800"/>
+                    <a:pt x="4468272" y="812800"/>
+                  </a:cubicBezTo>
+                  <a:lnTo>
+                    <a:pt x="7744" y="812800"/>
+                  </a:lnTo>
+                  <a:cubicBezTo>
+                    <a:pt x="5690" y="812800"/>
+                    <a:pt x="3721" y="811984"/>
+                    <a:pt x="2268" y="810532"/>
+                  </a:cubicBezTo>
+                  <a:cubicBezTo>
+                    <a:pt x="816" y="809079"/>
+                    <a:pt x="0" y="807110"/>
+                    <a:pt x="0" y="805056"/>
+                  </a:cubicBezTo>
+                  <a:lnTo>
+                    <a:pt x="0" y="7744"/>
+                  </a:lnTo>
+                  <a:cubicBezTo>
+                    <a:pt x="0" y="5690"/>
+                    <a:pt x="816" y="3721"/>
+                    <a:pt x="2268" y="2268"/>
+                  </a:cubicBezTo>
+                  <a:cubicBezTo>
+                    <a:pt x="3721" y="816"/>
+                    <a:pt x="5690" y="0"/>
+                    <a:pt x="7744" y="0"/>
                   </a:cubicBezTo>
                   <a:close/>
                 </a:path>
@@ -17528,127 +17335,7 @@
           <p:spPr>
             <a:xfrm>
               <a:off x="0" y="-38100"/>
-              <a:ext cx="1555388" cy="413435"/>
-            </a:xfrm>
-            <a:prstGeom prst="rect">
-              <a:avLst/>
-            </a:prstGeom>
-          </p:spPr>
-          <p:txBody>
-            <a:bodyPr anchor="ctr" rtlCol="false" tIns="50800" lIns="50800" bIns="50800" rIns="50800"/>
-            <a:lstStyle/>
-            <a:p>
-              <a:pPr algn="ctr">
-                <a:lnSpc>
-                  <a:spcPts val="3449"/>
-                </a:lnSpc>
-              </a:pPr>
-            </a:p>
-          </p:txBody>
-        </p:sp>
-      </p:grpSp>
-      <p:grpSp>
-        <p:nvGrpSpPr>
-          <p:cNvPr name="Group 6" id="6"/>
-          <p:cNvGrpSpPr/>
-          <p:nvPr/>
-        </p:nvGrpSpPr>
-        <p:grpSpPr>
-          <a:xfrm rot="0">
-            <a:off x="6441298" y="5246356"/>
-            <a:ext cx="10400090" cy="1425098"/>
-            <a:chOff x="0" y="0"/>
-            <a:chExt cx="2739118" cy="375335"/>
-          </a:xfrm>
-        </p:grpSpPr>
-        <p:sp>
-          <p:nvSpPr>
-            <p:cNvPr name="Freeform 7" id="7"/>
-            <p:cNvSpPr/>
-            <p:nvPr/>
-          </p:nvSpPr>
-          <p:spPr>
-            <a:xfrm flipH="false" flipV="false" rot="0">
-              <a:off x="0" y="0"/>
-              <a:ext cx="2739118" cy="375335"/>
-            </a:xfrm>
-            <a:custGeom>
-              <a:avLst/>
-              <a:gdLst/>
-              <a:ahLst/>
-              <a:cxnLst/>
-              <a:rect r="r" b="b" t="t" l="l"/>
-              <a:pathLst>
-                <a:path h="375335" w="2739118">
-                  <a:moveTo>
-                    <a:pt x="12655" y="0"/>
-                  </a:moveTo>
-                  <a:lnTo>
-                    <a:pt x="2726463" y="0"/>
-                  </a:lnTo>
-                  <a:cubicBezTo>
-                    <a:pt x="2733453" y="0"/>
-                    <a:pt x="2739118" y="5666"/>
-                    <a:pt x="2739118" y="12655"/>
-                  </a:cubicBezTo>
-                  <a:lnTo>
-                    <a:pt x="2739118" y="362680"/>
-                  </a:lnTo>
-                  <a:cubicBezTo>
-                    <a:pt x="2739118" y="366036"/>
-                    <a:pt x="2737785" y="369255"/>
-                    <a:pt x="2735412" y="371628"/>
-                  </a:cubicBezTo>
-                  <a:cubicBezTo>
-                    <a:pt x="2733039" y="374001"/>
-                    <a:pt x="2729820" y="375335"/>
-                    <a:pt x="2726463" y="375335"/>
-                  </a:cubicBezTo>
-                  <a:lnTo>
-                    <a:pt x="12655" y="375335"/>
-                  </a:lnTo>
-                  <a:cubicBezTo>
-                    <a:pt x="9299" y="375335"/>
-                    <a:pt x="6080" y="374001"/>
-                    <a:pt x="3707" y="371628"/>
-                  </a:cubicBezTo>
-                  <a:cubicBezTo>
-                    <a:pt x="1333" y="369255"/>
-                    <a:pt x="0" y="366036"/>
-                    <a:pt x="0" y="362680"/>
-                  </a:cubicBezTo>
-                  <a:lnTo>
-                    <a:pt x="0" y="12655"/>
-                  </a:lnTo>
-                  <a:cubicBezTo>
-                    <a:pt x="0" y="9299"/>
-                    <a:pt x="1333" y="6080"/>
-                    <a:pt x="3707" y="3707"/>
-                  </a:cubicBezTo>
-                  <a:cubicBezTo>
-                    <a:pt x="6080" y="1333"/>
-                    <a:pt x="9299" y="0"/>
-                    <a:pt x="12655" y="0"/>
-                  </a:cubicBezTo>
-                  <a:close/>
-                </a:path>
-              </a:pathLst>
-            </a:custGeom>
-            <a:solidFill>
-              <a:srgbClr val="233D89"/>
-            </a:solidFill>
-          </p:spPr>
-        </p:sp>
-        <p:sp>
-          <p:nvSpPr>
-            <p:cNvPr name="TextBox 8" id="8"/>
-            <p:cNvSpPr txBox="true"/>
-            <p:nvPr/>
-          </p:nvSpPr>
-          <p:spPr>
-            <a:xfrm>
-              <a:off x="0" y="-38100"/>
-              <a:ext cx="2739118" cy="413435"/>
+              <a:ext cx="4476016" cy="850900"/>
             </a:xfrm>
             <a:prstGeom prst="rect">
               <a:avLst/>
@@ -17707,7 +17394,7 @@
         </p:nvSpPr>
         <p:spPr>
           <a:xfrm flipH="false" flipV="false" rot="0">
-            <a:off x="266228" y="2227353"/>
+            <a:off x="266228" y="4109192"/>
             <a:ext cx="17755545" cy="5149108"/>
           </a:xfrm>
           <a:custGeom>
@@ -17753,10 +17440,10 @@
         </p:nvGrpSpPr>
         <p:grpSpPr>
           <a:xfrm rot="0">
-            <a:off x="621952" y="6126847"/>
-            <a:ext cx="5905615" cy="1425098"/>
+            <a:off x="646563" y="7982548"/>
+            <a:ext cx="16994873" cy="3086100"/>
             <a:chOff x="0" y="0"/>
-            <a:chExt cx="1555388" cy="375335"/>
+            <a:chExt cx="4476016" cy="812800"/>
           </a:xfrm>
         </p:grpSpPr>
         <p:sp>
@@ -17768,7 +17455,7 @@
           <p:spPr>
             <a:xfrm flipH="false" flipV="false" rot="0">
               <a:off x="0" y="0"/>
-              <a:ext cx="1555388" cy="375335"/>
+              <a:ext cx="4476016" cy="812800"/>
             </a:xfrm>
             <a:custGeom>
               <a:avLst/>
@@ -17777,51 +17464,61 @@
               <a:cxnLst/>
               <a:rect r="r" b="b" t="t" l="l"/>
               <a:pathLst>
-                <a:path h="375335" w="1555388">
+                <a:path h="812800" w="4476016">
                   <a:moveTo>
-                    <a:pt x="22286" y="0"/>
+                    <a:pt x="7744" y="0"/>
                   </a:moveTo>
                   <a:lnTo>
-                    <a:pt x="1533102" y="0"/>
-                  </a:lnTo>
-                  <a:cubicBezTo>
-                    <a:pt x="1539013" y="0"/>
-                    <a:pt x="1544682" y="2348"/>
-                    <a:pt x="1548861" y="6527"/>
-                  </a:cubicBezTo>
-                  <a:cubicBezTo>
-                    <a:pt x="1553040" y="10707"/>
-                    <a:pt x="1555388" y="16375"/>
-                    <a:pt x="1555388" y="22286"/>
-                  </a:cubicBezTo>
-                  <a:lnTo>
-                    <a:pt x="1555388" y="353049"/>
-                  </a:lnTo>
-                  <a:cubicBezTo>
-                    <a:pt x="1555388" y="365357"/>
-                    <a:pt x="1545411" y="375335"/>
-                    <a:pt x="1533102" y="375335"/>
-                  </a:cubicBezTo>
-                  <a:lnTo>
-                    <a:pt x="22286" y="375335"/>
-                  </a:lnTo>
-                  <a:cubicBezTo>
-                    <a:pt x="16375" y="375335"/>
-                    <a:pt x="10707" y="372987"/>
-                    <a:pt x="6527" y="368807"/>
-                  </a:cubicBezTo>
-                  <a:cubicBezTo>
-                    <a:pt x="2348" y="364628"/>
-                    <a:pt x="0" y="358959"/>
-                    <a:pt x="0" y="353049"/>
-                  </a:cubicBezTo>
-                  <a:lnTo>
-                    <a:pt x="0" y="22286"/>
-                  </a:lnTo>
-                  <a:cubicBezTo>
-                    <a:pt x="0" y="9978"/>
-                    <a:pt x="9978" y="0"/>
-                    <a:pt x="22286" y="0"/>
+                    <a:pt x="4468272" y="0"/>
+                  </a:lnTo>
+                  <a:cubicBezTo>
+                    <a:pt x="4470326" y="0"/>
+                    <a:pt x="4472295" y="816"/>
+                    <a:pt x="4473748" y="2268"/>
+                  </a:cubicBezTo>
+                  <a:cubicBezTo>
+                    <a:pt x="4475200" y="3721"/>
+                    <a:pt x="4476016" y="5690"/>
+                    <a:pt x="4476016" y="7744"/>
+                  </a:cubicBezTo>
+                  <a:lnTo>
+                    <a:pt x="4476016" y="805056"/>
+                  </a:lnTo>
+                  <a:cubicBezTo>
+                    <a:pt x="4476016" y="807110"/>
+                    <a:pt x="4475200" y="809079"/>
+                    <a:pt x="4473748" y="810532"/>
+                  </a:cubicBezTo>
+                  <a:cubicBezTo>
+                    <a:pt x="4472295" y="811984"/>
+                    <a:pt x="4470326" y="812800"/>
+                    <a:pt x="4468272" y="812800"/>
+                  </a:cubicBezTo>
+                  <a:lnTo>
+                    <a:pt x="7744" y="812800"/>
+                  </a:lnTo>
+                  <a:cubicBezTo>
+                    <a:pt x="5690" y="812800"/>
+                    <a:pt x="3721" y="811984"/>
+                    <a:pt x="2268" y="810532"/>
+                  </a:cubicBezTo>
+                  <a:cubicBezTo>
+                    <a:pt x="816" y="809079"/>
+                    <a:pt x="0" y="807110"/>
+                    <a:pt x="0" y="805056"/>
+                  </a:cubicBezTo>
+                  <a:lnTo>
+                    <a:pt x="0" y="7744"/>
+                  </a:lnTo>
+                  <a:cubicBezTo>
+                    <a:pt x="0" y="5690"/>
+                    <a:pt x="816" y="3721"/>
+                    <a:pt x="2268" y="2268"/>
+                  </a:cubicBezTo>
+                  <a:cubicBezTo>
+                    <a:pt x="3721" y="816"/>
+                    <a:pt x="5690" y="0"/>
+                    <a:pt x="7744" y="0"/>
                   </a:cubicBezTo>
                   <a:close/>
                 </a:path>
@@ -17841,7 +17538,7 @@
           <p:spPr>
             <a:xfrm>
               <a:off x="0" y="-38100"/>
-              <a:ext cx="1555388" cy="413435"/>
+              <a:ext cx="4476016" cy="850900"/>
             </a:xfrm>
             <a:prstGeom prst="rect">
               <a:avLst/>
@@ -17868,10 +17565,10 @@
         </p:nvGrpSpPr>
         <p:grpSpPr>
           <a:xfrm rot="0">
-            <a:off x="12261783" y="5246356"/>
-            <a:ext cx="4579606" cy="1425098"/>
+            <a:off x="6242582" y="7200900"/>
+            <a:ext cx="11607087" cy="3086100"/>
             <a:chOff x="0" y="0"/>
-            <a:chExt cx="1206151" cy="375335"/>
+            <a:chExt cx="3057010" cy="812800"/>
           </a:xfrm>
         </p:grpSpPr>
         <p:sp>
@@ -17883,7 +17580,7 @@
           <p:spPr>
             <a:xfrm flipH="false" flipV="false" rot="0">
               <a:off x="0" y="0"/>
-              <a:ext cx="1206151" cy="375335"/>
+              <a:ext cx="3057010" cy="812800"/>
             </a:xfrm>
             <a:custGeom>
               <a:avLst/>
@@ -17892,46 +17589,46 @@
               <a:cxnLst/>
               <a:rect r="r" b="b" t="t" l="l"/>
               <a:pathLst>
-                <a:path h="375335" w="1206151">
+                <a:path h="812800" w="3057010">
                   <a:moveTo>
-                    <a:pt x="28739" y="0"/>
+                    <a:pt x="11339" y="0"/>
                   </a:moveTo>
                   <a:lnTo>
-                    <a:pt x="1177412" y="0"/>
-                  </a:lnTo>
-                  <a:cubicBezTo>
-                    <a:pt x="1193284" y="0"/>
-                    <a:pt x="1206151" y="12867"/>
-                    <a:pt x="1206151" y="28739"/>
-                  </a:cubicBezTo>
-                  <a:lnTo>
-                    <a:pt x="1206151" y="346596"/>
-                  </a:lnTo>
-                  <a:cubicBezTo>
-                    <a:pt x="1206151" y="362468"/>
-                    <a:pt x="1193284" y="375335"/>
-                    <a:pt x="1177412" y="375335"/>
-                  </a:cubicBezTo>
-                  <a:lnTo>
-                    <a:pt x="28739" y="375335"/>
-                  </a:lnTo>
-                  <a:cubicBezTo>
-                    <a:pt x="21117" y="375335"/>
-                    <a:pt x="13807" y="372307"/>
-                    <a:pt x="8417" y="366917"/>
-                  </a:cubicBezTo>
-                  <a:cubicBezTo>
-                    <a:pt x="3028" y="361528"/>
-                    <a:pt x="0" y="354218"/>
-                    <a:pt x="0" y="346596"/>
-                  </a:cubicBezTo>
-                  <a:lnTo>
-                    <a:pt x="0" y="28739"/>
-                  </a:lnTo>
-                  <a:cubicBezTo>
-                    <a:pt x="0" y="12867"/>
-                    <a:pt x="12867" y="0"/>
-                    <a:pt x="28739" y="0"/>
+                    <a:pt x="3045671" y="0"/>
+                  </a:lnTo>
+                  <a:cubicBezTo>
+                    <a:pt x="3048679" y="0"/>
+                    <a:pt x="3051563" y="1195"/>
+                    <a:pt x="3053689" y="3321"/>
+                  </a:cubicBezTo>
+                  <a:cubicBezTo>
+                    <a:pt x="3055816" y="5448"/>
+                    <a:pt x="3057010" y="8332"/>
+                    <a:pt x="3057010" y="11339"/>
+                  </a:cubicBezTo>
+                  <a:lnTo>
+                    <a:pt x="3057010" y="801461"/>
+                  </a:lnTo>
+                  <a:cubicBezTo>
+                    <a:pt x="3057010" y="807723"/>
+                    <a:pt x="3051934" y="812800"/>
+                    <a:pt x="3045671" y="812800"/>
+                  </a:cubicBezTo>
+                  <a:lnTo>
+                    <a:pt x="11339" y="812800"/>
+                  </a:lnTo>
+                  <a:cubicBezTo>
+                    <a:pt x="5077" y="812800"/>
+                    <a:pt x="0" y="807723"/>
+                    <a:pt x="0" y="801461"/>
+                  </a:cubicBezTo>
+                  <a:lnTo>
+                    <a:pt x="0" y="11339"/>
+                  </a:lnTo>
+                  <a:cubicBezTo>
+                    <a:pt x="0" y="5077"/>
+                    <a:pt x="5077" y="0"/>
+                    <a:pt x="11339" y="0"/>
                   </a:cubicBezTo>
                   <a:close/>
                 </a:path>
@@ -17951,7 +17648,7 @@
           <p:spPr>
             <a:xfrm>
               <a:off x="0" y="-38100"/>
-              <a:ext cx="1206151" cy="413435"/>
+              <a:ext cx="3057010" cy="850900"/>
             </a:xfrm>
             <a:prstGeom prst="rect">
               <a:avLst/>
@@ -18327,7 +18024,7 @@
         </p:nvSpPr>
         <p:spPr>
           <a:xfrm flipH="false" flipV="false" rot="0">
-            <a:off x="266228" y="2227353"/>
+            <a:off x="266228" y="4109192"/>
             <a:ext cx="17755545" cy="5149108"/>
           </a:xfrm>
           <a:custGeom>
@@ -18373,10 +18070,10 @@
         </p:nvGrpSpPr>
         <p:grpSpPr>
           <a:xfrm rot="0">
-            <a:off x="621952" y="6126847"/>
-            <a:ext cx="5905615" cy="1425098"/>
+            <a:off x="646563" y="7982548"/>
+            <a:ext cx="16994873" cy="3086100"/>
             <a:chOff x="0" y="0"/>
-            <a:chExt cx="1555388" cy="375335"/>
+            <a:chExt cx="4476016" cy="812800"/>
           </a:xfrm>
         </p:grpSpPr>
         <p:sp>
@@ -18388,7 +18085,7 @@
           <p:spPr>
             <a:xfrm flipH="false" flipV="false" rot="0">
               <a:off x="0" y="0"/>
-              <a:ext cx="1555388" cy="375335"/>
+              <a:ext cx="4476016" cy="812800"/>
             </a:xfrm>
             <a:custGeom>
               <a:avLst/>
@@ -18397,51 +18094,61 @@
               <a:cxnLst/>
               <a:rect r="r" b="b" t="t" l="l"/>
               <a:pathLst>
-                <a:path h="375335" w="1555388">
+                <a:path h="812800" w="4476016">
                   <a:moveTo>
-                    <a:pt x="22286" y="0"/>
+                    <a:pt x="7744" y="0"/>
                   </a:moveTo>
                   <a:lnTo>
-                    <a:pt x="1533102" y="0"/>
-                  </a:lnTo>
-                  <a:cubicBezTo>
-                    <a:pt x="1539013" y="0"/>
-                    <a:pt x="1544682" y="2348"/>
-                    <a:pt x="1548861" y="6527"/>
-                  </a:cubicBezTo>
-                  <a:cubicBezTo>
-                    <a:pt x="1553040" y="10707"/>
-                    <a:pt x="1555388" y="16375"/>
-                    <a:pt x="1555388" y="22286"/>
-                  </a:cubicBezTo>
-                  <a:lnTo>
-                    <a:pt x="1555388" y="353049"/>
-                  </a:lnTo>
-                  <a:cubicBezTo>
-                    <a:pt x="1555388" y="365357"/>
-                    <a:pt x="1545411" y="375335"/>
-                    <a:pt x="1533102" y="375335"/>
-                  </a:cubicBezTo>
-                  <a:lnTo>
-                    <a:pt x="22286" y="375335"/>
-                  </a:lnTo>
-                  <a:cubicBezTo>
-                    <a:pt x="16375" y="375335"/>
-                    <a:pt x="10707" y="372987"/>
-                    <a:pt x="6527" y="368807"/>
-                  </a:cubicBezTo>
-                  <a:cubicBezTo>
-                    <a:pt x="2348" y="364628"/>
-                    <a:pt x="0" y="358959"/>
-                    <a:pt x="0" y="353049"/>
-                  </a:cubicBezTo>
-                  <a:lnTo>
-                    <a:pt x="0" y="22286"/>
-                  </a:lnTo>
-                  <a:cubicBezTo>
-                    <a:pt x="0" y="9978"/>
-                    <a:pt x="9978" y="0"/>
-                    <a:pt x="22286" y="0"/>
+                    <a:pt x="4468272" y="0"/>
+                  </a:lnTo>
+                  <a:cubicBezTo>
+                    <a:pt x="4470326" y="0"/>
+                    <a:pt x="4472295" y="816"/>
+                    <a:pt x="4473748" y="2268"/>
+                  </a:cubicBezTo>
+                  <a:cubicBezTo>
+                    <a:pt x="4475200" y="3721"/>
+                    <a:pt x="4476016" y="5690"/>
+                    <a:pt x="4476016" y="7744"/>
+                  </a:cubicBezTo>
+                  <a:lnTo>
+                    <a:pt x="4476016" y="805056"/>
+                  </a:lnTo>
+                  <a:cubicBezTo>
+                    <a:pt x="4476016" y="807110"/>
+                    <a:pt x="4475200" y="809079"/>
+                    <a:pt x="4473748" y="810532"/>
+                  </a:cubicBezTo>
+                  <a:cubicBezTo>
+                    <a:pt x="4472295" y="811984"/>
+                    <a:pt x="4470326" y="812800"/>
+                    <a:pt x="4468272" y="812800"/>
+                  </a:cubicBezTo>
+                  <a:lnTo>
+                    <a:pt x="7744" y="812800"/>
+                  </a:lnTo>
+                  <a:cubicBezTo>
+                    <a:pt x="5690" y="812800"/>
+                    <a:pt x="3721" y="811984"/>
+                    <a:pt x="2268" y="810532"/>
+                  </a:cubicBezTo>
+                  <a:cubicBezTo>
+                    <a:pt x="816" y="809079"/>
+                    <a:pt x="0" y="807110"/>
+                    <a:pt x="0" y="805056"/>
+                  </a:cubicBezTo>
+                  <a:lnTo>
+                    <a:pt x="0" y="7744"/>
+                  </a:lnTo>
+                  <a:cubicBezTo>
+                    <a:pt x="0" y="5690"/>
+                    <a:pt x="816" y="3721"/>
+                    <a:pt x="2268" y="2268"/>
+                  </a:cubicBezTo>
+                  <a:cubicBezTo>
+                    <a:pt x="3721" y="816"/>
+                    <a:pt x="5690" y="0"/>
+                    <a:pt x="7744" y="0"/>
                   </a:cubicBezTo>
                   <a:close/>
                 </a:path>
@@ -18461,7 +18168,132 @@
           <p:spPr>
             <a:xfrm>
               <a:off x="0" y="-38100"/>
-              <a:ext cx="1555388" cy="413435"/>
+              <a:ext cx="4476016" cy="850900"/>
+            </a:xfrm>
+            <a:prstGeom prst="rect">
+              <a:avLst/>
+            </a:prstGeom>
+          </p:spPr>
+          <p:txBody>
+            <a:bodyPr anchor="ctr" rtlCol="false" tIns="50800" lIns="50800" bIns="50800" rIns="50800"/>
+            <a:lstStyle/>
+            <a:p>
+              <a:pPr algn="ctr">
+                <a:lnSpc>
+                  <a:spcPts val="3449"/>
+                </a:lnSpc>
+              </a:pPr>
+            </a:p>
+          </p:txBody>
+        </p:sp>
+      </p:grpSp>
+      <p:grpSp>
+        <p:nvGrpSpPr>
+          <p:cNvPr name="Group 6" id="6"/>
+          <p:cNvGrpSpPr/>
+          <p:nvPr/>
+        </p:nvGrpSpPr>
+        <p:grpSpPr>
+          <a:xfrm rot="0">
+            <a:off x="12314311" y="7200900"/>
+            <a:ext cx="5535358" cy="3086100"/>
+            <a:chOff x="0" y="0"/>
+            <a:chExt cx="1457872" cy="812800"/>
+          </a:xfrm>
+        </p:grpSpPr>
+        <p:sp>
+          <p:nvSpPr>
+            <p:cNvPr name="Freeform 7" id="7"/>
+            <p:cNvSpPr/>
+            <p:nvPr/>
+          </p:nvSpPr>
+          <p:spPr>
+            <a:xfrm flipH="false" flipV="false" rot="0">
+              <a:off x="0" y="0"/>
+              <a:ext cx="1457872" cy="812800"/>
+            </a:xfrm>
+            <a:custGeom>
+              <a:avLst/>
+              <a:gdLst/>
+              <a:ahLst/>
+              <a:cxnLst/>
+              <a:rect r="r" b="b" t="t" l="l"/>
+              <a:pathLst>
+                <a:path h="812800" w="1457872">
+                  <a:moveTo>
+                    <a:pt x="23777" y="0"/>
+                  </a:moveTo>
+                  <a:lnTo>
+                    <a:pt x="1434095" y="0"/>
+                  </a:lnTo>
+                  <a:cubicBezTo>
+                    <a:pt x="1440401" y="0"/>
+                    <a:pt x="1446449" y="2505"/>
+                    <a:pt x="1450908" y="6964"/>
+                  </a:cubicBezTo>
+                  <a:cubicBezTo>
+                    <a:pt x="1455367" y="11423"/>
+                    <a:pt x="1457872" y="17471"/>
+                    <a:pt x="1457872" y="23777"/>
+                  </a:cubicBezTo>
+                  <a:lnTo>
+                    <a:pt x="1457872" y="789023"/>
+                  </a:lnTo>
+                  <a:cubicBezTo>
+                    <a:pt x="1457872" y="795329"/>
+                    <a:pt x="1455367" y="801377"/>
+                    <a:pt x="1450908" y="805836"/>
+                  </a:cubicBezTo>
+                  <a:cubicBezTo>
+                    <a:pt x="1446449" y="810295"/>
+                    <a:pt x="1440401" y="812800"/>
+                    <a:pt x="1434095" y="812800"/>
+                  </a:cubicBezTo>
+                  <a:lnTo>
+                    <a:pt x="23777" y="812800"/>
+                  </a:lnTo>
+                  <a:cubicBezTo>
+                    <a:pt x="17471" y="812800"/>
+                    <a:pt x="11423" y="810295"/>
+                    <a:pt x="6964" y="805836"/>
+                  </a:cubicBezTo>
+                  <a:cubicBezTo>
+                    <a:pt x="2505" y="801377"/>
+                    <a:pt x="0" y="795329"/>
+                    <a:pt x="0" y="789023"/>
+                  </a:cubicBezTo>
+                  <a:lnTo>
+                    <a:pt x="0" y="23777"/>
+                  </a:lnTo>
+                  <a:cubicBezTo>
+                    <a:pt x="0" y="17471"/>
+                    <a:pt x="2505" y="11423"/>
+                    <a:pt x="6964" y="6964"/>
+                  </a:cubicBezTo>
+                  <a:cubicBezTo>
+                    <a:pt x="11423" y="2505"/>
+                    <a:pt x="17471" y="0"/>
+                    <a:pt x="23777" y="0"/>
+                  </a:cubicBezTo>
+                  <a:close/>
+                </a:path>
+              </a:pathLst>
+            </a:custGeom>
+            <a:solidFill>
+              <a:srgbClr val="233D89"/>
+            </a:solidFill>
+          </p:spPr>
+        </p:sp>
+        <p:sp>
+          <p:nvSpPr>
+            <p:cNvPr name="TextBox 8" id="8"/>
+            <p:cNvSpPr txBox="true"/>
+            <p:nvPr/>
+          </p:nvSpPr>
+          <p:spPr>
+            <a:xfrm>
+              <a:off x="0" y="-38100"/>
+              <a:ext cx="1457872" cy="850900"/>
             </a:xfrm>
             <a:prstGeom prst="rect">
               <a:avLst/>
@@ -18520,7 +18352,210 @@
         </p:nvSpPr>
         <p:spPr>
           <a:xfrm flipH="false" flipV="false" rot="0">
-            <a:off x="266228" y="2227353"/>
+            <a:off x="266228" y="4109192"/>
+            <a:ext cx="17755545" cy="5149108"/>
+          </a:xfrm>
+          <a:custGeom>
+            <a:avLst/>
+            <a:gdLst/>
+            <a:ahLst/>
+            <a:cxnLst/>
+            <a:rect r="r" b="b" t="t" l="l"/>
+            <a:pathLst>
+              <a:path h="5149108" w="17755545">
+                <a:moveTo>
+                  <a:pt x="0" y="0"/>
+                </a:moveTo>
+                <a:lnTo>
+                  <a:pt x="17755544" y="0"/>
+                </a:lnTo>
+                <a:lnTo>
+                  <a:pt x="17755544" y="5149108"/>
+                </a:lnTo>
+                <a:lnTo>
+                  <a:pt x="0" y="5149108"/>
+                </a:lnTo>
+                <a:lnTo>
+                  <a:pt x="0" y="0"/>
+                </a:lnTo>
+                <a:close/>
+              </a:path>
+            </a:pathLst>
+          </a:custGeom>
+          <a:blipFill>
+            <a:blip r:embed="rId2"/>
+            <a:stretch>
+              <a:fillRect l="0" t="0" r="0" b="0"/>
+            </a:stretch>
+          </a:blipFill>
+        </p:spPr>
+      </p:sp>
+      <p:grpSp>
+        <p:nvGrpSpPr>
+          <p:cNvPr name="Group 3" id="3"/>
+          <p:cNvGrpSpPr/>
+          <p:nvPr/>
+        </p:nvGrpSpPr>
+        <p:grpSpPr>
+          <a:xfrm rot="0">
+            <a:off x="646563" y="7982548"/>
+            <a:ext cx="16994873" cy="3086100"/>
+            <a:chOff x="0" y="0"/>
+            <a:chExt cx="4476016" cy="812800"/>
+          </a:xfrm>
+        </p:grpSpPr>
+        <p:sp>
+          <p:nvSpPr>
+            <p:cNvPr name="Freeform 4" id="4"/>
+            <p:cNvSpPr/>
+            <p:nvPr/>
+          </p:nvSpPr>
+          <p:spPr>
+            <a:xfrm flipH="false" flipV="false" rot="0">
+              <a:off x="0" y="0"/>
+              <a:ext cx="4476016" cy="812800"/>
+            </a:xfrm>
+            <a:custGeom>
+              <a:avLst/>
+              <a:gdLst/>
+              <a:ahLst/>
+              <a:cxnLst/>
+              <a:rect r="r" b="b" t="t" l="l"/>
+              <a:pathLst>
+                <a:path h="812800" w="4476016">
+                  <a:moveTo>
+                    <a:pt x="7744" y="0"/>
+                  </a:moveTo>
+                  <a:lnTo>
+                    <a:pt x="4468272" y="0"/>
+                  </a:lnTo>
+                  <a:cubicBezTo>
+                    <a:pt x="4470326" y="0"/>
+                    <a:pt x="4472295" y="816"/>
+                    <a:pt x="4473748" y="2268"/>
+                  </a:cubicBezTo>
+                  <a:cubicBezTo>
+                    <a:pt x="4475200" y="3721"/>
+                    <a:pt x="4476016" y="5690"/>
+                    <a:pt x="4476016" y="7744"/>
+                  </a:cubicBezTo>
+                  <a:lnTo>
+                    <a:pt x="4476016" y="805056"/>
+                  </a:lnTo>
+                  <a:cubicBezTo>
+                    <a:pt x="4476016" y="807110"/>
+                    <a:pt x="4475200" y="809079"/>
+                    <a:pt x="4473748" y="810532"/>
+                  </a:cubicBezTo>
+                  <a:cubicBezTo>
+                    <a:pt x="4472295" y="811984"/>
+                    <a:pt x="4470326" y="812800"/>
+                    <a:pt x="4468272" y="812800"/>
+                  </a:cubicBezTo>
+                  <a:lnTo>
+                    <a:pt x="7744" y="812800"/>
+                  </a:lnTo>
+                  <a:cubicBezTo>
+                    <a:pt x="5690" y="812800"/>
+                    <a:pt x="3721" y="811984"/>
+                    <a:pt x="2268" y="810532"/>
+                  </a:cubicBezTo>
+                  <a:cubicBezTo>
+                    <a:pt x="816" y="809079"/>
+                    <a:pt x="0" y="807110"/>
+                    <a:pt x="0" y="805056"/>
+                  </a:cubicBezTo>
+                  <a:lnTo>
+                    <a:pt x="0" y="7744"/>
+                  </a:lnTo>
+                  <a:cubicBezTo>
+                    <a:pt x="0" y="5690"/>
+                    <a:pt x="816" y="3721"/>
+                    <a:pt x="2268" y="2268"/>
+                  </a:cubicBezTo>
+                  <a:cubicBezTo>
+                    <a:pt x="3721" y="816"/>
+                    <a:pt x="5690" y="0"/>
+                    <a:pt x="7744" y="0"/>
+                  </a:cubicBezTo>
+                  <a:close/>
+                </a:path>
+              </a:pathLst>
+            </a:custGeom>
+            <a:solidFill>
+              <a:srgbClr val="233D89"/>
+            </a:solidFill>
+          </p:spPr>
+        </p:sp>
+        <p:sp>
+          <p:nvSpPr>
+            <p:cNvPr name="TextBox 5" id="5"/>
+            <p:cNvSpPr txBox="true"/>
+            <p:nvPr/>
+          </p:nvSpPr>
+          <p:spPr>
+            <a:xfrm>
+              <a:off x="0" y="-38100"/>
+              <a:ext cx="4476016" cy="850900"/>
+            </a:xfrm>
+            <a:prstGeom prst="rect">
+              <a:avLst/>
+            </a:prstGeom>
+          </p:spPr>
+          <p:txBody>
+            <a:bodyPr anchor="ctr" rtlCol="false" tIns="50800" lIns="50800" bIns="50800" rIns="50800"/>
+            <a:lstStyle/>
+            <a:p>
+              <a:pPr algn="ctr">
+                <a:lnSpc>
+                  <a:spcPts val="3449"/>
+                </a:lnSpc>
+              </a:pPr>
+            </a:p>
+          </p:txBody>
+        </p:sp>
+      </p:grpSp>
+    </p:spTree>
+  </p:cSld>
+  <p:clrMapOvr>
+    <a:masterClrMapping/>
+  </p:clrMapOvr>
+</p:sld>
+</file>
+
+<file path=ppt/slides/slide32.xml><?xml version="1.0" encoding="utf-8"?>
+<p:sld xmlns:p="http://schemas.openxmlformats.org/presentationml/2006/main" xmlns:a="http://schemas.openxmlformats.org/drawingml/2006/main" xmlns:r="http://schemas.openxmlformats.org/officeDocument/2006/relationships">
+  <p:cSld>
+    <p:bg>
+      <p:bgPr>
+        <a:solidFill>
+          <a:srgbClr val="233D89"/>
+        </a:solidFill>
+      </p:bgPr>
+    </p:bg>
+    <p:spTree>
+      <p:nvGrpSpPr>
+        <p:cNvPr id="1" name=""/>
+        <p:cNvGrpSpPr/>
+        <p:nvPr/>
+      </p:nvGrpSpPr>
+      <p:grpSpPr>
+        <a:xfrm>
+          <a:off x="0" y="0"/>
+          <a:ext cx="0" cy="0"/>
+          <a:chOff x="0" y="0"/>
+          <a:chExt cx="0" cy="0"/>
+        </a:xfrm>
+      </p:grpSpPr>
+      <p:sp>
+        <p:nvSpPr>
+          <p:cNvPr name="Freeform 2" id="2"/>
+          <p:cNvSpPr/>
+          <p:nvPr/>
+        </p:nvSpPr>
+        <p:spPr>
+          <a:xfrm flipH="false" flipV="false" rot="0">
+            <a:off x="266228" y="4109192"/>
             <a:ext cx="17755545" cy="5149108"/>
           </a:xfrm>
           <a:custGeom>
@@ -18566,7 +18601,7 @@
 </p:sld>
 </file>
 
-<file path=ppt/slides/slide32.xml><?xml version="1.0" encoding="utf-8"?>
+<file path=ppt/slides/slide33.xml><?xml version="1.0" encoding="utf-8"?>
 <p:sld xmlns:p="http://schemas.openxmlformats.org/presentationml/2006/main" xmlns:a="http://schemas.openxmlformats.org/drawingml/2006/main">
   <p:cSld>
     <p:bg>
@@ -18639,7 +18674,7 @@
 </p:sld>
 </file>
 
-<file path=ppt/slides/slide33.xml><?xml version="1.0" encoding="utf-8"?>
+<file path=ppt/slides/slide34.xml><?xml version="1.0" encoding="utf-8"?>
 <p:sld xmlns:p="http://schemas.openxmlformats.org/presentationml/2006/main" xmlns:a="http://schemas.openxmlformats.org/drawingml/2006/main" xmlns:r="http://schemas.openxmlformats.org/officeDocument/2006/relationships">
   <p:cSld>
     <p:bg>
@@ -18717,7 +18752,7 @@
 </p:sld>
 </file>
 
-<file path=ppt/slides/slide34.xml><?xml version="1.0" encoding="utf-8"?>
+<file path=ppt/slides/slide35.xml><?xml version="1.0" encoding="utf-8"?>
 <p:sld xmlns:p="http://schemas.openxmlformats.org/presentationml/2006/main" xmlns:a="http://schemas.openxmlformats.org/drawingml/2006/main" xmlns:r="http://schemas.openxmlformats.org/officeDocument/2006/relationships">
   <p:cSld>
     <p:bg>
@@ -18795,7 +18830,7 @@
 </p:sld>
 </file>
 
-<file path=ppt/slides/slide35.xml><?xml version="1.0" encoding="utf-8"?>
+<file path=ppt/slides/slide36.xml><?xml version="1.0" encoding="utf-8"?>
 <p:sld xmlns:p="http://schemas.openxmlformats.org/presentationml/2006/main" xmlns:a="http://schemas.openxmlformats.org/drawingml/2006/main" xmlns:r="http://schemas.openxmlformats.org/officeDocument/2006/relationships">
   <p:cSld>
     <p:bg>
@@ -18873,7 +18908,7 @@
 </p:sld>
 </file>
 
-<file path=ppt/slides/slide36.xml><?xml version="1.0" encoding="utf-8"?>
+<file path=ppt/slides/slide37.xml><?xml version="1.0" encoding="utf-8"?>
 <p:sld xmlns:p="http://schemas.openxmlformats.org/presentationml/2006/main" xmlns:a="http://schemas.openxmlformats.org/drawingml/2006/main" xmlns:r="http://schemas.openxmlformats.org/officeDocument/2006/relationships">
   <p:cSld>
     <p:bg>
@@ -18951,7 +18986,7 @@
 </p:sld>
 </file>
 
-<file path=ppt/slides/slide37.xml><?xml version="1.0" encoding="utf-8"?>
+<file path=ppt/slides/slide38.xml><?xml version="1.0" encoding="utf-8"?>
 <p:sld xmlns:p="http://schemas.openxmlformats.org/presentationml/2006/main" xmlns:a="http://schemas.openxmlformats.org/drawingml/2006/main" xmlns:r="http://schemas.openxmlformats.org/officeDocument/2006/relationships">
   <p:cSld>
     <p:bg>
@@ -19029,7 +19064,7 @@
 </p:sld>
 </file>
 
-<file path=ppt/slides/slide38.xml><?xml version="1.0" encoding="utf-8"?>
+<file path=ppt/slides/slide39.xml><?xml version="1.0" encoding="utf-8"?>
 <p:sld xmlns:p="http://schemas.openxmlformats.org/presentationml/2006/main" xmlns:a="http://schemas.openxmlformats.org/drawingml/2006/main" xmlns:r="http://schemas.openxmlformats.org/officeDocument/2006/relationships">
   <p:cSld>
     <p:bg>
@@ -19098,79 +19133,6 @@
             </a:stretch>
           </a:blipFill>
         </p:spPr>
-      </p:sp>
-    </p:spTree>
-  </p:cSld>
-  <p:clrMapOvr>
-    <a:masterClrMapping/>
-  </p:clrMapOvr>
-</p:sld>
-</file>
-
-<file path=ppt/slides/slide39.xml><?xml version="1.0" encoding="utf-8"?>
-<p:sld xmlns:p="http://schemas.openxmlformats.org/presentationml/2006/main" xmlns:a="http://schemas.openxmlformats.org/drawingml/2006/main">
-  <p:cSld>
-    <p:bg>
-      <p:bgPr>
-        <a:solidFill>
-          <a:srgbClr val="1E3A8A"/>
-        </a:solidFill>
-      </p:bgPr>
-    </p:bg>
-    <p:spTree>
-      <p:nvGrpSpPr>
-        <p:cNvPr id="1" name=""/>
-        <p:cNvGrpSpPr/>
-        <p:nvPr/>
-      </p:nvGrpSpPr>
-      <p:grpSpPr>
-        <a:xfrm>
-          <a:off x="0" y="0"/>
-          <a:ext cx="0" cy="0"/>
-          <a:chOff x="0" y="0"/>
-          <a:chExt cx="0" cy="0"/>
-        </a:xfrm>
-      </p:grpSpPr>
-      <p:sp>
-        <p:nvSpPr>
-          <p:cNvPr name="TextBox 2" id="2"/>
-          <p:cNvSpPr txBox="true"/>
-          <p:nvPr/>
-        </p:nvSpPr>
-        <p:spPr>
-          <a:xfrm rot="0">
-            <a:off x="2335702" y="3518218"/>
-            <a:ext cx="13616597" cy="3145790"/>
-          </a:xfrm>
-          <a:prstGeom prst="rect">
-            <a:avLst/>
-          </a:prstGeom>
-        </p:spPr>
-        <p:txBody>
-          <a:bodyPr anchor="t" rtlCol="false" tIns="0" lIns="0" bIns="0" rIns="0">
-            <a:spAutoFit/>
-          </a:bodyPr>
-          <a:lstStyle/>
-          <a:p>
-            <a:pPr algn="l">
-              <a:lnSpc>
-                <a:spcPts val="25180"/>
-              </a:lnSpc>
-            </a:pPr>
-            <a:r>
-              <a:rPr lang="en-US" b="true" sz="20000">
-                <a:solidFill>
-                  <a:srgbClr val="FFFFFF"/>
-                </a:solidFill>
-                <a:latin typeface="Montserrat Bold"/>
-                <a:ea typeface="Montserrat Bold"/>
-                <a:cs typeface="Montserrat Bold"/>
-                <a:sym typeface="Montserrat Bold"/>
-              </a:rPr>
-              <a:t>Obrigado!</a:t>
-            </a:r>
-          </a:p>
-        </p:txBody>
       </p:sp>
     </p:spTree>
   </p:cSld>
@@ -19416,6 +19378,79 @@
                 <a:sym typeface="Montserrat"/>
               </a:rPr>
               <a:t>Os designer e programadores responsáveis pela contrução do sistema posuem outras preocupações, como verificar se determinado algoritimo atende aos resuisitos do sistema</a:t>
+            </a:r>
+          </a:p>
+        </p:txBody>
+      </p:sp>
+    </p:spTree>
+  </p:cSld>
+  <p:clrMapOvr>
+    <a:masterClrMapping/>
+  </p:clrMapOvr>
+</p:sld>
+</file>
+
+<file path=ppt/slides/slide40.xml><?xml version="1.0" encoding="utf-8"?>
+<p:sld xmlns:p="http://schemas.openxmlformats.org/presentationml/2006/main" xmlns:a="http://schemas.openxmlformats.org/drawingml/2006/main">
+  <p:cSld>
+    <p:bg>
+      <p:bgPr>
+        <a:solidFill>
+          <a:srgbClr val="1E3A8A"/>
+        </a:solidFill>
+      </p:bgPr>
+    </p:bg>
+    <p:spTree>
+      <p:nvGrpSpPr>
+        <p:cNvPr id="1" name=""/>
+        <p:cNvGrpSpPr/>
+        <p:nvPr/>
+      </p:nvGrpSpPr>
+      <p:grpSpPr>
+        <a:xfrm>
+          <a:off x="0" y="0"/>
+          <a:ext cx="0" cy="0"/>
+          <a:chOff x="0" y="0"/>
+          <a:chExt cx="0" cy="0"/>
+        </a:xfrm>
+      </p:grpSpPr>
+      <p:sp>
+        <p:nvSpPr>
+          <p:cNvPr name="TextBox 2" id="2"/>
+          <p:cNvSpPr txBox="true"/>
+          <p:nvPr/>
+        </p:nvSpPr>
+        <p:spPr>
+          <a:xfrm rot="0">
+            <a:off x="2335702" y="3518218"/>
+            <a:ext cx="13616597" cy="3145790"/>
+          </a:xfrm>
+          <a:prstGeom prst="rect">
+            <a:avLst/>
+          </a:prstGeom>
+        </p:spPr>
+        <p:txBody>
+          <a:bodyPr anchor="t" rtlCol="false" tIns="0" lIns="0" bIns="0" rIns="0">
+            <a:spAutoFit/>
+          </a:bodyPr>
+          <a:lstStyle/>
+          <a:p>
+            <a:pPr algn="l">
+              <a:lnSpc>
+                <a:spcPts val="25180"/>
+              </a:lnSpc>
+            </a:pPr>
+            <a:r>
+              <a:rPr lang="en-US" b="true" sz="20000">
+                <a:solidFill>
+                  <a:srgbClr val="FFFFFF"/>
+                </a:solidFill>
+                <a:latin typeface="Montserrat Bold"/>
+                <a:ea typeface="Montserrat Bold"/>
+                <a:cs typeface="Montserrat Bold"/>
+                <a:sym typeface="Montserrat Bold"/>
+              </a:rPr>
+              <a:t>Obrigado!</a:t>
             </a:r>
           </a:p>
         </p:txBody>

</xml_diff>